<commit_message>
Release 0.4.0, and read the version from the assembly
Bumps both projects to 0.4.0 for the work added since 0.3.0: query sync
against a central server, client-side AES+HMAC encryption of the query
library, and the query library manager.

The version was written out by hand in three places and had already
drifted — the About box still said 0.2.0 while the projects said 0.3.0.
Both runtime strings now read AssemblyInformationalVersion from the
running assembly and trim the git suffix the SDK appends, so there is a
single source of truth: <Version> in the csproj.

Verified rather than assumed: the published executable is stamped
0.4.0+<commit>, and the running server reports "version":"0.4.0" from
/api/v1/health.

Docs and deck updated to match. 146 checks passing.

Co-Authored-By: Claude Opus 4.8 <noreply@anthropic.com>
</commit_message>
<xml_diff>
--- a/docs/Qplus Feature Overview.pptx
+++ b/docs/Qplus Feature Overview.pptx
@@ -2384,7 +2384,7 @@
                 <a:ea typeface="Calibri" pitchFamily="34" charset="-122"/>
                 <a:cs typeface="Calibri" pitchFamily="34" charset="-120"/>
               </a:rPr>
-              <a:t>Version 0.3.0  ·  Feature Overview</a:t>
+              <a:t>Version 0.4.0  ·  Feature Overview</a:t>
             </a:r>
             <a:endParaRPr lang="en-US" sz="1200" dirty="0"/>
           </a:p>
@@ -6456,7 +6456,7 @@
                 <a:ea typeface="Calibri" pitchFamily="34" charset="-122"/>
                 <a:cs typeface="Calibri" pitchFamily="34" charset="-120"/>
               </a:rPr>
-              <a:t>Version 0.3.0</a:t>
+              <a:t>Version 0.4.0</a:t>
             </a:r>
             <a:endParaRPr lang="en-US" sz="1200" dirty="0"/>
           </a:p>

</xml_diff>

<commit_message>
Add the feature matrix to the slide deck
Two slides before the close, taking the deck from 16 to 18.

"How Qplus compares" condenses the document to eleven headline rows.
The last two are Qplus losing — no execution plans, no DBA or BI tooling
— and the speaker notes say to be straight about that rather than skate
past it. A caption points at the full document.

"Use the right tool for the job" gives each tool a card saying when to
reach for it, under a strip stating plainly that Qplus sits alongside
SSMS and SQL Developer rather than replacing them.

Closing slide now lists the feature matrix with the other documents.

Rendered and checked; the cards were two-thirds empty on the first pass,
so each gained a lead line and the geometry was tightened.

Co-Authored-By: Claude Opus 4.8 <noreply@anthropic.com>
</commit_message>
<xml_diff>
--- a/docs/Qplus Feature Overview.pptx
+++ b/docs/Qplus Feature Overview.pptx
@@ -21,9 +21,11 @@
     <p:sldId id="269" r:id="rId15"/>
     <p:sldId id="270" r:id="rId16"/>
     <p:sldId id="271" r:id="rId17"/>
+    <p:sldId id="272" r:id="rId18"/>
+    <p:sldId id="273" r:id="rId19"/>
   </p:sldIdLst>
   <p:notesMasterIdLst>
-    <p:notesMasterId r:id="rId18"/>
+    <p:notesMasterId r:id="rId20"/>
   </p:notesMasterIdLst>
   <p:sldSz cx="12192000" cy="6858000"/>
   <p:notesSz cx="6858000" cy="12192000"/>
@@ -1133,7 +1135,7 @@
           <a:p>
             <a:r>
               <a:rPr lang="en-US" dirty="0"/>
-              <a:t>Point people at the User Guide for day-to-day use and the Technical Documentation for architecture and maintenance.</a:t>
+              <a:t>Be straight about the last two rows. Qplus has no execution plans and no DBA or BI tooling, and neither is planned. It wins on reach, portability and the shared encrypted library; it does not try to replace the deep engine-specific tools.</a:t>
             </a:r>
             <a:endParaRPr lang="en-US" dirty="0"/>
           </a:p>
@@ -1157,6 +1159,182 @@
             <a:fld id="{F7021451-1387-4CA6-816F-3879F97B5CBC}" type="slidenum">
               <a:rPr lang="en-US"/>
               <a:t>16</a:t>
+            </a:fld>
+            <a:endParaRPr lang="en-US"/>
+          </a:p>
+        </p:txBody>
+      </p:sp>
+    </p:spTree>
+    <p:extLst>
+      <p:ext uri="{BB962C8B-B14F-4D97-AF65-F5344CB8AC3E}">
+        <p14:creationId xmlns:p14="http://schemas.microsoft.com/office/powerpoint/2010/main" val="1024086991"/>
+      </p:ext>
+    </p:extLst>
+  </p:cSld>
+  <p:clrMapOvr>
+    <a:masterClrMapping/>
+  </p:clrMapOvr>
+</p:notes>
+</file>
+
+<file path=ppt/notesSlides/notesSlide17.xml><?xml version="1.0" encoding="utf-8"?>
+<p:notes xmlns:a="http://schemas.openxmlformats.org/drawingml/2006/main" xmlns:r="http://schemas.openxmlformats.org/officeDocument/2006/relationships" xmlns:p="http://schemas.openxmlformats.org/presentationml/2006/main">
+  <p:cSld>
+    <p:spTree>
+      <p:nvGrpSpPr>
+        <p:cNvPr id="1" name=""/>
+        <p:cNvGrpSpPr/>
+        <p:nvPr/>
+      </p:nvGrpSpPr>
+      <p:grpSpPr>
+        <a:xfrm>
+          <a:off x="0" y="0"/>
+          <a:ext cx="0" cy="0"/>
+          <a:chOff x="0" y="0"/>
+          <a:chExt cx="0" cy="0"/>
+        </a:xfrm>
+      </p:grpSpPr>
+      <p:sp>
+        <p:nvSpPr>
+          <p:cNvPr id="2" name="Slide Image Placeholder 1"/>
+          <p:cNvSpPr>
+            <a:spLocks noGrp="1" noRot="1" noChangeAspect="1"/>
+          </p:cNvSpPr>
+          <p:nvPr>
+            <p:ph type="sldImg"/>
+          </p:nvPr>
+        </p:nvSpPr>
+        <p:spPr/>
+      </p:sp>
+      <p:sp>
+        <p:nvSpPr>
+          <p:cNvPr id="3" name="Notes Placeholder 2"/>
+          <p:cNvSpPr>
+            <a:spLocks noGrp="1"/>
+          </p:cNvSpPr>
+          <p:nvPr>
+            <p:ph type="body" idx="1"/>
+          </p:nvPr>
+        </p:nvSpPr>
+        <p:spPr/>
+        <p:txBody>
+          <a:bodyPr/>
+          <a:lstStyle/>
+          <a:p>
+            <a:r>
+              <a:rPr lang="en-US" dirty="0"/>
+              <a:t>Expect this question, so answer it before it is asked: nobody is uninstalling SSMS or SQL Developer. Qplus is the tool you keep open all day; those are the ones you open for a specific job.</a:t>
+            </a:r>
+            <a:endParaRPr lang="en-US" dirty="0"/>
+          </a:p>
+        </p:txBody>
+      </p:sp>
+      <p:sp>
+        <p:nvSpPr>
+          <p:cNvPr id="4" name="Slide Number Placeholder 3"/>
+          <p:cNvSpPr>
+            <a:spLocks noGrp="1"/>
+          </p:cNvSpPr>
+          <p:nvPr>
+            <p:ph type="sldNum" sz="quarter" idx="10"/>
+          </p:nvPr>
+        </p:nvSpPr>
+        <p:spPr/>
+        <p:txBody>
+          <a:bodyPr/>
+          <a:lstStyle/>
+          <a:p>
+            <a:fld id="{F7021451-1387-4CA6-816F-3879F97B5CBC}" type="slidenum">
+              <a:rPr lang="en-US"/>
+              <a:t>17</a:t>
+            </a:fld>
+            <a:endParaRPr lang="en-US"/>
+          </a:p>
+        </p:txBody>
+      </p:sp>
+    </p:spTree>
+    <p:extLst>
+      <p:ext uri="{BB962C8B-B14F-4D97-AF65-F5344CB8AC3E}">
+        <p14:creationId xmlns:p14="http://schemas.microsoft.com/office/powerpoint/2010/main" val="1024086991"/>
+      </p:ext>
+    </p:extLst>
+  </p:cSld>
+  <p:clrMapOvr>
+    <a:masterClrMapping/>
+  </p:clrMapOvr>
+</p:notes>
+</file>
+
+<file path=ppt/notesSlides/notesSlide18.xml><?xml version="1.0" encoding="utf-8"?>
+<p:notes xmlns:a="http://schemas.openxmlformats.org/drawingml/2006/main" xmlns:r="http://schemas.openxmlformats.org/officeDocument/2006/relationships" xmlns:p="http://schemas.openxmlformats.org/presentationml/2006/main">
+  <p:cSld>
+    <p:spTree>
+      <p:nvGrpSpPr>
+        <p:cNvPr id="1" name=""/>
+        <p:cNvGrpSpPr/>
+        <p:nvPr/>
+      </p:nvGrpSpPr>
+      <p:grpSpPr>
+        <a:xfrm>
+          <a:off x="0" y="0"/>
+          <a:ext cx="0" cy="0"/>
+          <a:chOff x="0" y="0"/>
+          <a:chExt cx="0" cy="0"/>
+        </a:xfrm>
+      </p:grpSpPr>
+      <p:sp>
+        <p:nvSpPr>
+          <p:cNvPr id="2" name="Slide Image Placeholder 1"/>
+          <p:cNvSpPr>
+            <a:spLocks noGrp="1" noRot="1" noChangeAspect="1"/>
+          </p:cNvSpPr>
+          <p:nvPr>
+            <p:ph type="sldImg"/>
+          </p:nvPr>
+        </p:nvSpPr>
+        <p:spPr/>
+      </p:sp>
+      <p:sp>
+        <p:nvSpPr>
+          <p:cNvPr id="3" name="Notes Placeholder 2"/>
+          <p:cNvSpPr>
+            <a:spLocks noGrp="1"/>
+          </p:cNvSpPr>
+          <p:nvPr>
+            <p:ph type="body" idx="1"/>
+          </p:nvPr>
+        </p:nvSpPr>
+        <p:spPr/>
+        <p:txBody>
+          <a:bodyPr/>
+          <a:lstStyle/>
+          <a:p>
+            <a:r>
+              <a:rPr lang="en-US" dirty="0"/>
+              <a:t>Point people at the User Guide for day-to-day use and the Technical Documentation for architecture and maintenance.</a:t>
+            </a:r>
+            <a:endParaRPr lang="en-US" dirty="0"/>
+          </a:p>
+        </p:txBody>
+      </p:sp>
+      <p:sp>
+        <p:nvSpPr>
+          <p:cNvPr id="4" name="Slide Number Placeholder 3"/>
+          <p:cNvSpPr>
+            <a:spLocks noGrp="1"/>
+          </p:cNvSpPr>
+          <p:nvPr>
+            <p:ph type="sldNum" sz="quarter" idx="10"/>
+          </p:nvPr>
+        </p:nvSpPr>
+        <p:spPr/>
+        <p:txBody>
+          <a:bodyPr/>
+          <a:lstStyle/>
+          <a:p>
+            <a:fld id="{F7021451-1387-4CA6-816F-3879F97B5CBC}" type="slidenum">
+              <a:rPr lang="en-US"/>
+              <a:t>18</a:t>
             </a:fld>
             <a:endParaRPr lang="en-US"/>
           </a:p>
@@ -6241,6 +6419,4474 @@
     <p:bg>
       <p:bgPr>
         <a:solidFill>
+          <a:srgbClr val="FFFFFF"/>
+        </a:solidFill>
+      </p:bgPr>
+    </p:bg>
+    <p:spTree>
+      <p:nvGrpSpPr>
+        <p:cNvPr id="1" name=""/>
+        <p:cNvGrpSpPr/>
+        <p:nvPr/>
+      </p:nvGrpSpPr>
+      <p:grpSpPr>
+        <a:xfrm>
+          <a:off x="0" y="0"/>
+          <a:ext cx="0" cy="0"/>
+          <a:chOff x="0" y="0"/>
+          <a:chExt cx="0" cy="0"/>
+        </a:xfrm>
+      </p:grpSpPr>
+      <p:sp>
+        <p:nvSpPr>
+          <p:cNvPr id="2" name="Text 0"/>
+          <p:cNvSpPr/>
+          <p:nvPr/>
+        </p:nvSpPr>
+        <p:spPr>
+          <a:xfrm>
+            <a:off x="548640" y="411480"/>
+            <a:ext cx="7315200" cy="256032"/>
+          </a:xfrm>
+          <a:prstGeom prst="rect">
+            <a:avLst/>
+          </a:prstGeom>
+          <a:noFill/>
+          <a:ln/>
+        </p:spPr>
+        <p:txBody>
+          <a:bodyPr wrap="square" lIns="0" tIns="0" rIns="0" bIns="0" rtlCol="0" anchor="ctr"/>
+          <a:lstStyle/>
+          <a:p>
+            <a:pPr indent="0" marL="0">
+              <a:buNone/>
+            </a:pPr>
+            <a:r>
+              <a:rPr lang="en-US" sz="1100" b="1" spc="200" kern="0" dirty="0">
+                <a:solidFill>
+                  <a:srgbClr val="2D8CFF"/>
+                </a:solidFill>
+                <a:latin typeface="Calibri" pitchFamily="34" charset="0"/>
+                <a:ea typeface="Calibri" pitchFamily="34" charset="-122"/>
+                <a:cs typeface="Calibri" pitchFamily="34" charset="-120"/>
+              </a:rPr>
+              <a:t>FEATURE MATRIX</a:t>
+            </a:r>
+            <a:endParaRPr lang="en-US" sz="1100" dirty="0"/>
+          </a:p>
+        </p:txBody>
+      </p:sp>
+      <p:sp>
+        <p:nvSpPr>
+          <p:cNvPr id="3" name="Text 1"/>
+          <p:cNvSpPr/>
+          <p:nvPr/>
+        </p:nvSpPr>
+        <p:spPr>
+          <a:xfrm>
+            <a:off x="548640" y="713232"/>
+            <a:ext cx="11064240" cy="685800"/>
+          </a:xfrm>
+          <a:prstGeom prst="rect">
+            <a:avLst/>
+          </a:prstGeom>
+          <a:noFill/>
+          <a:ln/>
+        </p:spPr>
+        <p:txBody>
+          <a:bodyPr wrap="square" lIns="0" tIns="0" rIns="0" bIns="0" rtlCol="0" anchor="ctr"/>
+          <a:lstStyle/>
+          <a:p>
+            <a:pPr indent="0" marL="0">
+              <a:buNone/>
+            </a:pPr>
+            <a:r>
+              <a:rPr lang="en-US" sz="3400" b="1" dirty="0">
+                <a:solidFill>
+                  <a:srgbClr val="1B1D22"/>
+                </a:solidFill>
+                <a:latin typeface="Calibri" pitchFamily="34" charset="0"/>
+                <a:ea typeface="Calibri" pitchFamily="34" charset="-122"/>
+                <a:cs typeface="Calibri" pitchFamily="34" charset="-120"/>
+              </a:rPr>
+              <a:t>How Qplus compares</a:t>
+            </a:r>
+            <a:endParaRPr lang="en-US" sz="3400" dirty="0"/>
+          </a:p>
+        </p:txBody>
+      </p:sp>
+      <p:graphicFrame>
+        <p:nvGraphicFramePr>
+          <p:cNvPr id="17" name="Table 0"/>
+          <p:cNvGraphicFramePr>
+            <a:graphicFrameLocks noGrp="1"/>
+          </p:cNvGraphicFramePr>
+          <p:nvPr>
+            <p:extLst>
+              <p:ext uri="{D42A27DB-BD31-4B8C-83A1-F6EECF244321}">
+                <p14:modId xmlns:p14="http://schemas.microsoft.com/office/powerpoint/2010/main" val="1579011935"/>
+              </p:ext>
+            </p:extLst>
+          </p:nvPr>
+        </p:nvGraphicFramePr>
+        <p:xfrm>
+          <a:off x="548640" y="1481328"/>
+          <a:ext cx="11064240" cy="914400"/>
+        </p:xfrm>
+        <a:graphic>
+          <a:graphicData uri="http://schemas.openxmlformats.org/drawingml/2006/table">
+            <a:tbl>
+              <a:tblPr/>
+              <a:tblGrid>
+                <a:gridCol w="5120640"/>
+                <a:gridCol w="1828800"/>
+                <a:gridCol w="1828800"/>
+                <a:gridCol w="2286000"/>
+              </a:tblGrid>
+              <a:tr h="333756">
+                <a:tc>
+                  <a:txBody>
+                    <a:bodyPr/>
+                    <a:lstStyle/>
+                    <a:p>
+                      <a:pPr algn="l" indent="0" marL="0">
+                        <a:buNone/>
+                      </a:pPr>
+                      <a:r>
+                        <a:rPr lang="en-US" sz="1200" b="1" dirty="0">
+                          <a:solidFill>
+                            <a:srgbClr val="FFFFFF"/>
+                          </a:solidFill>
+                          <a:latin typeface="Calibri" pitchFamily="34" charset="0"/>
+                          <a:ea typeface="Calibri" pitchFamily="34" charset="-122"/>
+                          <a:cs typeface="Calibri" pitchFamily="34" charset="-120"/>
+                        </a:rPr>
+                        <a:t>Feature</a:t>
+                      </a:r>
+                      <a:endParaRPr lang="en-US" sz="1200" dirty="0">
+                        <a:latin typeface="Calibri" charset="0"/>
+                        <a:ea typeface="Calibri" charset="0"/>
+                        <a:cs typeface="Calibri" charset="0"/>
+                      </a:endParaRPr>
+                    </a:p>
+                  </a:txBody>
+                  <a:tcPr marL="76200" marR="76200" marT="25400" marB="25400" anchor="ctr">
+                    <a:lnL w="6350" cap="flat" cmpd="sng" algn="ctr">
+                      <a:solidFill>
+                        <a:srgbClr val="DCE2EA"/>
+                      </a:solidFill>
+                      <a:prstDash val="solid"/>
+                      <a:round/>
+                      <a:headEnd type="none" w="med" len="med"/>
+                      <a:tailEnd type="none" w="med" len="med"/>
+                    </a:lnL>
+                    <a:lnR w="6350" cap="flat" cmpd="sng" algn="ctr">
+                      <a:solidFill>
+                        <a:srgbClr val="DCE2EA"/>
+                      </a:solidFill>
+                      <a:prstDash val="solid"/>
+                      <a:round/>
+                      <a:headEnd type="none" w="med" len="med"/>
+                      <a:tailEnd type="none" w="med" len="med"/>
+                    </a:lnR>
+                    <a:lnT w="6350" cap="flat" cmpd="sng" algn="ctr">
+                      <a:solidFill>
+                        <a:srgbClr val="DCE2EA"/>
+                      </a:solidFill>
+                      <a:prstDash val="solid"/>
+                      <a:round/>
+                      <a:headEnd type="none" w="med" len="med"/>
+                      <a:tailEnd type="none" w="med" len="med"/>
+                    </a:lnT>
+                    <a:lnB w="6350" cap="flat" cmpd="sng" algn="ctr">
+                      <a:solidFill>
+                        <a:srgbClr val="DCE2EA"/>
+                      </a:solidFill>
+                      <a:prstDash val="solid"/>
+                      <a:round/>
+                      <a:headEnd type="none" w="med" len="med"/>
+                      <a:tailEnd type="none" w="med" len="med"/>
+                    </a:lnB>
+                    <a:solidFill>
+                      <a:srgbClr val="1B1D22"/>
+                    </a:solidFill>
+                  </a:tcPr>
+                </a:tc>
+                <a:tc>
+                  <a:txBody>
+                    <a:bodyPr/>
+                    <a:lstStyle/>
+                    <a:p>
+                      <a:pPr algn="ctr" indent="0" marL="0">
+                        <a:buNone/>
+                      </a:pPr>
+                      <a:r>
+                        <a:rPr lang="en-US" sz="1200" b="1" dirty="0">
+                          <a:solidFill>
+                            <a:srgbClr val="FFFFFF"/>
+                          </a:solidFill>
+                          <a:latin typeface="Calibri" pitchFamily="34" charset="0"/>
+                          <a:ea typeface="Calibri" pitchFamily="34" charset="-122"/>
+                          <a:cs typeface="Calibri" pitchFamily="34" charset="-120"/>
+                        </a:rPr>
+                        <a:t>Qplus</a:t>
+                      </a:r>
+                      <a:endParaRPr lang="en-US" sz="1200" dirty="0">
+                        <a:latin typeface="Calibri" charset="0"/>
+                        <a:ea typeface="Calibri" charset="0"/>
+                        <a:cs typeface="Calibri" charset="0"/>
+                      </a:endParaRPr>
+                    </a:p>
+                  </a:txBody>
+                  <a:tcPr marL="76200" marR="76200" marT="25400" marB="25400" anchor="ctr">
+                    <a:lnL w="6350" cap="flat" cmpd="sng" algn="ctr">
+                      <a:solidFill>
+                        <a:srgbClr val="DCE2EA"/>
+                      </a:solidFill>
+                      <a:prstDash val="solid"/>
+                      <a:round/>
+                      <a:headEnd type="none" w="med" len="med"/>
+                      <a:tailEnd type="none" w="med" len="med"/>
+                    </a:lnL>
+                    <a:lnR w="6350" cap="flat" cmpd="sng" algn="ctr">
+                      <a:solidFill>
+                        <a:srgbClr val="DCE2EA"/>
+                      </a:solidFill>
+                      <a:prstDash val="solid"/>
+                      <a:round/>
+                      <a:headEnd type="none" w="med" len="med"/>
+                      <a:tailEnd type="none" w="med" len="med"/>
+                    </a:lnR>
+                    <a:lnT w="6350" cap="flat" cmpd="sng" algn="ctr">
+                      <a:solidFill>
+                        <a:srgbClr val="DCE2EA"/>
+                      </a:solidFill>
+                      <a:prstDash val="solid"/>
+                      <a:round/>
+                      <a:headEnd type="none" w="med" len="med"/>
+                      <a:tailEnd type="none" w="med" len="med"/>
+                    </a:lnT>
+                    <a:lnB w="6350" cap="flat" cmpd="sng" algn="ctr">
+                      <a:solidFill>
+                        <a:srgbClr val="DCE2EA"/>
+                      </a:solidFill>
+                      <a:prstDash val="solid"/>
+                      <a:round/>
+                      <a:headEnd type="none" w="med" len="med"/>
+                      <a:tailEnd type="none" w="med" len="med"/>
+                    </a:lnB>
+                    <a:solidFill>
+                      <a:srgbClr val="1B1D22"/>
+                    </a:solidFill>
+                  </a:tcPr>
+                </a:tc>
+                <a:tc>
+                  <a:txBody>
+                    <a:bodyPr/>
+                    <a:lstStyle/>
+                    <a:p>
+                      <a:pPr algn="ctr" indent="0" marL="0">
+                        <a:buNone/>
+                      </a:pPr>
+                      <a:r>
+                        <a:rPr lang="en-US" sz="1200" b="1" dirty="0">
+                          <a:solidFill>
+                            <a:srgbClr val="FFFFFF"/>
+                          </a:solidFill>
+                          <a:latin typeface="Calibri" pitchFamily="34" charset="0"/>
+                          <a:ea typeface="Calibri" pitchFamily="34" charset="-122"/>
+                          <a:cs typeface="Calibri" pitchFamily="34" charset="-120"/>
+                        </a:rPr>
+                        <a:t>SSMS</a:t>
+                      </a:r>
+                      <a:endParaRPr lang="en-US" sz="1200" dirty="0">
+                        <a:latin typeface="Calibri" charset="0"/>
+                        <a:ea typeface="Calibri" charset="0"/>
+                        <a:cs typeface="Calibri" charset="0"/>
+                      </a:endParaRPr>
+                    </a:p>
+                  </a:txBody>
+                  <a:tcPr marL="76200" marR="76200" marT="25400" marB="25400" anchor="ctr">
+                    <a:lnL w="6350" cap="flat" cmpd="sng" algn="ctr">
+                      <a:solidFill>
+                        <a:srgbClr val="DCE2EA"/>
+                      </a:solidFill>
+                      <a:prstDash val="solid"/>
+                      <a:round/>
+                      <a:headEnd type="none" w="med" len="med"/>
+                      <a:tailEnd type="none" w="med" len="med"/>
+                    </a:lnL>
+                    <a:lnR w="6350" cap="flat" cmpd="sng" algn="ctr">
+                      <a:solidFill>
+                        <a:srgbClr val="DCE2EA"/>
+                      </a:solidFill>
+                      <a:prstDash val="solid"/>
+                      <a:round/>
+                      <a:headEnd type="none" w="med" len="med"/>
+                      <a:tailEnd type="none" w="med" len="med"/>
+                    </a:lnR>
+                    <a:lnT w="6350" cap="flat" cmpd="sng" algn="ctr">
+                      <a:solidFill>
+                        <a:srgbClr val="DCE2EA"/>
+                      </a:solidFill>
+                      <a:prstDash val="solid"/>
+                      <a:round/>
+                      <a:headEnd type="none" w="med" len="med"/>
+                      <a:tailEnd type="none" w="med" len="med"/>
+                    </a:lnT>
+                    <a:lnB w="6350" cap="flat" cmpd="sng" algn="ctr">
+                      <a:solidFill>
+                        <a:srgbClr val="DCE2EA"/>
+                      </a:solidFill>
+                      <a:prstDash val="solid"/>
+                      <a:round/>
+                      <a:headEnd type="none" w="med" len="med"/>
+                      <a:tailEnd type="none" w="med" len="med"/>
+                    </a:lnB>
+                    <a:solidFill>
+                      <a:srgbClr val="1B1D22"/>
+                    </a:solidFill>
+                  </a:tcPr>
+                </a:tc>
+                <a:tc>
+                  <a:txBody>
+                    <a:bodyPr/>
+                    <a:lstStyle/>
+                    <a:p>
+                      <a:pPr algn="ctr" indent="0" marL="0">
+                        <a:buNone/>
+                      </a:pPr>
+                      <a:r>
+                        <a:rPr lang="en-US" sz="1200" b="1" dirty="0">
+                          <a:solidFill>
+                            <a:srgbClr val="FFFFFF"/>
+                          </a:solidFill>
+                          <a:latin typeface="Calibri" pitchFamily="34" charset="0"/>
+                          <a:ea typeface="Calibri" pitchFamily="34" charset="-122"/>
+                          <a:cs typeface="Calibri" pitchFamily="34" charset="-120"/>
+                        </a:rPr>
+                        <a:t>SQL Developer</a:t>
+                      </a:r>
+                      <a:endParaRPr lang="en-US" sz="1200" dirty="0">
+                        <a:latin typeface="Calibri" charset="0"/>
+                        <a:ea typeface="Calibri" charset="0"/>
+                        <a:cs typeface="Calibri" charset="0"/>
+                      </a:endParaRPr>
+                    </a:p>
+                  </a:txBody>
+                  <a:tcPr marL="76200" marR="76200" marT="25400" marB="25400" anchor="ctr">
+                    <a:lnL w="6350" cap="flat" cmpd="sng" algn="ctr">
+                      <a:solidFill>
+                        <a:srgbClr val="DCE2EA"/>
+                      </a:solidFill>
+                      <a:prstDash val="solid"/>
+                      <a:round/>
+                      <a:headEnd type="none" w="med" len="med"/>
+                      <a:tailEnd type="none" w="med" len="med"/>
+                    </a:lnL>
+                    <a:lnR w="6350" cap="flat" cmpd="sng" algn="ctr">
+                      <a:solidFill>
+                        <a:srgbClr val="DCE2EA"/>
+                      </a:solidFill>
+                      <a:prstDash val="solid"/>
+                      <a:round/>
+                      <a:headEnd type="none" w="med" len="med"/>
+                      <a:tailEnd type="none" w="med" len="med"/>
+                    </a:lnR>
+                    <a:lnT w="6350" cap="flat" cmpd="sng" algn="ctr">
+                      <a:solidFill>
+                        <a:srgbClr val="DCE2EA"/>
+                      </a:solidFill>
+                      <a:prstDash val="solid"/>
+                      <a:round/>
+                      <a:headEnd type="none" w="med" len="med"/>
+                      <a:tailEnd type="none" w="med" len="med"/>
+                    </a:lnT>
+                    <a:lnB w="6350" cap="flat" cmpd="sng" algn="ctr">
+                      <a:solidFill>
+                        <a:srgbClr val="DCE2EA"/>
+                      </a:solidFill>
+                      <a:prstDash val="solid"/>
+                      <a:round/>
+                      <a:headEnd type="none" w="med" len="med"/>
+                      <a:tailEnd type="none" w="med" len="med"/>
+                    </a:lnB>
+                    <a:solidFill>
+                      <a:srgbClr val="1B1D22"/>
+                    </a:solidFill>
+                  </a:tcPr>
+                </a:tc>
+              </a:tr>
+              <a:tr h="333756">
+                <a:tc>
+                  <a:txBody>
+                    <a:bodyPr/>
+                    <a:lstStyle/>
+                    <a:p>
+                      <a:pPr indent="0" marL="0">
+                        <a:buNone/>
+                      </a:pPr>
+                      <a:r>
+                        <a:rPr lang="en-US" sz="1150" dirty="0">
+                          <a:solidFill>
+                            <a:srgbClr val="1B1D22"/>
+                          </a:solidFill>
+                          <a:latin typeface="Calibri" pitchFamily="34" charset="0"/>
+                          <a:ea typeface="Calibri" pitchFamily="34" charset="-122"/>
+                          <a:cs typeface="Calibri" pitchFamily="34" charset="-120"/>
+                        </a:rPr>
+                        <a:t>SQL Server</a:t>
+                      </a:r>
+                      <a:endParaRPr lang="en-US" sz="1150" dirty="0">
+                        <a:latin typeface="Calibri" charset="0"/>
+                        <a:ea typeface="Calibri" charset="0"/>
+                        <a:cs typeface="Calibri" charset="0"/>
+                      </a:endParaRPr>
+                    </a:p>
+                  </a:txBody>
+                  <a:tcPr marL="76200" marR="76200" marT="25400" marB="25400" anchor="ctr">
+                    <a:lnL w="6350" cap="flat" cmpd="sng" algn="ctr">
+                      <a:solidFill>
+                        <a:srgbClr val="DCE2EA"/>
+                      </a:solidFill>
+                      <a:prstDash val="solid"/>
+                      <a:round/>
+                      <a:headEnd type="none" w="med" len="med"/>
+                      <a:tailEnd type="none" w="med" len="med"/>
+                    </a:lnL>
+                    <a:lnR w="6350" cap="flat" cmpd="sng" algn="ctr">
+                      <a:solidFill>
+                        <a:srgbClr val="DCE2EA"/>
+                      </a:solidFill>
+                      <a:prstDash val="solid"/>
+                      <a:round/>
+                      <a:headEnd type="none" w="med" len="med"/>
+                      <a:tailEnd type="none" w="med" len="med"/>
+                    </a:lnR>
+                    <a:lnT w="6350" cap="flat" cmpd="sng" algn="ctr">
+                      <a:solidFill>
+                        <a:srgbClr val="DCE2EA"/>
+                      </a:solidFill>
+                      <a:prstDash val="solid"/>
+                      <a:round/>
+                      <a:headEnd type="none" w="med" len="med"/>
+                      <a:tailEnd type="none" w="med" len="med"/>
+                    </a:lnT>
+                    <a:lnB w="6350" cap="flat" cmpd="sng" algn="ctr">
+                      <a:solidFill>
+                        <a:srgbClr val="DCE2EA"/>
+                      </a:solidFill>
+                      <a:prstDash val="solid"/>
+                      <a:round/>
+                      <a:headEnd type="none" w="med" len="med"/>
+                      <a:tailEnd type="none" w="med" len="med"/>
+                    </a:lnB>
+                    <a:solidFill>
+                      <a:srgbClr val="FFFFFF"/>
+                    </a:solidFill>
+                  </a:tcPr>
+                </a:tc>
+                <a:tc>
+                  <a:txBody>
+                    <a:bodyPr/>
+                    <a:lstStyle/>
+                    <a:p>
+                      <a:pPr algn="ctr" indent="0" marL="0">
+                        <a:buNone/>
+                      </a:pPr>
+                      <a:r>
+                        <a:rPr lang="en-US" sz="1500" b="1" dirty="0">
+                          <a:solidFill>
+                            <a:srgbClr val="1E7B34"/>
+                          </a:solidFill>
+                          <a:latin typeface="Calibri" pitchFamily="34" charset="0"/>
+                          <a:ea typeface="Calibri" pitchFamily="34" charset="-122"/>
+                          <a:cs typeface="Calibri" pitchFamily="34" charset="-120"/>
+                        </a:rPr>
+                        <a:t>●</a:t>
+                      </a:r>
+                      <a:endParaRPr lang="en-US" sz="1500" dirty="0">
+                        <a:latin typeface="Calibri" charset="0"/>
+                        <a:ea typeface="Calibri" charset="0"/>
+                        <a:cs typeface="Calibri" charset="0"/>
+                      </a:endParaRPr>
+                    </a:p>
+                  </a:txBody>
+                  <a:tcPr marL="76200" marR="76200" marT="25400" marB="25400" anchor="ctr">
+                    <a:lnL w="6350" cap="flat" cmpd="sng" algn="ctr">
+                      <a:solidFill>
+                        <a:srgbClr val="DCE2EA"/>
+                      </a:solidFill>
+                      <a:prstDash val="solid"/>
+                      <a:round/>
+                      <a:headEnd type="none" w="med" len="med"/>
+                      <a:tailEnd type="none" w="med" len="med"/>
+                    </a:lnL>
+                    <a:lnR w="6350" cap="flat" cmpd="sng" algn="ctr">
+                      <a:solidFill>
+                        <a:srgbClr val="DCE2EA"/>
+                      </a:solidFill>
+                      <a:prstDash val="solid"/>
+                      <a:round/>
+                      <a:headEnd type="none" w="med" len="med"/>
+                      <a:tailEnd type="none" w="med" len="med"/>
+                    </a:lnR>
+                    <a:lnT w="6350" cap="flat" cmpd="sng" algn="ctr">
+                      <a:solidFill>
+                        <a:srgbClr val="DCE2EA"/>
+                      </a:solidFill>
+                      <a:prstDash val="solid"/>
+                      <a:round/>
+                      <a:headEnd type="none" w="med" len="med"/>
+                      <a:tailEnd type="none" w="med" len="med"/>
+                    </a:lnT>
+                    <a:lnB w="6350" cap="flat" cmpd="sng" algn="ctr">
+                      <a:solidFill>
+                        <a:srgbClr val="DCE2EA"/>
+                      </a:solidFill>
+                      <a:prstDash val="solid"/>
+                      <a:round/>
+                      <a:headEnd type="none" w="med" len="med"/>
+                      <a:tailEnd type="none" w="med" len="med"/>
+                    </a:lnB>
+                    <a:solidFill>
+                      <a:srgbClr val="FFFFFF"/>
+                    </a:solidFill>
+                  </a:tcPr>
+                </a:tc>
+                <a:tc>
+                  <a:txBody>
+                    <a:bodyPr/>
+                    <a:lstStyle/>
+                    <a:p>
+                      <a:pPr algn="ctr" indent="0" marL="0">
+                        <a:buNone/>
+                      </a:pPr>
+                      <a:r>
+                        <a:rPr lang="en-US" sz="1500" b="1" dirty="0">
+                          <a:solidFill>
+                            <a:srgbClr val="1E7B34"/>
+                          </a:solidFill>
+                          <a:latin typeface="Calibri" pitchFamily="34" charset="0"/>
+                          <a:ea typeface="Calibri" pitchFamily="34" charset="-122"/>
+                          <a:cs typeface="Calibri" pitchFamily="34" charset="-120"/>
+                        </a:rPr>
+                        <a:t>●</a:t>
+                      </a:r>
+                      <a:endParaRPr lang="en-US" sz="1500" dirty="0">
+                        <a:latin typeface="Calibri" charset="0"/>
+                        <a:ea typeface="Calibri" charset="0"/>
+                        <a:cs typeface="Calibri" charset="0"/>
+                      </a:endParaRPr>
+                    </a:p>
+                  </a:txBody>
+                  <a:tcPr marL="76200" marR="76200" marT="25400" marB="25400" anchor="ctr">
+                    <a:lnL w="6350" cap="flat" cmpd="sng" algn="ctr">
+                      <a:solidFill>
+                        <a:srgbClr val="DCE2EA"/>
+                      </a:solidFill>
+                      <a:prstDash val="solid"/>
+                      <a:round/>
+                      <a:headEnd type="none" w="med" len="med"/>
+                      <a:tailEnd type="none" w="med" len="med"/>
+                    </a:lnL>
+                    <a:lnR w="6350" cap="flat" cmpd="sng" algn="ctr">
+                      <a:solidFill>
+                        <a:srgbClr val="DCE2EA"/>
+                      </a:solidFill>
+                      <a:prstDash val="solid"/>
+                      <a:round/>
+                      <a:headEnd type="none" w="med" len="med"/>
+                      <a:tailEnd type="none" w="med" len="med"/>
+                    </a:lnR>
+                    <a:lnT w="6350" cap="flat" cmpd="sng" algn="ctr">
+                      <a:solidFill>
+                        <a:srgbClr val="DCE2EA"/>
+                      </a:solidFill>
+                      <a:prstDash val="solid"/>
+                      <a:round/>
+                      <a:headEnd type="none" w="med" len="med"/>
+                      <a:tailEnd type="none" w="med" len="med"/>
+                    </a:lnT>
+                    <a:lnB w="6350" cap="flat" cmpd="sng" algn="ctr">
+                      <a:solidFill>
+                        <a:srgbClr val="DCE2EA"/>
+                      </a:solidFill>
+                      <a:prstDash val="solid"/>
+                      <a:round/>
+                      <a:headEnd type="none" w="med" len="med"/>
+                      <a:tailEnd type="none" w="med" len="med"/>
+                    </a:lnB>
+                    <a:solidFill>
+                      <a:srgbClr val="FFFFFF"/>
+                    </a:solidFill>
+                  </a:tcPr>
+                </a:tc>
+                <a:tc>
+                  <a:txBody>
+                    <a:bodyPr/>
+                    <a:lstStyle/>
+                    <a:p>
+                      <a:pPr algn="ctr" indent="0" marL="0">
+                        <a:buNone/>
+                      </a:pPr>
+                      <a:r>
+                        <a:rPr lang="en-US" sz="1500" b="1" dirty="0">
+                          <a:solidFill>
+                            <a:srgbClr val="B06000"/>
+                          </a:solidFill>
+                          <a:latin typeface="Calibri" pitchFamily="34" charset="0"/>
+                          <a:ea typeface="Calibri" pitchFamily="34" charset="-122"/>
+                          <a:cs typeface="Calibri" pitchFamily="34" charset="-120"/>
+                        </a:rPr>
+                        <a:t>◐</a:t>
+                      </a:r>
+                      <a:endParaRPr lang="en-US" sz="1500" dirty="0">
+                        <a:latin typeface="Calibri" charset="0"/>
+                        <a:ea typeface="Calibri" charset="0"/>
+                        <a:cs typeface="Calibri" charset="0"/>
+                      </a:endParaRPr>
+                    </a:p>
+                  </a:txBody>
+                  <a:tcPr marL="76200" marR="76200" marT="25400" marB="25400" anchor="ctr">
+                    <a:lnL w="6350" cap="flat" cmpd="sng" algn="ctr">
+                      <a:solidFill>
+                        <a:srgbClr val="DCE2EA"/>
+                      </a:solidFill>
+                      <a:prstDash val="solid"/>
+                      <a:round/>
+                      <a:headEnd type="none" w="med" len="med"/>
+                      <a:tailEnd type="none" w="med" len="med"/>
+                    </a:lnL>
+                    <a:lnR w="6350" cap="flat" cmpd="sng" algn="ctr">
+                      <a:solidFill>
+                        <a:srgbClr val="DCE2EA"/>
+                      </a:solidFill>
+                      <a:prstDash val="solid"/>
+                      <a:round/>
+                      <a:headEnd type="none" w="med" len="med"/>
+                      <a:tailEnd type="none" w="med" len="med"/>
+                    </a:lnR>
+                    <a:lnT w="6350" cap="flat" cmpd="sng" algn="ctr">
+                      <a:solidFill>
+                        <a:srgbClr val="DCE2EA"/>
+                      </a:solidFill>
+                      <a:prstDash val="solid"/>
+                      <a:round/>
+                      <a:headEnd type="none" w="med" len="med"/>
+                      <a:tailEnd type="none" w="med" len="med"/>
+                    </a:lnT>
+                    <a:lnB w="6350" cap="flat" cmpd="sng" algn="ctr">
+                      <a:solidFill>
+                        <a:srgbClr val="DCE2EA"/>
+                      </a:solidFill>
+                      <a:prstDash val="solid"/>
+                      <a:round/>
+                      <a:headEnd type="none" w="med" len="med"/>
+                      <a:tailEnd type="none" w="med" len="med"/>
+                    </a:lnB>
+                    <a:solidFill>
+                      <a:srgbClr val="FFFFFF"/>
+                    </a:solidFill>
+                  </a:tcPr>
+                </a:tc>
+              </a:tr>
+              <a:tr h="333756">
+                <a:tc>
+                  <a:txBody>
+                    <a:bodyPr/>
+                    <a:lstStyle/>
+                    <a:p>
+                      <a:pPr indent="0" marL="0">
+                        <a:buNone/>
+                      </a:pPr>
+                      <a:r>
+                        <a:rPr lang="en-US" sz="1150" dirty="0">
+                          <a:solidFill>
+                            <a:srgbClr val="1B1D22"/>
+                          </a:solidFill>
+                          <a:latin typeface="Calibri" pitchFamily="34" charset="0"/>
+                          <a:ea typeface="Calibri" pitchFamily="34" charset="-122"/>
+                          <a:cs typeface="Calibri" pitchFamily="34" charset="-120"/>
+                        </a:rPr>
+                        <a:t>Oracle</a:t>
+                      </a:r>
+                      <a:endParaRPr lang="en-US" sz="1150" dirty="0">
+                        <a:latin typeface="Calibri" charset="0"/>
+                        <a:ea typeface="Calibri" charset="0"/>
+                        <a:cs typeface="Calibri" charset="0"/>
+                      </a:endParaRPr>
+                    </a:p>
+                  </a:txBody>
+                  <a:tcPr marL="76200" marR="76200" marT="25400" marB="25400" anchor="ctr">
+                    <a:lnL w="6350" cap="flat" cmpd="sng" algn="ctr">
+                      <a:solidFill>
+                        <a:srgbClr val="DCE2EA"/>
+                      </a:solidFill>
+                      <a:prstDash val="solid"/>
+                      <a:round/>
+                      <a:headEnd type="none" w="med" len="med"/>
+                      <a:tailEnd type="none" w="med" len="med"/>
+                    </a:lnL>
+                    <a:lnR w="6350" cap="flat" cmpd="sng" algn="ctr">
+                      <a:solidFill>
+                        <a:srgbClr val="DCE2EA"/>
+                      </a:solidFill>
+                      <a:prstDash val="solid"/>
+                      <a:round/>
+                      <a:headEnd type="none" w="med" len="med"/>
+                      <a:tailEnd type="none" w="med" len="med"/>
+                    </a:lnR>
+                    <a:lnT w="6350" cap="flat" cmpd="sng" algn="ctr">
+                      <a:solidFill>
+                        <a:srgbClr val="DCE2EA"/>
+                      </a:solidFill>
+                      <a:prstDash val="solid"/>
+                      <a:round/>
+                      <a:headEnd type="none" w="med" len="med"/>
+                      <a:tailEnd type="none" w="med" len="med"/>
+                    </a:lnT>
+                    <a:lnB w="6350" cap="flat" cmpd="sng" algn="ctr">
+                      <a:solidFill>
+                        <a:srgbClr val="DCE2EA"/>
+                      </a:solidFill>
+                      <a:prstDash val="solid"/>
+                      <a:round/>
+                      <a:headEnd type="none" w="med" len="med"/>
+                      <a:tailEnd type="none" w="med" len="med"/>
+                    </a:lnB>
+                    <a:solidFill>
+                      <a:srgbClr val="F4F6F8"/>
+                    </a:solidFill>
+                  </a:tcPr>
+                </a:tc>
+                <a:tc>
+                  <a:txBody>
+                    <a:bodyPr/>
+                    <a:lstStyle/>
+                    <a:p>
+                      <a:pPr algn="ctr" indent="0" marL="0">
+                        <a:buNone/>
+                      </a:pPr>
+                      <a:r>
+                        <a:rPr lang="en-US" sz="1500" b="1" dirty="0">
+                          <a:solidFill>
+                            <a:srgbClr val="1E7B34"/>
+                          </a:solidFill>
+                          <a:latin typeface="Calibri" pitchFamily="34" charset="0"/>
+                          <a:ea typeface="Calibri" pitchFamily="34" charset="-122"/>
+                          <a:cs typeface="Calibri" pitchFamily="34" charset="-120"/>
+                        </a:rPr>
+                        <a:t>●</a:t>
+                      </a:r>
+                      <a:endParaRPr lang="en-US" sz="1500" dirty="0">
+                        <a:latin typeface="Calibri" charset="0"/>
+                        <a:ea typeface="Calibri" charset="0"/>
+                        <a:cs typeface="Calibri" charset="0"/>
+                      </a:endParaRPr>
+                    </a:p>
+                  </a:txBody>
+                  <a:tcPr marL="76200" marR="76200" marT="25400" marB="25400" anchor="ctr">
+                    <a:lnL w="6350" cap="flat" cmpd="sng" algn="ctr">
+                      <a:solidFill>
+                        <a:srgbClr val="DCE2EA"/>
+                      </a:solidFill>
+                      <a:prstDash val="solid"/>
+                      <a:round/>
+                      <a:headEnd type="none" w="med" len="med"/>
+                      <a:tailEnd type="none" w="med" len="med"/>
+                    </a:lnL>
+                    <a:lnR w="6350" cap="flat" cmpd="sng" algn="ctr">
+                      <a:solidFill>
+                        <a:srgbClr val="DCE2EA"/>
+                      </a:solidFill>
+                      <a:prstDash val="solid"/>
+                      <a:round/>
+                      <a:headEnd type="none" w="med" len="med"/>
+                      <a:tailEnd type="none" w="med" len="med"/>
+                    </a:lnR>
+                    <a:lnT w="6350" cap="flat" cmpd="sng" algn="ctr">
+                      <a:solidFill>
+                        <a:srgbClr val="DCE2EA"/>
+                      </a:solidFill>
+                      <a:prstDash val="solid"/>
+                      <a:round/>
+                      <a:headEnd type="none" w="med" len="med"/>
+                      <a:tailEnd type="none" w="med" len="med"/>
+                    </a:lnT>
+                    <a:lnB w="6350" cap="flat" cmpd="sng" algn="ctr">
+                      <a:solidFill>
+                        <a:srgbClr val="DCE2EA"/>
+                      </a:solidFill>
+                      <a:prstDash val="solid"/>
+                      <a:round/>
+                      <a:headEnd type="none" w="med" len="med"/>
+                      <a:tailEnd type="none" w="med" len="med"/>
+                    </a:lnB>
+                    <a:solidFill>
+                      <a:srgbClr val="F4F6F8"/>
+                    </a:solidFill>
+                  </a:tcPr>
+                </a:tc>
+                <a:tc>
+                  <a:txBody>
+                    <a:bodyPr/>
+                    <a:lstStyle/>
+                    <a:p>
+                      <a:pPr algn="ctr" indent="0" marL="0">
+                        <a:buNone/>
+                      </a:pPr>
+                      <a:r>
+                        <a:rPr lang="en-US" sz="1500" b="1" dirty="0">
+                          <a:solidFill>
+                            <a:srgbClr val="9AA3AE"/>
+                          </a:solidFill>
+                          <a:latin typeface="Calibri" pitchFamily="34" charset="0"/>
+                          <a:ea typeface="Calibri" pitchFamily="34" charset="-122"/>
+                          <a:cs typeface="Calibri" pitchFamily="34" charset="-120"/>
+                        </a:rPr>
+                        <a:t>○</a:t>
+                      </a:r>
+                      <a:endParaRPr lang="en-US" sz="1500" dirty="0">
+                        <a:latin typeface="Calibri" charset="0"/>
+                        <a:ea typeface="Calibri" charset="0"/>
+                        <a:cs typeface="Calibri" charset="0"/>
+                      </a:endParaRPr>
+                    </a:p>
+                  </a:txBody>
+                  <a:tcPr marL="76200" marR="76200" marT="25400" marB="25400" anchor="ctr">
+                    <a:lnL w="6350" cap="flat" cmpd="sng" algn="ctr">
+                      <a:solidFill>
+                        <a:srgbClr val="DCE2EA"/>
+                      </a:solidFill>
+                      <a:prstDash val="solid"/>
+                      <a:round/>
+                      <a:headEnd type="none" w="med" len="med"/>
+                      <a:tailEnd type="none" w="med" len="med"/>
+                    </a:lnL>
+                    <a:lnR w="6350" cap="flat" cmpd="sng" algn="ctr">
+                      <a:solidFill>
+                        <a:srgbClr val="DCE2EA"/>
+                      </a:solidFill>
+                      <a:prstDash val="solid"/>
+                      <a:round/>
+                      <a:headEnd type="none" w="med" len="med"/>
+                      <a:tailEnd type="none" w="med" len="med"/>
+                    </a:lnR>
+                    <a:lnT w="6350" cap="flat" cmpd="sng" algn="ctr">
+                      <a:solidFill>
+                        <a:srgbClr val="DCE2EA"/>
+                      </a:solidFill>
+                      <a:prstDash val="solid"/>
+                      <a:round/>
+                      <a:headEnd type="none" w="med" len="med"/>
+                      <a:tailEnd type="none" w="med" len="med"/>
+                    </a:lnT>
+                    <a:lnB w="6350" cap="flat" cmpd="sng" algn="ctr">
+                      <a:solidFill>
+                        <a:srgbClr val="DCE2EA"/>
+                      </a:solidFill>
+                      <a:prstDash val="solid"/>
+                      <a:round/>
+                      <a:headEnd type="none" w="med" len="med"/>
+                      <a:tailEnd type="none" w="med" len="med"/>
+                    </a:lnB>
+                    <a:solidFill>
+                      <a:srgbClr val="F4F6F8"/>
+                    </a:solidFill>
+                  </a:tcPr>
+                </a:tc>
+                <a:tc>
+                  <a:txBody>
+                    <a:bodyPr/>
+                    <a:lstStyle/>
+                    <a:p>
+                      <a:pPr algn="ctr" indent="0" marL="0">
+                        <a:buNone/>
+                      </a:pPr>
+                      <a:r>
+                        <a:rPr lang="en-US" sz="1500" b="1" dirty="0">
+                          <a:solidFill>
+                            <a:srgbClr val="1E7B34"/>
+                          </a:solidFill>
+                          <a:latin typeface="Calibri" pitchFamily="34" charset="0"/>
+                          <a:ea typeface="Calibri" pitchFamily="34" charset="-122"/>
+                          <a:cs typeface="Calibri" pitchFamily="34" charset="-120"/>
+                        </a:rPr>
+                        <a:t>●</a:t>
+                      </a:r>
+                      <a:endParaRPr lang="en-US" sz="1500" dirty="0">
+                        <a:latin typeface="Calibri" charset="0"/>
+                        <a:ea typeface="Calibri" charset="0"/>
+                        <a:cs typeface="Calibri" charset="0"/>
+                      </a:endParaRPr>
+                    </a:p>
+                  </a:txBody>
+                  <a:tcPr marL="76200" marR="76200" marT="25400" marB="25400" anchor="ctr">
+                    <a:lnL w="6350" cap="flat" cmpd="sng" algn="ctr">
+                      <a:solidFill>
+                        <a:srgbClr val="DCE2EA"/>
+                      </a:solidFill>
+                      <a:prstDash val="solid"/>
+                      <a:round/>
+                      <a:headEnd type="none" w="med" len="med"/>
+                      <a:tailEnd type="none" w="med" len="med"/>
+                    </a:lnL>
+                    <a:lnR w="6350" cap="flat" cmpd="sng" algn="ctr">
+                      <a:solidFill>
+                        <a:srgbClr val="DCE2EA"/>
+                      </a:solidFill>
+                      <a:prstDash val="solid"/>
+                      <a:round/>
+                      <a:headEnd type="none" w="med" len="med"/>
+                      <a:tailEnd type="none" w="med" len="med"/>
+                    </a:lnR>
+                    <a:lnT w="6350" cap="flat" cmpd="sng" algn="ctr">
+                      <a:solidFill>
+                        <a:srgbClr val="DCE2EA"/>
+                      </a:solidFill>
+                      <a:prstDash val="solid"/>
+                      <a:round/>
+                      <a:headEnd type="none" w="med" len="med"/>
+                      <a:tailEnd type="none" w="med" len="med"/>
+                    </a:lnT>
+                    <a:lnB w="6350" cap="flat" cmpd="sng" algn="ctr">
+                      <a:solidFill>
+                        <a:srgbClr val="DCE2EA"/>
+                      </a:solidFill>
+                      <a:prstDash val="solid"/>
+                      <a:round/>
+                      <a:headEnd type="none" w="med" len="med"/>
+                      <a:tailEnd type="none" w="med" len="med"/>
+                    </a:lnB>
+                    <a:solidFill>
+                      <a:srgbClr val="F4F6F8"/>
+                    </a:solidFill>
+                  </a:tcPr>
+                </a:tc>
+              </a:tr>
+              <a:tr h="333756">
+                <a:tc>
+                  <a:txBody>
+                    <a:bodyPr/>
+                    <a:lstStyle/>
+                    <a:p>
+                      <a:pPr indent="0" marL="0">
+                        <a:buNone/>
+                      </a:pPr>
+                      <a:r>
+                        <a:rPr lang="en-US" sz="1150" dirty="0">
+                          <a:solidFill>
+                            <a:srgbClr val="1B1D22"/>
+                          </a:solidFill>
+                          <a:latin typeface="Calibri" pitchFamily="34" charset="0"/>
+                          <a:ea typeface="Calibri" pitchFamily="34" charset="-122"/>
+                          <a:cs typeface="Calibri" pitchFamily="34" charset="-120"/>
+                        </a:rPr>
+                        <a:t>Both engines in one window</a:t>
+                      </a:r>
+                      <a:endParaRPr lang="en-US" sz="1150" dirty="0">
+                        <a:latin typeface="Calibri" charset="0"/>
+                        <a:ea typeface="Calibri" charset="0"/>
+                        <a:cs typeface="Calibri" charset="0"/>
+                      </a:endParaRPr>
+                    </a:p>
+                  </a:txBody>
+                  <a:tcPr marL="76200" marR="76200" marT="25400" marB="25400" anchor="ctr">
+                    <a:lnL w="6350" cap="flat" cmpd="sng" algn="ctr">
+                      <a:solidFill>
+                        <a:srgbClr val="DCE2EA"/>
+                      </a:solidFill>
+                      <a:prstDash val="solid"/>
+                      <a:round/>
+                      <a:headEnd type="none" w="med" len="med"/>
+                      <a:tailEnd type="none" w="med" len="med"/>
+                    </a:lnL>
+                    <a:lnR w="6350" cap="flat" cmpd="sng" algn="ctr">
+                      <a:solidFill>
+                        <a:srgbClr val="DCE2EA"/>
+                      </a:solidFill>
+                      <a:prstDash val="solid"/>
+                      <a:round/>
+                      <a:headEnd type="none" w="med" len="med"/>
+                      <a:tailEnd type="none" w="med" len="med"/>
+                    </a:lnR>
+                    <a:lnT w="6350" cap="flat" cmpd="sng" algn="ctr">
+                      <a:solidFill>
+                        <a:srgbClr val="DCE2EA"/>
+                      </a:solidFill>
+                      <a:prstDash val="solid"/>
+                      <a:round/>
+                      <a:headEnd type="none" w="med" len="med"/>
+                      <a:tailEnd type="none" w="med" len="med"/>
+                    </a:lnT>
+                    <a:lnB w="6350" cap="flat" cmpd="sng" algn="ctr">
+                      <a:solidFill>
+                        <a:srgbClr val="DCE2EA"/>
+                      </a:solidFill>
+                      <a:prstDash val="solid"/>
+                      <a:round/>
+                      <a:headEnd type="none" w="med" len="med"/>
+                      <a:tailEnd type="none" w="med" len="med"/>
+                    </a:lnB>
+                    <a:solidFill>
+                      <a:srgbClr val="FFFFFF"/>
+                    </a:solidFill>
+                  </a:tcPr>
+                </a:tc>
+                <a:tc>
+                  <a:txBody>
+                    <a:bodyPr/>
+                    <a:lstStyle/>
+                    <a:p>
+                      <a:pPr algn="ctr" indent="0" marL="0">
+                        <a:buNone/>
+                      </a:pPr>
+                      <a:r>
+                        <a:rPr lang="en-US" sz="1500" b="1" dirty="0">
+                          <a:solidFill>
+                            <a:srgbClr val="1E7B34"/>
+                          </a:solidFill>
+                          <a:latin typeface="Calibri" pitchFamily="34" charset="0"/>
+                          <a:ea typeface="Calibri" pitchFamily="34" charset="-122"/>
+                          <a:cs typeface="Calibri" pitchFamily="34" charset="-120"/>
+                        </a:rPr>
+                        <a:t>●</a:t>
+                      </a:r>
+                      <a:endParaRPr lang="en-US" sz="1500" dirty="0">
+                        <a:latin typeface="Calibri" charset="0"/>
+                        <a:ea typeface="Calibri" charset="0"/>
+                        <a:cs typeface="Calibri" charset="0"/>
+                      </a:endParaRPr>
+                    </a:p>
+                  </a:txBody>
+                  <a:tcPr marL="76200" marR="76200" marT="25400" marB="25400" anchor="ctr">
+                    <a:lnL w="6350" cap="flat" cmpd="sng" algn="ctr">
+                      <a:solidFill>
+                        <a:srgbClr val="DCE2EA"/>
+                      </a:solidFill>
+                      <a:prstDash val="solid"/>
+                      <a:round/>
+                      <a:headEnd type="none" w="med" len="med"/>
+                      <a:tailEnd type="none" w="med" len="med"/>
+                    </a:lnL>
+                    <a:lnR w="6350" cap="flat" cmpd="sng" algn="ctr">
+                      <a:solidFill>
+                        <a:srgbClr val="DCE2EA"/>
+                      </a:solidFill>
+                      <a:prstDash val="solid"/>
+                      <a:round/>
+                      <a:headEnd type="none" w="med" len="med"/>
+                      <a:tailEnd type="none" w="med" len="med"/>
+                    </a:lnR>
+                    <a:lnT w="6350" cap="flat" cmpd="sng" algn="ctr">
+                      <a:solidFill>
+                        <a:srgbClr val="DCE2EA"/>
+                      </a:solidFill>
+                      <a:prstDash val="solid"/>
+                      <a:round/>
+                      <a:headEnd type="none" w="med" len="med"/>
+                      <a:tailEnd type="none" w="med" len="med"/>
+                    </a:lnT>
+                    <a:lnB w="6350" cap="flat" cmpd="sng" algn="ctr">
+                      <a:solidFill>
+                        <a:srgbClr val="DCE2EA"/>
+                      </a:solidFill>
+                      <a:prstDash val="solid"/>
+                      <a:round/>
+                      <a:headEnd type="none" w="med" len="med"/>
+                      <a:tailEnd type="none" w="med" len="med"/>
+                    </a:lnB>
+                    <a:solidFill>
+                      <a:srgbClr val="FFFFFF"/>
+                    </a:solidFill>
+                  </a:tcPr>
+                </a:tc>
+                <a:tc>
+                  <a:txBody>
+                    <a:bodyPr/>
+                    <a:lstStyle/>
+                    <a:p>
+                      <a:pPr algn="ctr" indent="0" marL="0">
+                        <a:buNone/>
+                      </a:pPr>
+                      <a:r>
+                        <a:rPr lang="en-US" sz="1500" b="1" dirty="0">
+                          <a:solidFill>
+                            <a:srgbClr val="9AA3AE"/>
+                          </a:solidFill>
+                          <a:latin typeface="Calibri" pitchFamily="34" charset="0"/>
+                          <a:ea typeface="Calibri" pitchFamily="34" charset="-122"/>
+                          <a:cs typeface="Calibri" pitchFamily="34" charset="-120"/>
+                        </a:rPr>
+                        <a:t>○</a:t>
+                      </a:r>
+                      <a:endParaRPr lang="en-US" sz="1500" dirty="0">
+                        <a:latin typeface="Calibri" charset="0"/>
+                        <a:ea typeface="Calibri" charset="0"/>
+                        <a:cs typeface="Calibri" charset="0"/>
+                      </a:endParaRPr>
+                    </a:p>
+                  </a:txBody>
+                  <a:tcPr marL="76200" marR="76200" marT="25400" marB="25400" anchor="ctr">
+                    <a:lnL w="6350" cap="flat" cmpd="sng" algn="ctr">
+                      <a:solidFill>
+                        <a:srgbClr val="DCE2EA"/>
+                      </a:solidFill>
+                      <a:prstDash val="solid"/>
+                      <a:round/>
+                      <a:headEnd type="none" w="med" len="med"/>
+                      <a:tailEnd type="none" w="med" len="med"/>
+                    </a:lnL>
+                    <a:lnR w="6350" cap="flat" cmpd="sng" algn="ctr">
+                      <a:solidFill>
+                        <a:srgbClr val="DCE2EA"/>
+                      </a:solidFill>
+                      <a:prstDash val="solid"/>
+                      <a:round/>
+                      <a:headEnd type="none" w="med" len="med"/>
+                      <a:tailEnd type="none" w="med" len="med"/>
+                    </a:lnR>
+                    <a:lnT w="6350" cap="flat" cmpd="sng" algn="ctr">
+                      <a:solidFill>
+                        <a:srgbClr val="DCE2EA"/>
+                      </a:solidFill>
+                      <a:prstDash val="solid"/>
+                      <a:round/>
+                      <a:headEnd type="none" w="med" len="med"/>
+                      <a:tailEnd type="none" w="med" len="med"/>
+                    </a:lnT>
+                    <a:lnB w="6350" cap="flat" cmpd="sng" algn="ctr">
+                      <a:solidFill>
+                        <a:srgbClr val="DCE2EA"/>
+                      </a:solidFill>
+                      <a:prstDash val="solid"/>
+                      <a:round/>
+                      <a:headEnd type="none" w="med" len="med"/>
+                      <a:tailEnd type="none" w="med" len="med"/>
+                    </a:lnB>
+                    <a:solidFill>
+                      <a:srgbClr val="FFFFFF"/>
+                    </a:solidFill>
+                  </a:tcPr>
+                </a:tc>
+                <a:tc>
+                  <a:txBody>
+                    <a:bodyPr/>
+                    <a:lstStyle/>
+                    <a:p>
+                      <a:pPr algn="ctr" indent="0" marL="0">
+                        <a:buNone/>
+                      </a:pPr>
+                      <a:r>
+                        <a:rPr lang="en-US" sz="1500" b="1" dirty="0">
+                          <a:solidFill>
+                            <a:srgbClr val="B06000"/>
+                          </a:solidFill>
+                          <a:latin typeface="Calibri" pitchFamily="34" charset="0"/>
+                          <a:ea typeface="Calibri" pitchFamily="34" charset="-122"/>
+                          <a:cs typeface="Calibri" pitchFamily="34" charset="-120"/>
+                        </a:rPr>
+                        <a:t>◐</a:t>
+                      </a:r>
+                      <a:endParaRPr lang="en-US" sz="1500" dirty="0">
+                        <a:latin typeface="Calibri" charset="0"/>
+                        <a:ea typeface="Calibri" charset="0"/>
+                        <a:cs typeface="Calibri" charset="0"/>
+                      </a:endParaRPr>
+                    </a:p>
+                  </a:txBody>
+                  <a:tcPr marL="76200" marR="76200" marT="25400" marB="25400" anchor="ctr">
+                    <a:lnL w="6350" cap="flat" cmpd="sng" algn="ctr">
+                      <a:solidFill>
+                        <a:srgbClr val="DCE2EA"/>
+                      </a:solidFill>
+                      <a:prstDash val="solid"/>
+                      <a:round/>
+                      <a:headEnd type="none" w="med" len="med"/>
+                      <a:tailEnd type="none" w="med" len="med"/>
+                    </a:lnL>
+                    <a:lnR w="6350" cap="flat" cmpd="sng" algn="ctr">
+                      <a:solidFill>
+                        <a:srgbClr val="DCE2EA"/>
+                      </a:solidFill>
+                      <a:prstDash val="solid"/>
+                      <a:round/>
+                      <a:headEnd type="none" w="med" len="med"/>
+                      <a:tailEnd type="none" w="med" len="med"/>
+                    </a:lnR>
+                    <a:lnT w="6350" cap="flat" cmpd="sng" algn="ctr">
+                      <a:solidFill>
+                        <a:srgbClr val="DCE2EA"/>
+                      </a:solidFill>
+                      <a:prstDash val="solid"/>
+                      <a:round/>
+                      <a:headEnd type="none" w="med" len="med"/>
+                      <a:tailEnd type="none" w="med" len="med"/>
+                    </a:lnT>
+                    <a:lnB w="6350" cap="flat" cmpd="sng" algn="ctr">
+                      <a:solidFill>
+                        <a:srgbClr val="DCE2EA"/>
+                      </a:solidFill>
+                      <a:prstDash val="solid"/>
+                      <a:round/>
+                      <a:headEnd type="none" w="med" len="med"/>
+                      <a:tailEnd type="none" w="med" len="med"/>
+                    </a:lnB>
+                    <a:solidFill>
+                      <a:srgbClr val="FFFFFF"/>
+                    </a:solidFill>
+                  </a:tcPr>
+                </a:tc>
+              </a:tr>
+              <a:tr h="333756">
+                <a:tc>
+                  <a:txBody>
+                    <a:bodyPr/>
+                    <a:lstStyle/>
+                    <a:p>
+                      <a:pPr indent="0" marL="0">
+                        <a:buNone/>
+                      </a:pPr>
+                      <a:r>
+                        <a:rPr lang="en-US" sz="1150" dirty="0">
+                          <a:solidFill>
+                            <a:srgbClr val="1B1D22"/>
+                          </a:solidFill>
+                          <a:latin typeface="Calibri" pitchFamily="34" charset="0"/>
+                          <a:ea typeface="Calibri" pitchFamily="34" charset="-122"/>
+                          <a:cs typeface="Calibri" pitchFamily="34" charset="-120"/>
+                        </a:rPr>
+                        <a:t>Nothing to install — no client, no runtime</a:t>
+                      </a:r>
+                      <a:endParaRPr lang="en-US" sz="1150" dirty="0">
+                        <a:latin typeface="Calibri" charset="0"/>
+                        <a:ea typeface="Calibri" charset="0"/>
+                        <a:cs typeface="Calibri" charset="0"/>
+                      </a:endParaRPr>
+                    </a:p>
+                  </a:txBody>
+                  <a:tcPr marL="76200" marR="76200" marT="25400" marB="25400" anchor="ctr">
+                    <a:lnL w="6350" cap="flat" cmpd="sng" algn="ctr">
+                      <a:solidFill>
+                        <a:srgbClr val="DCE2EA"/>
+                      </a:solidFill>
+                      <a:prstDash val="solid"/>
+                      <a:round/>
+                      <a:headEnd type="none" w="med" len="med"/>
+                      <a:tailEnd type="none" w="med" len="med"/>
+                    </a:lnL>
+                    <a:lnR w="6350" cap="flat" cmpd="sng" algn="ctr">
+                      <a:solidFill>
+                        <a:srgbClr val="DCE2EA"/>
+                      </a:solidFill>
+                      <a:prstDash val="solid"/>
+                      <a:round/>
+                      <a:headEnd type="none" w="med" len="med"/>
+                      <a:tailEnd type="none" w="med" len="med"/>
+                    </a:lnR>
+                    <a:lnT w="6350" cap="flat" cmpd="sng" algn="ctr">
+                      <a:solidFill>
+                        <a:srgbClr val="DCE2EA"/>
+                      </a:solidFill>
+                      <a:prstDash val="solid"/>
+                      <a:round/>
+                      <a:headEnd type="none" w="med" len="med"/>
+                      <a:tailEnd type="none" w="med" len="med"/>
+                    </a:lnT>
+                    <a:lnB w="6350" cap="flat" cmpd="sng" algn="ctr">
+                      <a:solidFill>
+                        <a:srgbClr val="DCE2EA"/>
+                      </a:solidFill>
+                      <a:prstDash val="solid"/>
+                      <a:round/>
+                      <a:headEnd type="none" w="med" len="med"/>
+                      <a:tailEnd type="none" w="med" len="med"/>
+                    </a:lnB>
+                    <a:solidFill>
+                      <a:srgbClr val="F4F6F8"/>
+                    </a:solidFill>
+                  </a:tcPr>
+                </a:tc>
+                <a:tc>
+                  <a:txBody>
+                    <a:bodyPr/>
+                    <a:lstStyle/>
+                    <a:p>
+                      <a:pPr algn="ctr" indent="0" marL="0">
+                        <a:buNone/>
+                      </a:pPr>
+                      <a:r>
+                        <a:rPr lang="en-US" sz="1500" b="1" dirty="0">
+                          <a:solidFill>
+                            <a:srgbClr val="1E7B34"/>
+                          </a:solidFill>
+                          <a:latin typeface="Calibri" pitchFamily="34" charset="0"/>
+                          <a:ea typeface="Calibri" pitchFamily="34" charset="-122"/>
+                          <a:cs typeface="Calibri" pitchFamily="34" charset="-120"/>
+                        </a:rPr>
+                        <a:t>●</a:t>
+                      </a:r>
+                      <a:endParaRPr lang="en-US" sz="1500" dirty="0">
+                        <a:latin typeface="Calibri" charset="0"/>
+                        <a:ea typeface="Calibri" charset="0"/>
+                        <a:cs typeface="Calibri" charset="0"/>
+                      </a:endParaRPr>
+                    </a:p>
+                  </a:txBody>
+                  <a:tcPr marL="76200" marR="76200" marT="25400" marB="25400" anchor="ctr">
+                    <a:lnL w="6350" cap="flat" cmpd="sng" algn="ctr">
+                      <a:solidFill>
+                        <a:srgbClr val="DCE2EA"/>
+                      </a:solidFill>
+                      <a:prstDash val="solid"/>
+                      <a:round/>
+                      <a:headEnd type="none" w="med" len="med"/>
+                      <a:tailEnd type="none" w="med" len="med"/>
+                    </a:lnL>
+                    <a:lnR w="6350" cap="flat" cmpd="sng" algn="ctr">
+                      <a:solidFill>
+                        <a:srgbClr val="DCE2EA"/>
+                      </a:solidFill>
+                      <a:prstDash val="solid"/>
+                      <a:round/>
+                      <a:headEnd type="none" w="med" len="med"/>
+                      <a:tailEnd type="none" w="med" len="med"/>
+                    </a:lnR>
+                    <a:lnT w="6350" cap="flat" cmpd="sng" algn="ctr">
+                      <a:solidFill>
+                        <a:srgbClr val="DCE2EA"/>
+                      </a:solidFill>
+                      <a:prstDash val="solid"/>
+                      <a:round/>
+                      <a:headEnd type="none" w="med" len="med"/>
+                      <a:tailEnd type="none" w="med" len="med"/>
+                    </a:lnT>
+                    <a:lnB w="6350" cap="flat" cmpd="sng" algn="ctr">
+                      <a:solidFill>
+                        <a:srgbClr val="DCE2EA"/>
+                      </a:solidFill>
+                      <a:prstDash val="solid"/>
+                      <a:round/>
+                      <a:headEnd type="none" w="med" len="med"/>
+                      <a:tailEnd type="none" w="med" len="med"/>
+                    </a:lnB>
+                    <a:solidFill>
+                      <a:srgbClr val="F4F6F8"/>
+                    </a:solidFill>
+                  </a:tcPr>
+                </a:tc>
+                <a:tc>
+                  <a:txBody>
+                    <a:bodyPr/>
+                    <a:lstStyle/>
+                    <a:p>
+                      <a:pPr algn="ctr" indent="0" marL="0">
+                        <a:buNone/>
+                      </a:pPr>
+                      <a:r>
+                        <a:rPr lang="en-US" sz="1500" b="1" dirty="0">
+                          <a:solidFill>
+                            <a:srgbClr val="9AA3AE"/>
+                          </a:solidFill>
+                          <a:latin typeface="Calibri" pitchFamily="34" charset="0"/>
+                          <a:ea typeface="Calibri" pitchFamily="34" charset="-122"/>
+                          <a:cs typeface="Calibri" pitchFamily="34" charset="-120"/>
+                        </a:rPr>
+                        <a:t>○</a:t>
+                      </a:r>
+                      <a:endParaRPr lang="en-US" sz="1500" dirty="0">
+                        <a:latin typeface="Calibri" charset="0"/>
+                        <a:ea typeface="Calibri" charset="0"/>
+                        <a:cs typeface="Calibri" charset="0"/>
+                      </a:endParaRPr>
+                    </a:p>
+                  </a:txBody>
+                  <a:tcPr marL="76200" marR="76200" marT="25400" marB="25400" anchor="ctr">
+                    <a:lnL w="6350" cap="flat" cmpd="sng" algn="ctr">
+                      <a:solidFill>
+                        <a:srgbClr val="DCE2EA"/>
+                      </a:solidFill>
+                      <a:prstDash val="solid"/>
+                      <a:round/>
+                      <a:headEnd type="none" w="med" len="med"/>
+                      <a:tailEnd type="none" w="med" len="med"/>
+                    </a:lnL>
+                    <a:lnR w="6350" cap="flat" cmpd="sng" algn="ctr">
+                      <a:solidFill>
+                        <a:srgbClr val="DCE2EA"/>
+                      </a:solidFill>
+                      <a:prstDash val="solid"/>
+                      <a:round/>
+                      <a:headEnd type="none" w="med" len="med"/>
+                      <a:tailEnd type="none" w="med" len="med"/>
+                    </a:lnR>
+                    <a:lnT w="6350" cap="flat" cmpd="sng" algn="ctr">
+                      <a:solidFill>
+                        <a:srgbClr val="DCE2EA"/>
+                      </a:solidFill>
+                      <a:prstDash val="solid"/>
+                      <a:round/>
+                      <a:headEnd type="none" w="med" len="med"/>
+                      <a:tailEnd type="none" w="med" len="med"/>
+                    </a:lnT>
+                    <a:lnB w="6350" cap="flat" cmpd="sng" algn="ctr">
+                      <a:solidFill>
+                        <a:srgbClr val="DCE2EA"/>
+                      </a:solidFill>
+                      <a:prstDash val="solid"/>
+                      <a:round/>
+                      <a:headEnd type="none" w="med" len="med"/>
+                      <a:tailEnd type="none" w="med" len="med"/>
+                    </a:lnB>
+                    <a:solidFill>
+                      <a:srgbClr val="F4F6F8"/>
+                    </a:solidFill>
+                  </a:tcPr>
+                </a:tc>
+                <a:tc>
+                  <a:txBody>
+                    <a:bodyPr/>
+                    <a:lstStyle/>
+                    <a:p>
+                      <a:pPr algn="ctr" indent="0" marL="0">
+                        <a:buNone/>
+                      </a:pPr>
+                      <a:r>
+                        <a:rPr lang="en-US" sz="1500" b="1" dirty="0">
+                          <a:solidFill>
+                            <a:srgbClr val="9AA3AE"/>
+                          </a:solidFill>
+                          <a:latin typeface="Calibri" pitchFamily="34" charset="0"/>
+                          <a:ea typeface="Calibri" pitchFamily="34" charset="-122"/>
+                          <a:cs typeface="Calibri" pitchFamily="34" charset="-120"/>
+                        </a:rPr>
+                        <a:t>○</a:t>
+                      </a:r>
+                      <a:endParaRPr lang="en-US" sz="1500" dirty="0">
+                        <a:latin typeface="Calibri" charset="0"/>
+                        <a:ea typeface="Calibri" charset="0"/>
+                        <a:cs typeface="Calibri" charset="0"/>
+                      </a:endParaRPr>
+                    </a:p>
+                  </a:txBody>
+                  <a:tcPr marL="76200" marR="76200" marT="25400" marB="25400" anchor="ctr">
+                    <a:lnL w="6350" cap="flat" cmpd="sng" algn="ctr">
+                      <a:solidFill>
+                        <a:srgbClr val="DCE2EA"/>
+                      </a:solidFill>
+                      <a:prstDash val="solid"/>
+                      <a:round/>
+                      <a:headEnd type="none" w="med" len="med"/>
+                      <a:tailEnd type="none" w="med" len="med"/>
+                    </a:lnL>
+                    <a:lnR w="6350" cap="flat" cmpd="sng" algn="ctr">
+                      <a:solidFill>
+                        <a:srgbClr val="DCE2EA"/>
+                      </a:solidFill>
+                      <a:prstDash val="solid"/>
+                      <a:round/>
+                      <a:headEnd type="none" w="med" len="med"/>
+                      <a:tailEnd type="none" w="med" len="med"/>
+                    </a:lnR>
+                    <a:lnT w="6350" cap="flat" cmpd="sng" algn="ctr">
+                      <a:solidFill>
+                        <a:srgbClr val="DCE2EA"/>
+                      </a:solidFill>
+                      <a:prstDash val="solid"/>
+                      <a:round/>
+                      <a:headEnd type="none" w="med" len="med"/>
+                      <a:tailEnd type="none" w="med" len="med"/>
+                    </a:lnT>
+                    <a:lnB w="6350" cap="flat" cmpd="sng" algn="ctr">
+                      <a:solidFill>
+                        <a:srgbClr val="DCE2EA"/>
+                      </a:solidFill>
+                      <a:prstDash val="solid"/>
+                      <a:round/>
+                      <a:headEnd type="none" w="med" len="med"/>
+                      <a:tailEnd type="none" w="med" len="med"/>
+                    </a:lnB>
+                    <a:solidFill>
+                      <a:srgbClr val="F4F6F8"/>
+                    </a:solidFill>
+                  </a:tcPr>
+                </a:tc>
+              </a:tr>
+              <a:tr h="333756">
+                <a:tc>
+                  <a:txBody>
+                    <a:bodyPr/>
+                    <a:lstStyle/>
+                    <a:p>
+                      <a:pPr indent="0" marL="0">
+                        <a:buNone/>
+                      </a:pPr>
+                      <a:r>
+                        <a:rPr lang="en-US" sz="1150" dirty="0">
+                          <a:solidFill>
+                            <a:srgbClr val="1B1D22"/>
+                          </a:solidFill>
+                          <a:latin typeface="Calibri" pitchFamily="34" charset="0"/>
+                          <a:ea typeface="Calibri" pitchFamily="34" charset="-122"/>
+                          <a:cs typeface="Calibri" pitchFamily="34" charset="-120"/>
+                        </a:rPr>
+                        <a:t>Editor, completion, grid and text results</a:t>
+                      </a:r>
+                      <a:endParaRPr lang="en-US" sz="1150" dirty="0">
+                        <a:latin typeface="Calibri" charset="0"/>
+                        <a:ea typeface="Calibri" charset="0"/>
+                        <a:cs typeface="Calibri" charset="0"/>
+                      </a:endParaRPr>
+                    </a:p>
+                  </a:txBody>
+                  <a:tcPr marL="76200" marR="76200" marT="25400" marB="25400" anchor="ctr">
+                    <a:lnL w="6350" cap="flat" cmpd="sng" algn="ctr">
+                      <a:solidFill>
+                        <a:srgbClr val="DCE2EA"/>
+                      </a:solidFill>
+                      <a:prstDash val="solid"/>
+                      <a:round/>
+                      <a:headEnd type="none" w="med" len="med"/>
+                      <a:tailEnd type="none" w="med" len="med"/>
+                    </a:lnL>
+                    <a:lnR w="6350" cap="flat" cmpd="sng" algn="ctr">
+                      <a:solidFill>
+                        <a:srgbClr val="DCE2EA"/>
+                      </a:solidFill>
+                      <a:prstDash val="solid"/>
+                      <a:round/>
+                      <a:headEnd type="none" w="med" len="med"/>
+                      <a:tailEnd type="none" w="med" len="med"/>
+                    </a:lnR>
+                    <a:lnT w="6350" cap="flat" cmpd="sng" algn="ctr">
+                      <a:solidFill>
+                        <a:srgbClr val="DCE2EA"/>
+                      </a:solidFill>
+                      <a:prstDash val="solid"/>
+                      <a:round/>
+                      <a:headEnd type="none" w="med" len="med"/>
+                      <a:tailEnd type="none" w="med" len="med"/>
+                    </a:lnT>
+                    <a:lnB w="6350" cap="flat" cmpd="sng" algn="ctr">
+                      <a:solidFill>
+                        <a:srgbClr val="DCE2EA"/>
+                      </a:solidFill>
+                      <a:prstDash val="solid"/>
+                      <a:round/>
+                      <a:headEnd type="none" w="med" len="med"/>
+                      <a:tailEnd type="none" w="med" len="med"/>
+                    </a:lnB>
+                    <a:solidFill>
+                      <a:srgbClr val="FFFFFF"/>
+                    </a:solidFill>
+                  </a:tcPr>
+                </a:tc>
+                <a:tc>
+                  <a:txBody>
+                    <a:bodyPr/>
+                    <a:lstStyle/>
+                    <a:p>
+                      <a:pPr algn="ctr" indent="0" marL="0">
+                        <a:buNone/>
+                      </a:pPr>
+                      <a:r>
+                        <a:rPr lang="en-US" sz="1500" b="1" dirty="0">
+                          <a:solidFill>
+                            <a:srgbClr val="1E7B34"/>
+                          </a:solidFill>
+                          <a:latin typeface="Calibri" pitchFamily="34" charset="0"/>
+                          <a:ea typeface="Calibri" pitchFamily="34" charset="-122"/>
+                          <a:cs typeface="Calibri" pitchFamily="34" charset="-120"/>
+                        </a:rPr>
+                        <a:t>●</a:t>
+                      </a:r>
+                      <a:endParaRPr lang="en-US" sz="1500" dirty="0">
+                        <a:latin typeface="Calibri" charset="0"/>
+                        <a:ea typeface="Calibri" charset="0"/>
+                        <a:cs typeface="Calibri" charset="0"/>
+                      </a:endParaRPr>
+                    </a:p>
+                  </a:txBody>
+                  <a:tcPr marL="76200" marR="76200" marT="25400" marB="25400" anchor="ctr">
+                    <a:lnL w="6350" cap="flat" cmpd="sng" algn="ctr">
+                      <a:solidFill>
+                        <a:srgbClr val="DCE2EA"/>
+                      </a:solidFill>
+                      <a:prstDash val="solid"/>
+                      <a:round/>
+                      <a:headEnd type="none" w="med" len="med"/>
+                      <a:tailEnd type="none" w="med" len="med"/>
+                    </a:lnL>
+                    <a:lnR w="6350" cap="flat" cmpd="sng" algn="ctr">
+                      <a:solidFill>
+                        <a:srgbClr val="DCE2EA"/>
+                      </a:solidFill>
+                      <a:prstDash val="solid"/>
+                      <a:round/>
+                      <a:headEnd type="none" w="med" len="med"/>
+                      <a:tailEnd type="none" w="med" len="med"/>
+                    </a:lnR>
+                    <a:lnT w="6350" cap="flat" cmpd="sng" algn="ctr">
+                      <a:solidFill>
+                        <a:srgbClr val="DCE2EA"/>
+                      </a:solidFill>
+                      <a:prstDash val="solid"/>
+                      <a:round/>
+                      <a:headEnd type="none" w="med" len="med"/>
+                      <a:tailEnd type="none" w="med" len="med"/>
+                    </a:lnT>
+                    <a:lnB w="6350" cap="flat" cmpd="sng" algn="ctr">
+                      <a:solidFill>
+                        <a:srgbClr val="DCE2EA"/>
+                      </a:solidFill>
+                      <a:prstDash val="solid"/>
+                      <a:round/>
+                      <a:headEnd type="none" w="med" len="med"/>
+                      <a:tailEnd type="none" w="med" len="med"/>
+                    </a:lnB>
+                    <a:solidFill>
+                      <a:srgbClr val="FFFFFF"/>
+                    </a:solidFill>
+                  </a:tcPr>
+                </a:tc>
+                <a:tc>
+                  <a:txBody>
+                    <a:bodyPr/>
+                    <a:lstStyle/>
+                    <a:p>
+                      <a:pPr algn="ctr" indent="0" marL="0">
+                        <a:buNone/>
+                      </a:pPr>
+                      <a:r>
+                        <a:rPr lang="en-US" sz="1500" b="1" dirty="0">
+                          <a:solidFill>
+                            <a:srgbClr val="1E7B34"/>
+                          </a:solidFill>
+                          <a:latin typeface="Calibri" pitchFamily="34" charset="0"/>
+                          <a:ea typeface="Calibri" pitchFamily="34" charset="-122"/>
+                          <a:cs typeface="Calibri" pitchFamily="34" charset="-120"/>
+                        </a:rPr>
+                        <a:t>●</a:t>
+                      </a:r>
+                      <a:endParaRPr lang="en-US" sz="1500" dirty="0">
+                        <a:latin typeface="Calibri" charset="0"/>
+                        <a:ea typeface="Calibri" charset="0"/>
+                        <a:cs typeface="Calibri" charset="0"/>
+                      </a:endParaRPr>
+                    </a:p>
+                  </a:txBody>
+                  <a:tcPr marL="76200" marR="76200" marT="25400" marB="25400" anchor="ctr">
+                    <a:lnL w="6350" cap="flat" cmpd="sng" algn="ctr">
+                      <a:solidFill>
+                        <a:srgbClr val="DCE2EA"/>
+                      </a:solidFill>
+                      <a:prstDash val="solid"/>
+                      <a:round/>
+                      <a:headEnd type="none" w="med" len="med"/>
+                      <a:tailEnd type="none" w="med" len="med"/>
+                    </a:lnL>
+                    <a:lnR w="6350" cap="flat" cmpd="sng" algn="ctr">
+                      <a:solidFill>
+                        <a:srgbClr val="DCE2EA"/>
+                      </a:solidFill>
+                      <a:prstDash val="solid"/>
+                      <a:round/>
+                      <a:headEnd type="none" w="med" len="med"/>
+                      <a:tailEnd type="none" w="med" len="med"/>
+                    </a:lnR>
+                    <a:lnT w="6350" cap="flat" cmpd="sng" algn="ctr">
+                      <a:solidFill>
+                        <a:srgbClr val="DCE2EA"/>
+                      </a:solidFill>
+                      <a:prstDash val="solid"/>
+                      <a:round/>
+                      <a:headEnd type="none" w="med" len="med"/>
+                      <a:tailEnd type="none" w="med" len="med"/>
+                    </a:lnT>
+                    <a:lnB w="6350" cap="flat" cmpd="sng" algn="ctr">
+                      <a:solidFill>
+                        <a:srgbClr val="DCE2EA"/>
+                      </a:solidFill>
+                      <a:prstDash val="solid"/>
+                      <a:round/>
+                      <a:headEnd type="none" w="med" len="med"/>
+                      <a:tailEnd type="none" w="med" len="med"/>
+                    </a:lnB>
+                    <a:solidFill>
+                      <a:srgbClr val="FFFFFF"/>
+                    </a:solidFill>
+                  </a:tcPr>
+                </a:tc>
+                <a:tc>
+                  <a:txBody>
+                    <a:bodyPr/>
+                    <a:lstStyle/>
+                    <a:p>
+                      <a:pPr algn="ctr" indent="0" marL="0">
+                        <a:buNone/>
+                      </a:pPr>
+                      <a:r>
+                        <a:rPr lang="en-US" sz="1500" b="1" dirty="0">
+                          <a:solidFill>
+                            <a:srgbClr val="1E7B34"/>
+                          </a:solidFill>
+                          <a:latin typeface="Calibri" pitchFamily="34" charset="0"/>
+                          <a:ea typeface="Calibri" pitchFamily="34" charset="-122"/>
+                          <a:cs typeface="Calibri" pitchFamily="34" charset="-120"/>
+                        </a:rPr>
+                        <a:t>●</a:t>
+                      </a:r>
+                      <a:endParaRPr lang="en-US" sz="1500" dirty="0">
+                        <a:latin typeface="Calibri" charset="0"/>
+                        <a:ea typeface="Calibri" charset="0"/>
+                        <a:cs typeface="Calibri" charset="0"/>
+                      </a:endParaRPr>
+                    </a:p>
+                  </a:txBody>
+                  <a:tcPr marL="76200" marR="76200" marT="25400" marB="25400" anchor="ctr">
+                    <a:lnL w="6350" cap="flat" cmpd="sng" algn="ctr">
+                      <a:solidFill>
+                        <a:srgbClr val="DCE2EA"/>
+                      </a:solidFill>
+                      <a:prstDash val="solid"/>
+                      <a:round/>
+                      <a:headEnd type="none" w="med" len="med"/>
+                      <a:tailEnd type="none" w="med" len="med"/>
+                    </a:lnL>
+                    <a:lnR w="6350" cap="flat" cmpd="sng" algn="ctr">
+                      <a:solidFill>
+                        <a:srgbClr val="DCE2EA"/>
+                      </a:solidFill>
+                      <a:prstDash val="solid"/>
+                      <a:round/>
+                      <a:headEnd type="none" w="med" len="med"/>
+                      <a:tailEnd type="none" w="med" len="med"/>
+                    </a:lnR>
+                    <a:lnT w="6350" cap="flat" cmpd="sng" algn="ctr">
+                      <a:solidFill>
+                        <a:srgbClr val="DCE2EA"/>
+                      </a:solidFill>
+                      <a:prstDash val="solid"/>
+                      <a:round/>
+                      <a:headEnd type="none" w="med" len="med"/>
+                      <a:tailEnd type="none" w="med" len="med"/>
+                    </a:lnT>
+                    <a:lnB w="6350" cap="flat" cmpd="sng" algn="ctr">
+                      <a:solidFill>
+                        <a:srgbClr val="DCE2EA"/>
+                      </a:solidFill>
+                      <a:prstDash val="solid"/>
+                      <a:round/>
+                      <a:headEnd type="none" w="med" len="med"/>
+                      <a:tailEnd type="none" w="med" len="med"/>
+                    </a:lnB>
+                    <a:solidFill>
+                      <a:srgbClr val="FFFFFF"/>
+                    </a:solidFill>
+                  </a:tcPr>
+                </a:tc>
+              </a:tr>
+              <a:tr h="333756">
+                <a:tc>
+                  <a:txBody>
+                    <a:bodyPr/>
+                    <a:lstStyle/>
+                    <a:p>
+                      <a:pPr indent="0" marL="0">
+                        <a:buNone/>
+                      </a:pPr>
+                      <a:r>
+                        <a:rPr lang="en-US" sz="1150" dirty="0">
+                          <a:solidFill>
+                            <a:srgbClr val="1B1D22"/>
+                          </a:solidFill>
+                          <a:latin typeface="Calibri" pitchFamily="34" charset="0"/>
+                          <a:ea typeface="Calibri" pitchFamily="34" charset="-122"/>
+                          <a:cs typeface="Calibri" pitchFamily="34" charset="-120"/>
+                        </a:rPr>
+                        <a:t>Editable data grid</a:t>
+                      </a:r>
+                      <a:endParaRPr lang="en-US" sz="1150" dirty="0">
+                        <a:latin typeface="Calibri" charset="0"/>
+                        <a:ea typeface="Calibri" charset="0"/>
+                        <a:cs typeface="Calibri" charset="0"/>
+                      </a:endParaRPr>
+                    </a:p>
+                  </a:txBody>
+                  <a:tcPr marL="76200" marR="76200" marT="25400" marB="25400" anchor="ctr">
+                    <a:lnL w="6350" cap="flat" cmpd="sng" algn="ctr">
+                      <a:solidFill>
+                        <a:srgbClr val="DCE2EA"/>
+                      </a:solidFill>
+                      <a:prstDash val="solid"/>
+                      <a:round/>
+                      <a:headEnd type="none" w="med" len="med"/>
+                      <a:tailEnd type="none" w="med" len="med"/>
+                    </a:lnL>
+                    <a:lnR w="6350" cap="flat" cmpd="sng" algn="ctr">
+                      <a:solidFill>
+                        <a:srgbClr val="DCE2EA"/>
+                      </a:solidFill>
+                      <a:prstDash val="solid"/>
+                      <a:round/>
+                      <a:headEnd type="none" w="med" len="med"/>
+                      <a:tailEnd type="none" w="med" len="med"/>
+                    </a:lnR>
+                    <a:lnT w="6350" cap="flat" cmpd="sng" algn="ctr">
+                      <a:solidFill>
+                        <a:srgbClr val="DCE2EA"/>
+                      </a:solidFill>
+                      <a:prstDash val="solid"/>
+                      <a:round/>
+                      <a:headEnd type="none" w="med" len="med"/>
+                      <a:tailEnd type="none" w="med" len="med"/>
+                    </a:lnT>
+                    <a:lnB w="6350" cap="flat" cmpd="sng" algn="ctr">
+                      <a:solidFill>
+                        <a:srgbClr val="DCE2EA"/>
+                      </a:solidFill>
+                      <a:prstDash val="solid"/>
+                      <a:round/>
+                      <a:headEnd type="none" w="med" len="med"/>
+                      <a:tailEnd type="none" w="med" len="med"/>
+                    </a:lnB>
+                    <a:solidFill>
+                      <a:srgbClr val="F4F6F8"/>
+                    </a:solidFill>
+                  </a:tcPr>
+                </a:tc>
+                <a:tc>
+                  <a:txBody>
+                    <a:bodyPr/>
+                    <a:lstStyle/>
+                    <a:p>
+                      <a:pPr algn="ctr" indent="0" marL="0">
+                        <a:buNone/>
+                      </a:pPr>
+                      <a:r>
+                        <a:rPr lang="en-US" sz="1500" b="1" dirty="0">
+                          <a:solidFill>
+                            <a:srgbClr val="1E7B34"/>
+                          </a:solidFill>
+                          <a:latin typeface="Calibri" pitchFamily="34" charset="0"/>
+                          <a:ea typeface="Calibri" pitchFamily="34" charset="-122"/>
+                          <a:cs typeface="Calibri" pitchFamily="34" charset="-120"/>
+                        </a:rPr>
+                        <a:t>●</a:t>
+                      </a:r>
+                      <a:endParaRPr lang="en-US" sz="1500" dirty="0">
+                        <a:latin typeface="Calibri" charset="0"/>
+                        <a:ea typeface="Calibri" charset="0"/>
+                        <a:cs typeface="Calibri" charset="0"/>
+                      </a:endParaRPr>
+                    </a:p>
+                  </a:txBody>
+                  <a:tcPr marL="76200" marR="76200" marT="25400" marB="25400" anchor="ctr">
+                    <a:lnL w="6350" cap="flat" cmpd="sng" algn="ctr">
+                      <a:solidFill>
+                        <a:srgbClr val="DCE2EA"/>
+                      </a:solidFill>
+                      <a:prstDash val="solid"/>
+                      <a:round/>
+                      <a:headEnd type="none" w="med" len="med"/>
+                      <a:tailEnd type="none" w="med" len="med"/>
+                    </a:lnL>
+                    <a:lnR w="6350" cap="flat" cmpd="sng" algn="ctr">
+                      <a:solidFill>
+                        <a:srgbClr val="DCE2EA"/>
+                      </a:solidFill>
+                      <a:prstDash val="solid"/>
+                      <a:round/>
+                      <a:headEnd type="none" w="med" len="med"/>
+                      <a:tailEnd type="none" w="med" len="med"/>
+                    </a:lnR>
+                    <a:lnT w="6350" cap="flat" cmpd="sng" algn="ctr">
+                      <a:solidFill>
+                        <a:srgbClr val="DCE2EA"/>
+                      </a:solidFill>
+                      <a:prstDash val="solid"/>
+                      <a:round/>
+                      <a:headEnd type="none" w="med" len="med"/>
+                      <a:tailEnd type="none" w="med" len="med"/>
+                    </a:lnT>
+                    <a:lnB w="6350" cap="flat" cmpd="sng" algn="ctr">
+                      <a:solidFill>
+                        <a:srgbClr val="DCE2EA"/>
+                      </a:solidFill>
+                      <a:prstDash val="solid"/>
+                      <a:round/>
+                      <a:headEnd type="none" w="med" len="med"/>
+                      <a:tailEnd type="none" w="med" len="med"/>
+                    </a:lnB>
+                    <a:solidFill>
+                      <a:srgbClr val="F4F6F8"/>
+                    </a:solidFill>
+                  </a:tcPr>
+                </a:tc>
+                <a:tc>
+                  <a:txBody>
+                    <a:bodyPr/>
+                    <a:lstStyle/>
+                    <a:p>
+                      <a:pPr algn="ctr" indent="0" marL="0">
+                        <a:buNone/>
+                      </a:pPr>
+                      <a:r>
+                        <a:rPr lang="en-US" sz="1500" b="1" dirty="0">
+                          <a:solidFill>
+                            <a:srgbClr val="B06000"/>
+                          </a:solidFill>
+                          <a:latin typeface="Calibri" pitchFamily="34" charset="0"/>
+                          <a:ea typeface="Calibri" pitchFamily="34" charset="-122"/>
+                          <a:cs typeface="Calibri" pitchFamily="34" charset="-120"/>
+                        </a:rPr>
+                        <a:t>◐</a:t>
+                      </a:r>
+                      <a:endParaRPr lang="en-US" sz="1500" dirty="0">
+                        <a:latin typeface="Calibri" charset="0"/>
+                        <a:ea typeface="Calibri" charset="0"/>
+                        <a:cs typeface="Calibri" charset="0"/>
+                      </a:endParaRPr>
+                    </a:p>
+                  </a:txBody>
+                  <a:tcPr marL="76200" marR="76200" marT="25400" marB="25400" anchor="ctr">
+                    <a:lnL w="6350" cap="flat" cmpd="sng" algn="ctr">
+                      <a:solidFill>
+                        <a:srgbClr val="DCE2EA"/>
+                      </a:solidFill>
+                      <a:prstDash val="solid"/>
+                      <a:round/>
+                      <a:headEnd type="none" w="med" len="med"/>
+                      <a:tailEnd type="none" w="med" len="med"/>
+                    </a:lnL>
+                    <a:lnR w="6350" cap="flat" cmpd="sng" algn="ctr">
+                      <a:solidFill>
+                        <a:srgbClr val="DCE2EA"/>
+                      </a:solidFill>
+                      <a:prstDash val="solid"/>
+                      <a:round/>
+                      <a:headEnd type="none" w="med" len="med"/>
+                      <a:tailEnd type="none" w="med" len="med"/>
+                    </a:lnR>
+                    <a:lnT w="6350" cap="flat" cmpd="sng" algn="ctr">
+                      <a:solidFill>
+                        <a:srgbClr val="DCE2EA"/>
+                      </a:solidFill>
+                      <a:prstDash val="solid"/>
+                      <a:round/>
+                      <a:headEnd type="none" w="med" len="med"/>
+                      <a:tailEnd type="none" w="med" len="med"/>
+                    </a:lnT>
+                    <a:lnB w="6350" cap="flat" cmpd="sng" algn="ctr">
+                      <a:solidFill>
+                        <a:srgbClr val="DCE2EA"/>
+                      </a:solidFill>
+                      <a:prstDash val="solid"/>
+                      <a:round/>
+                      <a:headEnd type="none" w="med" len="med"/>
+                      <a:tailEnd type="none" w="med" len="med"/>
+                    </a:lnB>
+                    <a:solidFill>
+                      <a:srgbClr val="F4F6F8"/>
+                    </a:solidFill>
+                  </a:tcPr>
+                </a:tc>
+                <a:tc>
+                  <a:txBody>
+                    <a:bodyPr/>
+                    <a:lstStyle/>
+                    <a:p>
+                      <a:pPr algn="ctr" indent="0" marL="0">
+                        <a:buNone/>
+                      </a:pPr>
+                      <a:r>
+                        <a:rPr lang="en-US" sz="1500" b="1" dirty="0">
+                          <a:solidFill>
+                            <a:srgbClr val="1E7B34"/>
+                          </a:solidFill>
+                          <a:latin typeface="Calibri" pitchFamily="34" charset="0"/>
+                          <a:ea typeface="Calibri" pitchFamily="34" charset="-122"/>
+                          <a:cs typeface="Calibri" pitchFamily="34" charset="-120"/>
+                        </a:rPr>
+                        <a:t>●</a:t>
+                      </a:r>
+                      <a:endParaRPr lang="en-US" sz="1500" dirty="0">
+                        <a:latin typeface="Calibri" charset="0"/>
+                        <a:ea typeface="Calibri" charset="0"/>
+                        <a:cs typeface="Calibri" charset="0"/>
+                      </a:endParaRPr>
+                    </a:p>
+                  </a:txBody>
+                  <a:tcPr marL="76200" marR="76200" marT="25400" marB="25400" anchor="ctr">
+                    <a:lnL w="6350" cap="flat" cmpd="sng" algn="ctr">
+                      <a:solidFill>
+                        <a:srgbClr val="DCE2EA"/>
+                      </a:solidFill>
+                      <a:prstDash val="solid"/>
+                      <a:round/>
+                      <a:headEnd type="none" w="med" len="med"/>
+                      <a:tailEnd type="none" w="med" len="med"/>
+                    </a:lnL>
+                    <a:lnR w="6350" cap="flat" cmpd="sng" algn="ctr">
+                      <a:solidFill>
+                        <a:srgbClr val="DCE2EA"/>
+                      </a:solidFill>
+                      <a:prstDash val="solid"/>
+                      <a:round/>
+                      <a:headEnd type="none" w="med" len="med"/>
+                      <a:tailEnd type="none" w="med" len="med"/>
+                    </a:lnR>
+                    <a:lnT w="6350" cap="flat" cmpd="sng" algn="ctr">
+                      <a:solidFill>
+                        <a:srgbClr val="DCE2EA"/>
+                      </a:solidFill>
+                      <a:prstDash val="solid"/>
+                      <a:round/>
+                      <a:headEnd type="none" w="med" len="med"/>
+                      <a:tailEnd type="none" w="med" len="med"/>
+                    </a:lnT>
+                    <a:lnB w="6350" cap="flat" cmpd="sng" algn="ctr">
+                      <a:solidFill>
+                        <a:srgbClr val="DCE2EA"/>
+                      </a:solidFill>
+                      <a:prstDash val="solid"/>
+                      <a:round/>
+                      <a:headEnd type="none" w="med" len="med"/>
+                      <a:tailEnd type="none" w="med" len="med"/>
+                    </a:lnB>
+                    <a:solidFill>
+                      <a:srgbClr val="F4F6F8"/>
+                    </a:solidFill>
+                  </a:tcPr>
+                </a:tc>
+              </a:tr>
+              <a:tr h="333756">
+                <a:tc>
+                  <a:txBody>
+                    <a:bodyPr/>
+                    <a:lstStyle/>
+                    <a:p>
+                      <a:pPr indent="0" marL="0">
+                        <a:buNone/>
+                      </a:pPr>
+                      <a:r>
+                        <a:rPr lang="en-US" sz="1150" dirty="0">
+                          <a:solidFill>
+                            <a:srgbClr val="1B1D22"/>
+                          </a:solidFill>
+                          <a:latin typeface="Calibri" pitchFamily="34" charset="0"/>
+                          <a:ea typeface="Calibri" pitchFamily="34" charset="-122"/>
+                          <a:cs typeface="Calibri" pitchFamily="34" charset="-120"/>
+                        </a:rPr>
+                        <a:t>Table details in a single tab</a:t>
+                      </a:r>
+                      <a:endParaRPr lang="en-US" sz="1150" dirty="0">
+                        <a:latin typeface="Calibri" charset="0"/>
+                        <a:ea typeface="Calibri" charset="0"/>
+                        <a:cs typeface="Calibri" charset="0"/>
+                      </a:endParaRPr>
+                    </a:p>
+                  </a:txBody>
+                  <a:tcPr marL="76200" marR="76200" marT="25400" marB="25400" anchor="ctr">
+                    <a:lnL w="6350" cap="flat" cmpd="sng" algn="ctr">
+                      <a:solidFill>
+                        <a:srgbClr val="DCE2EA"/>
+                      </a:solidFill>
+                      <a:prstDash val="solid"/>
+                      <a:round/>
+                      <a:headEnd type="none" w="med" len="med"/>
+                      <a:tailEnd type="none" w="med" len="med"/>
+                    </a:lnL>
+                    <a:lnR w="6350" cap="flat" cmpd="sng" algn="ctr">
+                      <a:solidFill>
+                        <a:srgbClr val="DCE2EA"/>
+                      </a:solidFill>
+                      <a:prstDash val="solid"/>
+                      <a:round/>
+                      <a:headEnd type="none" w="med" len="med"/>
+                      <a:tailEnd type="none" w="med" len="med"/>
+                    </a:lnR>
+                    <a:lnT w="6350" cap="flat" cmpd="sng" algn="ctr">
+                      <a:solidFill>
+                        <a:srgbClr val="DCE2EA"/>
+                      </a:solidFill>
+                      <a:prstDash val="solid"/>
+                      <a:round/>
+                      <a:headEnd type="none" w="med" len="med"/>
+                      <a:tailEnd type="none" w="med" len="med"/>
+                    </a:lnT>
+                    <a:lnB w="6350" cap="flat" cmpd="sng" algn="ctr">
+                      <a:solidFill>
+                        <a:srgbClr val="DCE2EA"/>
+                      </a:solidFill>
+                      <a:prstDash val="solid"/>
+                      <a:round/>
+                      <a:headEnd type="none" w="med" len="med"/>
+                      <a:tailEnd type="none" w="med" len="med"/>
+                    </a:lnB>
+                    <a:solidFill>
+                      <a:srgbClr val="FFFFFF"/>
+                    </a:solidFill>
+                  </a:tcPr>
+                </a:tc>
+                <a:tc>
+                  <a:txBody>
+                    <a:bodyPr/>
+                    <a:lstStyle/>
+                    <a:p>
+                      <a:pPr algn="ctr" indent="0" marL="0">
+                        <a:buNone/>
+                      </a:pPr>
+                      <a:r>
+                        <a:rPr lang="en-US" sz="1500" b="1" dirty="0">
+                          <a:solidFill>
+                            <a:srgbClr val="1E7B34"/>
+                          </a:solidFill>
+                          <a:latin typeface="Calibri" pitchFamily="34" charset="0"/>
+                          <a:ea typeface="Calibri" pitchFamily="34" charset="-122"/>
+                          <a:cs typeface="Calibri" pitchFamily="34" charset="-120"/>
+                        </a:rPr>
+                        <a:t>●</a:t>
+                      </a:r>
+                      <a:endParaRPr lang="en-US" sz="1500" dirty="0">
+                        <a:latin typeface="Calibri" charset="0"/>
+                        <a:ea typeface="Calibri" charset="0"/>
+                        <a:cs typeface="Calibri" charset="0"/>
+                      </a:endParaRPr>
+                    </a:p>
+                  </a:txBody>
+                  <a:tcPr marL="76200" marR="76200" marT="25400" marB="25400" anchor="ctr">
+                    <a:lnL w="6350" cap="flat" cmpd="sng" algn="ctr">
+                      <a:solidFill>
+                        <a:srgbClr val="DCE2EA"/>
+                      </a:solidFill>
+                      <a:prstDash val="solid"/>
+                      <a:round/>
+                      <a:headEnd type="none" w="med" len="med"/>
+                      <a:tailEnd type="none" w="med" len="med"/>
+                    </a:lnL>
+                    <a:lnR w="6350" cap="flat" cmpd="sng" algn="ctr">
+                      <a:solidFill>
+                        <a:srgbClr val="DCE2EA"/>
+                      </a:solidFill>
+                      <a:prstDash val="solid"/>
+                      <a:round/>
+                      <a:headEnd type="none" w="med" len="med"/>
+                      <a:tailEnd type="none" w="med" len="med"/>
+                    </a:lnR>
+                    <a:lnT w="6350" cap="flat" cmpd="sng" algn="ctr">
+                      <a:solidFill>
+                        <a:srgbClr val="DCE2EA"/>
+                      </a:solidFill>
+                      <a:prstDash val="solid"/>
+                      <a:round/>
+                      <a:headEnd type="none" w="med" len="med"/>
+                      <a:tailEnd type="none" w="med" len="med"/>
+                    </a:lnT>
+                    <a:lnB w="6350" cap="flat" cmpd="sng" algn="ctr">
+                      <a:solidFill>
+                        <a:srgbClr val="DCE2EA"/>
+                      </a:solidFill>
+                      <a:prstDash val="solid"/>
+                      <a:round/>
+                      <a:headEnd type="none" w="med" len="med"/>
+                      <a:tailEnd type="none" w="med" len="med"/>
+                    </a:lnB>
+                    <a:solidFill>
+                      <a:srgbClr val="FFFFFF"/>
+                    </a:solidFill>
+                  </a:tcPr>
+                </a:tc>
+                <a:tc>
+                  <a:txBody>
+                    <a:bodyPr/>
+                    <a:lstStyle/>
+                    <a:p>
+                      <a:pPr algn="ctr" indent="0" marL="0">
+                        <a:buNone/>
+                      </a:pPr>
+                      <a:r>
+                        <a:rPr lang="en-US" sz="1500" b="1" dirty="0">
+                          <a:solidFill>
+                            <a:srgbClr val="B06000"/>
+                          </a:solidFill>
+                          <a:latin typeface="Calibri" pitchFamily="34" charset="0"/>
+                          <a:ea typeface="Calibri" pitchFamily="34" charset="-122"/>
+                          <a:cs typeface="Calibri" pitchFamily="34" charset="-120"/>
+                        </a:rPr>
+                        <a:t>◐</a:t>
+                      </a:r>
+                      <a:endParaRPr lang="en-US" sz="1500" dirty="0">
+                        <a:latin typeface="Calibri" charset="0"/>
+                        <a:ea typeface="Calibri" charset="0"/>
+                        <a:cs typeface="Calibri" charset="0"/>
+                      </a:endParaRPr>
+                    </a:p>
+                  </a:txBody>
+                  <a:tcPr marL="76200" marR="76200" marT="25400" marB="25400" anchor="ctr">
+                    <a:lnL w="6350" cap="flat" cmpd="sng" algn="ctr">
+                      <a:solidFill>
+                        <a:srgbClr val="DCE2EA"/>
+                      </a:solidFill>
+                      <a:prstDash val="solid"/>
+                      <a:round/>
+                      <a:headEnd type="none" w="med" len="med"/>
+                      <a:tailEnd type="none" w="med" len="med"/>
+                    </a:lnL>
+                    <a:lnR w="6350" cap="flat" cmpd="sng" algn="ctr">
+                      <a:solidFill>
+                        <a:srgbClr val="DCE2EA"/>
+                      </a:solidFill>
+                      <a:prstDash val="solid"/>
+                      <a:round/>
+                      <a:headEnd type="none" w="med" len="med"/>
+                      <a:tailEnd type="none" w="med" len="med"/>
+                    </a:lnR>
+                    <a:lnT w="6350" cap="flat" cmpd="sng" algn="ctr">
+                      <a:solidFill>
+                        <a:srgbClr val="DCE2EA"/>
+                      </a:solidFill>
+                      <a:prstDash val="solid"/>
+                      <a:round/>
+                      <a:headEnd type="none" w="med" len="med"/>
+                      <a:tailEnd type="none" w="med" len="med"/>
+                    </a:lnT>
+                    <a:lnB w="6350" cap="flat" cmpd="sng" algn="ctr">
+                      <a:solidFill>
+                        <a:srgbClr val="DCE2EA"/>
+                      </a:solidFill>
+                      <a:prstDash val="solid"/>
+                      <a:round/>
+                      <a:headEnd type="none" w="med" len="med"/>
+                      <a:tailEnd type="none" w="med" len="med"/>
+                    </a:lnB>
+                    <a:solidFill>
+                      <a:srgbClr val="FFFFFF"/>
+                    </a:solidFill>
+                  </a:tcPr>
+                </a:tc>
+                <a:tc>
+                  <a:txBody>
+                    <a:bodyPr/>
+                    <a:lstStyle/>
+                    <a:p>
+                      <a:pPr algn="ctr" indent="0" marL="0">
+                        <a:buNone/>
+                      </a:pPr>
+                      <a:r>
+                        <a:rPr lang="en-US" sz="1500" b="1" dirty="0">
+                          <a:solidFill>
+                            <a:srgbClr val="1E7B34"/>
+                          </a:solidFill>
+                          <a:latin typeface="Calibri" pitchFamily="34" charset="0"/>
+                          <a:ea typeface="Calibri" pitchFamily="34" charset="-122"/>
+                          <a:cs typeface="Calibri" pitchFamily="34" charset="-120"/>
+                        </a:rPr>
+                        <a:t>●</a:t>
+                      </a:r>
+                      <a:endParaRPr lang="en-US" sz="1500" dirty="0">
+                        <a:latin typeface="Calibri" charset="0"/>
+                        <a:ea typeface="Calibri" charset="0"/>
+                        <a:cs typeface="Calibri" charset="0"/>
+                      </a:endParaRPr>
+                    </a:p>
+                  </a:txBody>
+                  <a:tcPr marL="76200" marR="76200" marT="25400" marB="25400" anchor="ctr">
+                    <a:lnL w="6350" cap="flat" cmpd="sng" algn="ctr">
+                      <a:solidFill>
+                        <a:srgbClr val="DCE2EA"/>
+                      </a:solidFill>
+                      <a:prstDash val="solid"/>
+                      <a:round/>
+                      <a:headEnd type="none" w="med" len="med"/>
+                      <a:tailEnd type="none" w="med" len="med"/>
+                    </a:lnL>
+                    <a:lnR w="6350" cap="flat" cmpd="sng" algn="ctr">
+                      <a:solidFill>
+                        <a:srgbClr val="DCE2EA"/>
+                      </a:solidFill>
+                      <a:prstDash val="solid"/>
+                      <a:round/>
+                      <a:headEnd type="none" w="med" len="med"/>
+                      <a:tailEnd type="none" w="med" len="med"/>
+                    </a:lnR>
+                    <a:lnT w="6350" cap="flat" cmpd="sng" algn="ctr">
+                      <a:solidFill>
+                        <a:srgbClr val="DCE2EA"/>
+                      </a:solidFill>
+                      <a:prstDash val="solid"/>
+                      <a:round/>
+                      <a:headEnd type="none" w="med" len="med"/>
+                      <a:tailEnd type="none" w="med" len="med"/>
+                    </a:lnT>
+                    <a:lnB w="6350" cap="flat" cmpd="sng" algn="ctr">
+                      <a:solidFill>
+                        <a:srgbClr val="DCE2EA"/>
+                      </a:solidFill>
+                      <a:prstDash val="solid"/>
+                      <a:round/>
+                      <a:headEnd type="none" w="med" len="med"/>
+                      <a:tailEnd type="none" w="med" len="med"/>
+                    </a:lnB>
+                    <a:solidFill>
+                      <a:srgbClr val="FFFFFF"/>
+                    </a:solidFill>
+                  </a:tcPr>
+                </a:tc>
+              </a:tr>
+              <a:tr h="333756">
+                <a:tc>
+                  <a:txBody>
+                    <a:bodyPr/>
+                    <a:lstStyle/>
+                    <a:p>
+                      <a:pPr indent="0" marL="0">
+                        <a:buNone/>
+                      </a:pPr>
+                      <a:r>
+                        <a:rPr lang="en-US" sz="1150" dirty="0">
+                          <a:solidFill>
+                            <a:srgbClr val="1B1D22"/>
+                          </a:solidFill>
+                          <a:latin typeface="Calibri" pitchFamily="34" charset="0"/>
+                          <a:ea typeface="Calibri" pitchFamily="34" charset="-122"/>
+                          <a:cs typeface="Calibri" pitchFamily="34" charset="-120"/>
+                        </a:rPr>
+                        <a:t>User administration</a:t>
+                      </a:r>
+                      <a:endParaRPr lang="en-US" sz="1150" dirty="0">
+                        <a:latin typeface="Calibri" charset="0"/>
+                        <a:ea typeface="Calibri" charset="0"/>
+                        <a:cs typeface="Calibri" charset="0"/>
+                      </a:endParaRPr>
+                    </a:p>
+                  </a:txBody>
+                  <a:tcPr marL="76200" marR="76200" marT="25400" marB="25400" anchor="ctr">
+                    <a:lnL w="6350" cap="flat" cmpd="sng" algn="ctr">
+                      <a:solidFill>
+                        <a:srgbClr val="DCE2EA"/>
+                      </a:solidFill>
+                      <a:prstDash val="solid"/>
+                      <a:round/>
+                      <a:headEnd type="none" w="med" len="med"/>
+                      <a:tailEnd type="none" w="med" len="med"/>
+                    </a:lnL>
+                    <a:lnR w="6350" cap="flat" cmpd="sng" algn="ctr">
+                      <a:solidFill>
+                        <a:srgbClr val="DCE2EA"/>
+                      </a:solidFill>
+                      <a:prstDash val="solid"/>
+                      <a:round/>
+                      <a:headEnd type="none" w="med" len="med"/>
+                      <a:tailEnd type="none" w="med" len="med"/>
+                    </a:lnR>
+                    <a:lnT w="6350" cap="flat" cmpd="sng" algn="ctr">
+                      <a:solidFill>
+                        <a:srgbClr val="DCE2EA"/>
+                      </a:solidFill>
+                      <a:prstDash val="solid"/>
+                      <a:round/>
+                      <a:headEnd type="none" w="med" len="med"/>
+                      <a:tailEnd type="none" w="med" len="med"/>
+                    </a:lnT>
+                    <a:lnB w="6350" cap="flat" cmpd="sng" algn="ctr">
+                      <a:solidFill>
+                        <a:srgbClr val="DCE2EA"/>
+                      </a:solidFill>
+                      <a:prstDash val="solid"/>
+                      <a:round/>
+                      <a:headEnd type="none" w="med" len="med"/>
+                      <a:tailEnd type="none" w="med" len="med"/>
+                    </a:lnB>
+                    <a:solidFill>
+                      <a:srgbClr val="F4F6F8"/>
+                    </a:solidFill>
+                  </a:tcPr>
+                </a:tc>
+                <a:tc>
+                  <a:txBody>
+                    <a:bodyPr/>
+                    <a:lstStyle/>
+                    <a:p>
+                      <a:pPr algn="ctr" indent="0" marL="0">
+                        <a:buNone/>
+                      </a:pPr>
+                      <a:r>
+                        <a:rPr lang="en-US" sz="1500" b="1" dirty="0">
+                          <a:solidFill>
+                            <a:srgbClr val="1E7B34"/>
+                          </a:solidFill>
+                          <a:latin typeface="Calibri" pitchFamily="34" charset="0"/>
+                          <a:ea typeface="Calibri" pitchFamily="34" charset="-122"/>
+                          <a:cs typeface="Calibri" pitchFamily="34" charset="-120"/>
+                        </a:rPr>
+                        <a:t>●</a:t>
+                      </a:r>
+                      <a:endParaRPr lang="en-US" sz="1500" dirty="0">
+                        <a:latin typeface="Calibri" charset="0"/>
+                        <a:ea typeface="Calibri" charset="0"/>
+                        <a:cs typeface="Calibri" charset="0"/>
+                      </a:endParaRPr>
+                    </a:p>
+                  </a:txBody>
+                  <a:tcPr marL="76200" marR="76200" marT="25400" marB="25400" anchor="ctr">
+                    <a:lnL w="6350" cap="flat" cmpd="sng" algn="ctr">
+                      <a:solidFill>
+                        <a:srgbClr val="DCE2EA"/>
+                      </a:solidFill>
+                      <a:prstDash val="solid"/>
+                      <a:round/>
+                      <a:headEnd type="none" w="med" len="med"/>
+                      <a:tailEnd type="none" w="med" len="med"/>
+                    </a:lnL>
+                    <a:lnR w="6350" cap="flat" cmpd="sng" algn="ctr">
+                      <a:solidFill>
+                        <a:srgbClr val="DCE2EA"/>
+                      </a:solidFill>
+                      <a:prstDash val="solid"/>
+                      <a:round/>
+                      <a:headEnd type="none" w="med" len="med"/>
+                      <a:tailEnd type="none" w="med" len="med"/>
+                    </a:lnR>
+                    <a:lnT w="6350" cap="flat" cmpd="sng" algn="ctr">
+                      <a:solidFill>
+                        <a:srgbClr val="DCE2EA"/>
+                      </a:solidFill>
+                      <a:prstDash val="solid"/>
+                      <a:round/>
+                      <a:headEnd type="none" w="med" len="med"/>
+                      <a:tailEnd type="none" w="med" len="med"/>
+                    </a:lnT>
+                    <a:lnB w="6350" cap="flat" cmpd="sng" algn="ctr">
+                      <a:solidFill>
+                        <a:srgbClr val="DCE2EA"/>
+                      </a:solidFill>
+                      <a:prstDash val="solid"/>
+                      <a:round/>
+                      <a:headEnd type="none" w="med" len="med"/>
+                      <a:tailEnd type="none" w="med" len="med"/>
+                    </a:lnB>
+                    <a:solidFill>
+                      <a:srgbClr val="F4F6F8"/>
+                    </a:solidFill>
+                  </a:tcPr>
+                </a:tc>
+                <a:tc>
+                  <a:txBody>
+                    <a:bodyPr/>
+                    <a:lstStyle/>
+                    <a:p>
+                      <a:pPr algn="ctr" indent="0" marL="0">
+                        <a:buNone/>
+                      </a:pPr>
+                      <a:r>
+                        <a:rPr lang="en-US" sz="1500" b="1" dirty="0">
+                          <a:solidFill>
+                            <a:srgbClr val="1E7B34"/>
+                          </a:solidFill>
+                          <a:latin typeface="Calibri" pitchFamily="34" charset="0"/>
+                          <a:ea typeface="Calibri" pitchFamily="34" charset="-122"/>
+                          <a:cs typeface="Calibri" pitchFamily="34" charset="-120"/>
+                        </a:rPr>
+                        <a:t>●</a:t>
+                      </a:r>
+                      <a:endParaRPr lang="en-US" sz="1500" dirty="0">
+                        <a:latin typeface="Calibri" charset="0"/>
+                        <a:ea typeface="Calibri" charset="0"/>
+                        <a:cs typeface="Calibri" charset="0"/>
+                      </a:endParaRPr>
+                    </a:p>
+                  </a:txBody>
+                  <a:tcPr marL="76200" marR="76200" marT="25400" marB="25400" anchor="ctr">
+                    <a:lnL w="6350" cap="flat" cmpd="sng" algn="ctr">
+                      <a:solidFill>
+                        <a:srgbClr val="DCE2EA"/>
+                      </a:solidFill>
+                      <a:prstDash val="solid"/>
+                      <a:round/>
+                      <a:headEnd type="none" w="med" len="med"/>
+                      <a:tailEnd type="none" w="med" len="med"/>
+                    </a:lnL>
+                    <a:lnR w="6350" cap="flat" cmpd="sng" algn="ctr">
+                      <a:solidFill>
+                        <a:srgbClr val="DCE2EA"/>
+                      </a:solidFill>
+                      <a:prstDash val="solid"/>
+                      <a:round/>
+                      <a:headEnd type="none" w="med" len="med"/>
+                      <a:tailEnd type="none" w="med" len="med"/>
+                    </a:lnR>
+                    <a:lnT w="6350" cap="flat" cmpd="sng" algn="ctr">
+                      <a:solidFill>
+                        <a:srgbClr val="DCE2EA"/>
+                      </a:solidFill>
+                      <a:prstDash val="solid"/>
+                      <a:round/>
+                      <a:headEnd type="none" w="med" len="med"/>
+                      <a:tailEnd type="none" w="med" len="med"/>
+                    </a:lnT>
+                    <a:lnB w="6350" cap="flat" cmpd="sng" algn="ctr">
+                      <a:solidFill>
+                        <a:srgbClr val="DCE2EA"/>
+                      </a:solidFill>
+                      <a:prstDash val="solid"/>
+                      <a:round/>
+                      <a:headEnd type="none" w="med" len="med"/>
+                      <a:tailEnd type="none" w="med" len="med"/>
+                    </a:lnB>
+                    <a:solidFill>
+                      <a:srgbClr val="F4F6F8"/>
+                    </a:solidFill>
+                  </a:tcPr>
+                </a:tc>
+                <a:tc>
+                  <a:txBody>
+                    <a:bodyPr/>
+                    <a:lstStyle/>
+                    <a:p>
+                      <a:pPr algn="ctr" indent="0" marL="0">
+                        <a:buNone/>
+                      </a:pPr>
+                      <a:r>
+                        <a:rPr lang="en-US" sz="1500" b="1" dirty="0">
+                          <a:solidFill>
+                            <a:srgbClr val="1E7B34"/>
+                          </a:solidFill>
+                          <a:latin typeface="Calibri" pitchFamily="34" charset="0"/>
+                          <a:ea typeface="Calibri" pitchFamily="34" charset="-122"/>
+                          <a:cs typeface="Calibri" pitchFamily="34" charset="-120"/>
+                        </a:rPr>
+                        <a:t>●</a:t>
+                      </a:r>
+                      <a:endParaRPr lang="en-US" sz="1500" dirty="0">
+                        <a:latin typeface="Calibri" charset="0"/>
+                        <a:ea typeface="Calibri" charset="0"/>
+                        <a:cs typeface="Calibri" charset="0"/>
+                      </a:endParaRPr>
+                    </a:p>
+                  </a:txBody>
+                  <a:tcPr marL="76200" marR="76200" marT="25400" marB="25400" anchor="ctr">
+                    <a:lnL w="6350" cap="flat" cmpd="sng" algn="ctr">
+                      <a:solidFill>
+                        <a:srgbClr val="DCE2EA"/>
+                      </a:solidFill>
+                      <a:prstDash val="solid"/>
+                      <a:round/>
+                      <a:headEnd type="none" w="med" len="med"/>
+                      <a:tailEnd type="none" w="med" len="med"/>
+                    </a:lnL>
+                    <a:lnR w="6350" cap="flat" cmpd="sng" algn="ctr">
+                      <a:solidFill>
+                        <a:srgbClr val="DCE2EA"/>
+                      </a:solidFill>
+                      <a:prstDash val="solid"/>
+                      <a:round/>
+                      <a:headEnd type="none" w="med" len="med"/>
+                      <a:tailEnd type="none" w="med" len="med"/>
+                    </a:lnR>
+                    <a:lnT w="6350" cap="flat" cmpd="sng" algn="ctr">
+                      <a:solidFill>
+                        <a:srgbClr val="DCE2EA"/>
+                      </a:solidFill>
+                      <a:prstDash val="solid"/>
+                      <a:round/>
+                      <a:headEnd type="none" w="med" len="med"/>
+                      <a:tailEnd type="none" w="med" len="med"/>
+                    </a:lnT>
+                    <a:lnB w="6350" cap="flat" cmpd="sng" algn="ctr">
+                      <a:solidFill>
+                        <a:srgbClr val="DCE2EA"/>
+                      </a:solidFill>
+                      <a:prstDash val="solid"/>
+                      <a:round/>
+                      <a:headEnd type="none" w="med" len="med"/>
+                      <a:tailEnd type="none" w="med" len="med"/>
+                    </a:lnB>
+                    <a:solidFill>
+                      <a:srgbClr val="F4F6F8"/>
+                    </a:solidFill>
+                  </a:tcPr>
+                </a:tc>
+              </a:tr>
+              <a:tr h="333756">
+                <a:tc>
+                  <a:txBody>
+                    <a:bodyPr/>
+                    <a:lstStyle/>
+                    <a:p>
+                      <a:pPr indent="0" marL="0">
+                        <a:buNone/>
+                      </a:pPr>
+                      <a:r>
+                        <a:rPr lang="en-US" sz="1150" dirty="0">
+                          <a:solidFill>
+                            <a:srgbClr val="1B1D22"/>
+                          </a:solidFill>
+                          <a:latin typeface="Calibri" pitchFamily="34" charset="0"/>
+                          <a:ea typeface="Calibri" pitchFamily="34" charset="-122"/>
+                          <a:cs typeface="Calibri" pitchFamily="34" charset="-120"/>
+                        </a:rPr>
+                        <a:t>Shared, encrypted query library</a:t>
+                      </a:r>
+                      <a:endParaRPr lang="en-US" sz="1150" dirty="0">
+                        <a:latin typeface="Calibri" charset="0"/>
+                        <a:ea typeface="Calibri" charset="0"/>
+                        <a:cs typeface="Calibri" charset="0"/>
+                      </a:endParaRPr>
+                    </a:p>
+                  </a:txBody>
+                  <a:tcPr marL="76200" marR="76200" marT="25400" marB="25400" anchor="ctr">
+                    <a:lnL w="6350" cap="flat" cmpd="sng" algn="ctr">
+                      <a:solidFill>
+                        <a:srgbClr val="DCE2EA"/>
+                      </a:solidFill>
+                      <a:prstDash val="solid"/>
+                      <a:round/>
+                      <a:headEnd type="none" w="med" len="med"/>
+                      <a:tailEnd type="none" w="med" len="med"/>
+                    </a:lnL>
+                    <a:lnR w="6350" cap="flat" cmpd="sng" algn="ctr">
+                      <a:solidFill>
+                        <a:srgbClr val="DCE2EA"/>
+                      </a:solidFill>
+                      <a:prstDash val="solid"/>
+                      <a:round/>
+                      <a:headEnd type="none" w="med" len="med"/>
+                      <a:tailEnd type="none" w="med" len="med"/>
+                    </a:lnR>
+                    <a:lnT w="6350" cap="flat" cmpd="sng" algn="ctr">
+                      <a:solidFill>
+                        <a:srgbClr val="DCE2EA"/>
+                      </a:solidFill>
+                      <a:prstDash val="solid"/>
+                      <a:round/>
+                      <a:headEnd type="none" w="med" len="med"/>
+                      <a:tailEnd type="none" w="med" len="med"/>
+                    </a:lnT>
+                    <a:lnB w="6350" cap="flat" cmpd="sng" algn="ctr">
+                      <a:solidFill>
+                        <a:srgbClr val="DCE2EA"/>
+                      </a:solidFill>
+                      <a:prstDash val="solid"/>
+                      <a:round/>
+                      <a:headEnd type="none" w="med" len="med"/>
+                      <a:tailEnd type="none" w="med" len="med"/>
+                    </a:lnB>
+                    <a:solidFill>
+                      <a:srgbClr val="FFFFFF"/>
+                    </a:solidFill>
+                  </a:tcPr>
+                </a:tc>
+                <a:tc>
+                  <a:txBody>
+                    <a:bodyPr/>
+                    <a:lstStyle/>
+                    <a:p>
+                      <a:pPr algn="ctr" indent="0" marL="0">
+                        <a:buNone/>
+                      </a:pPr>
+                      <a:r>
+                        <a:rPr lang="en-US" sz="1500" b="1" dirty="0">
+                          <a:solidFill>
+                            <a:srgbClr val="1E7B34"/>
+                          </a:solidFill>
+                          <a:latin typeface="Calibri" pitchFamily="34" charset="0"/>
+                          <a:ea typeface="Calibri" pitchFamily="34" charset="-122"/>
+                          <a:cs typeface="Calibri" pitchFamily="34" charset="-120"/>
+                        </a:rPr>
+                        <a:t>●</a:t>
+                      </a:r>
+                      <a:endParaRPr lang="en-US" sz="1500" dirty="0">
+                        <a:latin typeface="Calibri" charset="0"/>
+                        <a:ea typeface="Calibri" charset="0"/>
+                        <a:cs typeface="Calibri" charset="0"/>
+                      </a:endParaRPr>
+                    </a:p>
+                  </a:txBody>
+                  <a:tcPr marL="76200" marR="76200" marT="25400" marB="25400" anchor="ctr">
+                    <a:lnL w="6350" cap="flat" cmpd="sng" algn="ctr">
+                      <a:solidFill>
+                        <a:srgbClr val="DCE2EA"/>
+                      </a:solidFill>
+                      <a:prstDash val="solid"/>
+                      <a:round/>
+                      <a:headEnd type="none" w="med" len="med"/>
+                      <a:tailEnd type="none" w="med" len="med"/>
+                    </a:lnL>
+                    <a:lnR w="6350" cap="flat" cmpd="sng" algn="ctr">
+                      <a:solidFill>
+                        <a:srgbClr val="DCE2EA"/>
+                      </a:solidFill>
+                      <a:prstDash val="solid"/>
+                      <a:round/>
+                      <a:headEnd type="none" w="med" len="med"/>
+                      <a:tailEnd type="none" w="med" len="med"/>
+                    </a:lnR>
+                    <a:lnT w="6350" cap="flat" cmpd="sng" algn="ctr">
+                      <a:solidFill>
+                        <a:srgbClr val="DCE2EA"/>
+                      </a:solidFill>
+                      <a:prstDash val="solid"/>
+                      <a:round/>
+                      <a:headEnd type="none" w="med" len="med"/>
+                      <a:tailEnd type="none" w="med" len="med"/>
+                    </a:lnT>
+                    <a:lnB w="6350" cap="flat" cmpd="sng" algn="ctr">
+                      <a:solidFill>
+                        <a:srgbClr val="DCE2EA"/>
+                      </a:solidFill>
+                      <a:prstDash val="solid"/>
+                      <a:round/>
+                      <a:headEnd type="none" w="med" len="med"/>
+                      <a:tailEnd type="none" w="med" len="med"/>
+                    </a:lnB>
+                    <a:solidFill>
+                      <a:srgbClr val="FFFFFF"/>
+                    </a:solidFill>
+                  </a:tcPr>
+                </a:tc>
+                <a:tc>
+                  <a:txBody>
+                    <a:bodyPr/>
+                    <a:lstStyle/>
+                    <a:p>
+                      <a:pPr algn="ctr" indent="0" marL="0">
+                        <a:buNone/>
+                      </a:pPr>
+                      <a:r>
+                        <a:rPr lang="en-US" sz="1500" b="1" dirty="0">
+                          <a:solidFill>
+                            <a:srgbClr val="9AA3AE"/>
+                          </a:solidFill>
+                          <a:latin typeface="Calibri" pitchFamily="34" charset="0"/>
+                          <a:ea typeface="Calibri" pitchFamily="34" charset="-122"/>
+                          <a:cs typeface="Calibri" pitchFamily="34" charset="-120"/>
+                        </a:rPr>
+                        <a:t>○</a:t>
+                      </a:r>
+                      <a:endParaRPr lang="en-US" sz="1500" dirty="0">
+                        <a:latin typeface="Calibri" charset="0"/>
+                        <a:ea typeface="Calibri" charset="0"/>
+                        <a:cs typeface="Calibri" charset="0"/>
+                      </a:endParaRPr>
+                    </a:p>
+                  </a:txBody>
+                  <a:tcPr marL="76200" marR="76200" marT="25400" marB="25400" anchor="ctr">
+                    <a:lnL w="6350" cap="flat" cmpd="sng" algn="ctr">
+                      <a:solidFill>
+                        <a:srgbClr val="DCE2EA"/>
+                      </a:solidFill>
+                      <a:prstDash val="solid"/>
+                      <a:round/>
+                      <a:headEnd type="none" w="med" len="med"/>
+                      <a:tailEnd type="none" w="med" len="med"/>
+                    </a:lnL>
+                    <a:lnR w="6350" cap="flat" cmpd="sng" algn="ctr">
+                      <a:solidFill>
+                        <a:srgbClr val="DCE2EA"/>
+                      </a:solidFill>
+                      <a:prstDash val="solid"/>
+                      <a:round/>
+                      <a:headEnd type="none" w="med" len="med"/>
+                      <a:tailEnd type="none" w="med" len="med"/>
+                    </a:lnR>
+                    <a:lnT w="6350" cap="flat" cmpd="sng" algn="ctr">
+                      <a:solidFill>
+                        <a:srgbClr val="DCE2EA"/>
+                      </a:solidFill>
+                      <a:prstDash val="solid"/>
+                      <a:round/>
+                      <a:headEnd type="none" w="med" len="med"/>
+                      <a:tailEnd type="none" w="med" len="med"/>
+                    </a:lnT>
+                    <a:lnB w="6350" cap="flat" cmpd="sng" algn="ctr">
+                      <a:solidFill>
+                        <a:srgbClr val="DCE2EA"/>
+                      </a:solidFill>
+                      <a:prstDash val="solid"/>
+                      <a:round/>
+                      <a:headEnd type="none" w="med" len="med"/>
+                      <a:tailEnd type="none" w="med" len="med"/>
+                    </a:lnB>
+                    <a:solidFill>
+                      <a:srgbClr val="FFFFFF"/>
+                    </a:solidFill>
+                  </a:tcPr>
+                </a:tc>
+                <a:tc>
+                  <a:txBody>
+                    <a:bodyPr/>
+                    <a:lstStyle/>
+                    <a:p>
+                      <a:pPr algn="ctr" indent="0" marL="0">
+                        <a:buNone/>
+                      </a:pPr>
+                      <a:r>
+                        <a:rPr lang="en-US" sz="1500" b="1" dirty="0">
+                          <a:solidFill>
+                            <a:srgbClr val="9AA3AE"/>
+                          </a:solidFill>
+                          <a:latin typeface="Calibri" pitchFamily="34" charset="0"/>
+                          <a:ea typeface="Calibri" pitchFamily="34" charset="-122"/>
+                          <a:cs typeface="Calibri" pitchFamily="34" charset="-120"/>
+                        </a:rPr>
+                        <a:t>○</a:t>
+                      </a:r>
+                      <a:endParaRPr lang="en-US" sz="1500" dirty="0">
+                        <a:latin typeface="Calibri" charset="0"/>
+                        <a:ea typeface="Calibri" charset="0"/>
+                        <a:cs typeface="Calibri" charset="0"/>
+                      </a:endParaRPr>
+                    </a:p>
+                  </a:txBody>
+                  <a:tcPr marL="76200" marR="76200" marT="25400" marB="25400" anchor="ctr">
+                    <a:lnL w="6350" cap="flat" cmpd="sng" algn="ctr">
+                      <a:solidFill>
+                        <a:srgbClr val="DCE2EA"/>
+                      </a:solidFill>
+                      <a:prstDash val="solid"/>
+                      <a:round/>
+                      <a:headEnd type="none" w="med" len="med"/>
+                      <a:tailEnd type="none" w="med" len="med"/>
+                    </a:lnL>
+                    <a:lnR w="6350" cap="flat" cmpd="sng" algn="ctr">
+                      <a:solidFill>
+                        <a:srgbClr val="DCE2EA"/>
+                      </a:solidFill>
+                      <a:prstDash val="solid"/>
+                      <a:round/>
+                      <a:headEnd type="none" w="med" len="med"/>
+                      <a:tailEnd type="none" w="med" len="med"/>
+                    </a:lnR>
+                    <a:lnT w="6350" cap="flat" cmpd="sng" algn="ctr">
+                      <a:solidFill>
+                        <a:srgbClr val="DCE2EA"/>
+                      </a:solidFill>
+                      <a:prstDash val="solid"/>
+                      <a:round/>
+                      <a:headEnd type="none" w="med" len="med"/>
+                      <a:tailEnd type="none" w="med" len="med"/>
+                    </a:lnT>
+                    <a:lnB w="6350" cap="flat" cmpd="sng" algn="ctr">
+                      <a:solidFill>
+                        <a:srgbClr val="DCE2EA"/>
+                      </a:solidFill>
+                      <a:prstDash val="solid"/>
+                      <a:round/>
+                      <a:headEnd type="none" w="med" len="med"/>
+                      <a:tailEnd type="none" w="med" len="med"/>
+                    </a:lnB>
+                    <a:solidFill>
+                      <a:srgbClr val="FFFFFF"/>
+                    </a:solidFill>
+                  </a:tcPr>
+                </a:tc>
+              </a:tr>
+              <a:tr h="333756">
+                <a:tc>
+                  <a:txBody>
+                    <a:bodyPr/>
+                    <a:lstStyle/>
+                    <a:p>
+                      <a:pPr indent="0" marL="0">
+                        <a:buNone/>
+                      </a:pPr>
+                      <a:r>
+                        <a:rPr lang="en-US" sz="1150" dirty="0">
+                          <a:solidFill>
+                            <a:srgbClr val="1B1D22"/>
+                          </a:solidFill>
+                          <a:latin typeface="Calibri" pitchFamily="34" charset="0"/>
+                          <a:ea typeface="Calibri" pitchFamily="34" charset="-122"/>
+                          <a:cs typeface="Calibri" pitchFamily="34" charset="-120"/>
+                        </a:rPr>
+                        <a:t>Execution plans</a:t>
+                      </a:r>
+                      <a:endParaRPr lang="en-US" sz="1150" dirty="0">
+                        <a:latin typeface="Calibri" charset="0"/>
+                        <a:ea typeface="Calibri" charset="0"/>
+                        <a:cs typeface="Calibri" charset="0"/>
+                      </a:endParaRPr>
+                    </a:p>
+                  </a:txBody>
+                  <a:tcPr marL="76200" marR="76200" marT="25400" marB="25400" anchor="ctr">
+                    <a:lnL w="6350" cap="flat" cmpd="sng" algn="ctr">
+                      <a:solidFill>
+                        <a:srgbClr val="DCE2EA"/>
+                      </a:solidFill>
+                      <a:prstDash val="solid"/>
+                      <a:round/>
+                      <a:headEnd type="none" w="med" len="med"/>
+                      <a:tailEnd type="none" w="med" len="med"/>
+                    </a:lnL>
+                    <a:lnR w="6350" cap="flat" cmpd="sng" algn="ctr">
+                      <a:solidFill>
+                        <a:srgbClr val="DCE2EA"/>
+                      </a:solidFill>
+                      <a:prstDash val="solid"/>
+                      <a:round/>
+                      <a:headEnd type="none" w="med" len="med"/>
+                      <a:tailEnd type="none" w="med" len="med"/>
+                    </a:lnR>
+                    <a:lnT w="6350" cap="flat" cmpd="sng" algn="ctr">
+                      <a:solidFill>
+                        <a:srgbClr val="DCE2EA"/>
+                      </a:solidFill>
+                      <a:prstDash val="solid"/>
+                      <a:round/>
+                      <a:headEnd type="none" w="med" len="med"/>
+                      <a:tailEnd type="none" w="med" len="med"/>
+                    </a:lnT>
+                    <a:lnB w="6350" cap="flat" cmpd="sng" algn="ctr">
+                      <a:solidFill>
+                        <a:srgbClr val="DCE2EA"/>
+                      </a:solidFill>
+                      <a:prstDash val="solid"/>
+                      <a:round/>
+                      <a:headEnd type="none" w="med" len="med"/>
+                      <a:tailEnd type="none" w="med" len="med"/>
+                    </a:lnB>
+                    <a:solidFill>
+                      <a:srgbClr val="F4F6F8"/>
+                    </a:solidFill>
+                  </a:tcPr>
+                </a:tc>
+                <a:tc>
+                  <a:txBody>
+                    <a:bodyPr/>
+                    <a:lstStyle/>
+                    <a:p>
+                      <a:pPr algn="ctr" indent="0" marL="0">
+                        <a:buNone/>
+                      </a:pPr>
+                      <a:r>
+                        <a:rPr lang="en-US" sz="1500" b="1" dirty="0">
+                          <a:solidFill>
+                            <a:srgbClr val="9AA3AE"/>
+                          </a:solidFill>
+                          <a:latin typeface="Calibri" pitchFamily="34" charset="0"/>
+                          <a:ea typeface="Calibri" pitchFamily="34" charset="-122"/>
+                          <a:cs typeface="Calibri" pitchFamily="34" charset="-120"/>
+                        </a:rPr>
+                        <a:t>○</a:t>
+                      </a:r>
+                      <a:endParaRPr lang="en-US" sz="1500" dirty="0">
+                        <a:latin typeface="Calibri" charset="0"/>
+                        <a:ea typeface="Calibri" charset="0"/>
+                        <a:cs typeface="Calibri" charset="0"/>
+                      </a:endParaRPr>
+                    </a:p>
+                  </a:txBody>
+                  <a:tcPr marL="76200" marR="76200" marT="25400" marB="25400" anchor="ctr">
+                    <a:lnL w="6350" cap="flat" cmpd="sng" algn="ctr">
+                      <a:solidFill>
+                        <a:srgbClr val="DCE2EA"/>
+                      </a:solidFill>
+                      <a:prstDash val="solid"/>
+                      <a:round/>
+                      <a:headEnd type="none" w="med" len="med"/>
+                      <a:tailEnd type="none" w="med" len="med"/>
+                    </a:lnL>
+                    <a:lnR w="6350" cap="flat" cmpd="sng" algn="ctr">
+                      <a:solidFill>
+                        <a:srgbClr val="DCE2EA"/>
+                      </a:solidFill>
+                      <a:prstDash val="solid"/>
+                      <a:round/>
+                      <a:headEnd type="none" w="med" len="med"/>
+                      <a:tailEnd type="none" w="med" len="med"/>
+                    </a:lnR>
+                    <a:lnT w="6350" cap="flat" cmpd="sng" algn="ctr">
+                      <a:solidFill>
+                        <a:srgbClr val="DCE2EA"/>
+                      </a:solidFill>
+                      <a:prstDash val="solid"/>
+                      <a:round/>
+                      <a:headEnd type="none" w="med" len="med"/>
+                      <a:tailEnd type="none" w="med" len="med"/>
+                    </a:lnT>
+                    <a:lnB w="6350" cap="flat" cmpd="sng" algn="ctr">
+                      <a:solidFill>
+                        <a:srgbClr val="DCE2EA"/>
+                      </a:solidFill>
+                      <a:prstDash val="solid"/>
+                      <a:round/>
+                      <a:headEnd type="none" w="med" len="med"/>
+                      <a:tailEnd type="none" w="med" len="med"/>
+                    </a:lnB>
+                    <a:solidFill>
+                      <a:srgbClr val="F4F6F8"/>
+                    </a:solidFill>
+                  </a:tcPr>
+                </a:tc>
+                <a:tc>
+                  <a:txBody>
+                    <a:bodyPr/>
+                    <a:lstStyle/>
+                    <a:p>
+                      <a:pPr algn="ctr" indent="0" marL="0">
+                        <a:buNone/>
+                      </a:pPr>
+                      <a:r>
+                        <a:rPr lang="en-US" sz="1500" b="1" dirty="0">
+                          <a:solidFill>
+                            <a:srgbClr val="1E7B34"/>
+                          </a:solidFill>
+                          <a:latin typeface="Calibri" pitchFamily="34" charset="0"/>
+                          <a:ea typeface="Calibri" pitchFamily="34" charset="-122"/>
+                          <a:cs typeface="Calibri" pitchFamily="34" charset="-120"/>
+                        </a:rPr>
+                        <a:t>●</a:t>
+                      </a:r>
+                      <a:endParaRPr lang="en-US" sz="1500" dirty="0">
+                        <a:latin typeface="Calibri" charset="0"/>
+                        <a:ea typeface="Calibri" charset="0"/>
+                        <a:cs typeface="Calibri" charset="0"/>
+                      </a:endParaRPr>
+                    </a:p>
+                  </a:txBody>
+                  <a:tcPr marL="76200" marR="76200" marT="25400" marB="25400" anchor="ctr">
+                    <a:lnL w="6350" cap="flat" cmpd="sng" algn="ctr">
+                      <a:solidFill>
+                        <a:srgbClr val="DCE2EA"/>
+                      </a:solidFill>
+                      <a:prstDash val="solid"/>
+                      <a:round/>
+                      <a:headEnd type="none" w="med" len="med"/>
+                      <a:tailEnd type="none" w="med" len="med"/>
+                    </a:lnL>
+                    <a:lnR w="6350" cap="flat" cmpd="sng" algn="ctr">
+                      <a:solidFill>
+                        <a:srgbClr val="DCE2EA"/>
+                      </a:solidFill>
+                      <a:prstDash val="solid"/>
+                      <a:round/>
+                      <a:headEnd type="none" w="med" len="med"/>
+                      <a:tailEnd type="none" w="med" len="med"/>
+                    </a:lnR>
+                    <a:lnT w="6350" cap="flat" cmpd="sng" algn="ctr">
+                      <a:solidFill>
+                        <a:srgbClr val="DCE2EA"/>
+                      </a:solidFill>
+                      <a:prstDash val="solid"/>
+                      <a:round/>
+                      <a:headEnd type="none" w="med" len="med"/>
+                      <a:tailEnd type="none" w="med" len="med"/>
+                    </a:lnT>
+                    <a:lnB w="6350" cap="flat" cmpd="sng" algn="ctr">
+                      <a:solidFill>
+                        <a:srgbClr val="DCE2EA"/>
+                      </a:solidFill>
+                      <a:prstDash val="solid"/>
+                      <a:round/>
+                      <a:headEnd type="none" w="med" len="med"/>
+                      <a:tailEnd type="none" w="med" len="med"/>
+                    </a:lnB>
+                    <a:solidFill>
+                      <a:srgbClr val="F4F6F8"/>
+                    </a:solidFill>
+                  </a:tcPr>
+                </a:tc>
+                <a:tc>
+                  <a:txBody>
+                    <a:bodyPr/>
+                    <a:lstStyle/>
+                    <a:p>
+                      <a:pPr algn="ctr" indent="0" marL="0">
+                        <a:buNone/>
+                      </a:pPr>
+                      <a:r>
+                        <a:rPr lang="en-US" sz="1500" b="1" dirty="0">
+                          <a:solidFill>
+                            <a:srgbClr val="1E7B34"/>
+                          </a:solidFill>
+                          <a:latin typeface="Calibri" pitchFamily="34" charset="0"/>
+                          <a:ea typeface="Calibri" pitchFamily="34" charset="-122"/>
+                          <a:cs typeface="Calibri" pitchFamily="34" charset="-120"/>
+                        </a:rPr>
+                        <a:t>●</a:t>
+                      </a:r>
+                      <a:endParaRPr lang="en-US" sz="1500" dirty="0">
+                        <a:latin typeface="Calibri" charset="0"/>
+                        <a:ea typeface="Calibri" charset="0"/>
+                        <a:cs typeface="Calibri" charset="0"/>
+                      </a:endParaRPr>
+                    </a:p>
+                  </a:txBody>
+                  <a:tcPr marL="76200" marR="76200" marT="25400" marB="25400" anchor="ctr">
+                    <a:lnL w="6350" cap="flat" cmpd="sng" algn="ctr">
+                      <a:solidFill>
+                        <a:srgbClr val="DCE2EA"/>
+                      </a:solidFill>
+                      <a:prstDash val="solid"/>
+                      <a:round/>
+                      <a:headEnd type="none" w="med" len="med"/>
+                      <a:tailEnd type="none" w="med" len="med"/>
+                    </a:lnL>
+                    <a:lnR w="6350" cap="flat" cmpd="sng" algn="ctr">
+                      <a:solidFill>
+                        <a:srgbClr val="DCE2EA"/>
+                      </a:solidFill>
+                      <a:prstDash val="solid"/>
+                      <a:round/>
+                      <a:headEnd type="none" w="med" len="med"/>
+                      <a:tailEnd type="none" w="med" len="med"/>
+                    </a:lnR>
+                    <a:lnT w="6350" cap="flat" cmpd="sng" algn="ctr">
+                      <a:solidFill>
+                        <a:srgbClr val="DCE2EA"/>
+                      </a:solidFill>
+                      <a:prstDash val="solid"/>
+                      <a:round/>
+                      <a:headEnd type="none" w="med" len="med"/>
+                      <a:tailEnd type="none" w="med" len="med"/>
+                    </a:lnT>
+                    <a:lnB w="6350" cap="flat" cmpd="sng" algn="ctr">
+                      <a:solidFill>
+                        <a:srgbClr val="DCE2EA"/>
+                      </a:solidFill>
+                      <a:prstDash val="solid"/>
+                      <a:round/>
+                      <a:headEnd type="none" w="med" len="med"/>
+                      <a:tailEnd type="none" w="med" len="med"/>
+                    </a:lnB>
+                    <a:solidFill>
+                      <a:srgbClr val="F4F6F8"/>
+                    </a:solidFill>
+                  </a:tcPr>
+                </a:tc>
+              </a:tr>
+              <a:tr h="333756">
+                <a:tc>
+                  <a:txBody>
+                    <a:bodyPr/>
+                    <a:lstStyle/>
+                    <a:p>
+                      <a:pPr indent="0" marL="0">
+                        <a:buNone/>
+                      </a:pPr>
+                      <a:r>
+                        <a:rPr lang="en-US" sz="1150" dirty="0">
+                          <a:solidFill>
+                            <a:srgbClr val="1B1D22"/>
+                          </a:solidFill>
+                          <a:latin typeface="Calibri" pitchFamily="34" charset="0"/>
+                          <a:ea typeface="Calibri" pitchFamily="34" charset="-122"/>
+                          <a:cs typeface="Calibri" pitchFamily="34" charset="-120"/>
+                        </a:rPr>
+                        <a:t>Backups, jobs and BI tooling</a:t>
+                      </a:r>
+                      <a:endParaRPr lang="en-US" sz="1150" dirty="0">
+                        <a:latin typeface="Calibri" charset="0"/>
+                        <a:ea typeface="Calibri" charset="0"/>
+                        <a:cs typeface="Calibri" charset="0"/>
+                      </a:endParaRPr>
+                    </a:p>
+                  </a:txBody>
+                  <a:tcPr marL="76200" marR="76200" marT="25400" marB="25400" anchor="ctr">
+                    <a:lnL w="6350" cap="flat" cmpd="sng" algn="ctr">
+                      <a:solidFill>
+                        <a:srgbClr val="DCE2EA"/>
+                      </a:solidFill>
+                      <a:prstDash val="solid"/>
+                      <a:round/>
+                      <a:headEnd type="none" w="med" len="med"/>
+                      <a:tailEnd type="none" w="med" len="med"/>
+                    </a:lnL>
+                    <a:lnR w="6350" cap="flat" cmpd="sng" algn="ctr">
+                      <a:solidFill>
+                        <a:srgbClr val="DCE2EA"/>
+                      </a:solidFill>
+                      <a:prstDash val="solid"/>
+                      <a:round/>
+                      <a:headEnd type="none" w="med" len="med"/>
+                      <a:tailEnd type="none" w="med" len="med"/>
+                    </a:lnR>
+                    <a:lnT w="6350" cap="flat" cmpd="sng" algn="ctr">
+                      <a:solidFill>
+                        <a:srgbClr val="DCE2EA"/>
+                      </a:solidFill>
+                      <a:prstDash val="solid"/>
+                      <a:round/>
+                      <a:headEnd type="none" w="med" len="med"/>
+                      <a:tailEnd type="none" w="med" len="med"/>
+                    </a:lnT>
+                    <a:lnB w="6350" cap="flat" cmpd="sng" algn="ctr">
+                      <a:solidFill>
+                        <a:srgbClr val="DCE2EA"/>
+                      </a:solidFill>
+                      <a:prstDash val="solid"/>
+                      <a:round/>
+                      <a:headEnd type="none" w="med" len="med"/>
+                      <a:tailEnd type="none" w="med" len="med"/>
+                    </a:lnB>
+                    <a:solidFill>
+                      <a:srgbClr val="FFFFFF"/>
+                    </a:solidFill>
+                  </a:tcPr>
+                </a:tc>
+                <a:tc>
+                  <a:txBody>
+                    <a:bodyPr/>
+                    <a:lstStyle/>
+                    <a:p>
+                      <a:pPr algn="ctr" indent="0" marL="0">
+                        <a:buNone/>
+                      </a:pPr>
+                      <a:r>
+                        <a:rPr lang="en-US" sz="1500" b="1" dirty="0">
+                          <a:solidFill>
+                            <a:srgbClr val="9AA3AE"/>
+                          </a:solidFill>
+                          <a:latin typeface="Calibri" pitchFamily="34" charset="0"/>
+                          <a:ea typeface="Calibri" pitchFamily="34" charset="-122"/>
+                          <a:cs typeface="Calibri" pitchFamily="34" charset="-120"/>
+                        </a:rPr>
+                        <a:t>○</a:t>
+                      </a:r>
+                      <a:endParaRPr lang="en-US" sz="1500" dirty="0">
+                        <a:latin typeface="Calibri" charset="0"/>
+                        <a:ea typeface="Calibri" charset="0"/>
+                        <a:cs typeface="Calibri" charset="0"/>
+                      </a:endParaRPr>
+                    </a:p>
+                  </a:txBody>
+                  <a:tcPr marL="76200" marR="76200" marT="25400" marB="25400" anchor="ctr">
+                    <a:lnL w="6350" cap="flat" cmpd="sng" algn="ctr">
+                      <a:solidFill>
+                        <a:srgbClr val="DCE2EA"/>
+                      </a:solidFill>
+                      <a:prstDash val="solid"/>
+                      <a:round/>
+                      <a:headEnd type="none" w="med" len="med"/>
+                      <a:tailEnd type="none" w="med" len="med"/>
+                    </a:lnL>
+                    <a:lnR w="6350" cap="flat" cmpd="sng" algn="ctr">
+                      <a:solidFill>
+                        <a:srgbClr val="DCE2EA"/>
+                      </a:solidFill>
+                      <a:prstDash val="solid"/>
+                      <a:round/>
+                      <a:headEnd type="none" w="med" len="med"/>
+                      <a:tailEnd type="none" w="med" len="med"/>
+                    </a:lnR>
+                    <a:lnT w="6350" cap="flat" cmpd="sng" algn="ctr">
+                      <a:solidFill>
+                        <a:srgbClr val="DCE2EA"/>
+                      </a:solidFill>
+                      <a:prstDash val="solid"/>
+                      <a:round/>
+                      <a:headEnd type="none" w="med" len="med"/>
+                      <a:tailEnd type="none" w="med" len="med"/>
+                    </a:lnT>
+                    <a:lnB w="6350" cap="flat" cmpd="sng" algn="ctr">
+                      <a:solidFill>
+                        <a:srgbClr val="DCE2EA"/>
+                      </a:solidFill>
+                      <a:prstDash val="solid"/>
+                      <a:round/>
+                      <a:headEnd type="none" w="med" len="med"/>
+                      <a:tailEnd type="none" w="med" len="med"/>
+                    </a:lnB>
+                    <a:solidFill>
+                      <a:srgbClr val="FFFFFF"/>
+                    </a:solidFill>
+                  </a:tcPr>
+                </a:tc>
+                <a:tc>
+                  <a:txBody>
+                    <a:bodyPr/>
+                    <a:lstStyle/>
+                    <a:p>
+                      <a:pPr algn="ctr" indent="0" marL="0">
+                        <a:buNone/>
+                      </a:pPr>
+                      <a:r>
+                        <a:rPr lang="en-US" sz="1500" b="1" dirty="0">
+                          <a:solidFill>
+                            <a:srgbClr val="1E7B34"/>
+                          </a:solidFill>
+                          <a:latin typeface="Calibri" pitchFamily="34" charset="0"/>
+                          <a:ea typeface="Calibri" pitchFamily="34" charset="-122"/>
+                          <a:cs typeface="Calibri" pitchFamily="34" charset="-120"/>
+                        </a:rPr>
+                        <a:t>●</a:t>
+                      </a:r>
+                      <a:endParaRPr lang="en-US" sz="1500" dirty="0">
+                        <a:latin typeface="Calibri" charset="0"/>
+                        <a:ea typeface="Calibri" charset="0"/>
+                        <a:cs typeface="Calibri" charset="0"/>
+                      </a:endParaRPr>
+                    </a:p>
+                  </a:txBody>
+                  <a:tcPr marL="76200" marR="76200" marT="25400" marB="25400" anchor="ctr">
+                    <a:lnL w="6350" cap="flat" cmpd="sng" algn="ctr">
+                      <a:solidFill>
+                        <a:srgbClr val="DCE2EA"/>
+                      </a:solidFill>
+                      <a:prstDash val="solid"/>
+                      <a:round/>
+                      <a:headEnd type="none" w="med" len="med"/>
+                      <a:tailEnd type="none" w="med" len="med"/>
+                    </a:lnL>
+                    <a:lnR w="6350" cap="flat" cmpd="sng" algn="ctr">
+                      <a:solidFill>
+                        <a:srgbClr val="DCE2EA"/>
+                      </a:solidFill>
+                      <a:prstDash val="solid"/>
+                      <a:round/>
+                      <a:headEnd type="none" w="med" len="med"/>
+                      <a:tailEnd type="none" w="med" len="med"/>
+                    </a:lnR>
+                    <a:lnT w="6350" cap="flat" cmpd="sng" algn="ctr">
+                      <a:solidFill>
+                        <a:srgbClr val="DCE2EA"/>
+                      </a:solidFill>
+                      <a:prstDash val="solid"/>
+                      <a:round/>
+                      <a:headEnd type="none" w="med" len="med"/>
+                      <a:tailEnd type="none" w="med" len="med"/>
+                    </a:lnT>
+                    <a:lnB w="6350" cap="flat" cmpd="sng" algn="ctr">
+                      <a:solidFill>
+                        <a:srgbClr val="DCE2EA"/>
+                      </a:solidFill>
+                      <a:prstDash val="solid"/>
+                      <a:round/>
+                      <a:headEnd type="none" w="med" len="med"/>
+                      <a:tailEnd type="none" w="med" len="med"/>
+                    </a:lnB>
+                    <a:solidFill>
+                      <a:srgbClr val="FFFFFF"/>
+                    </a:solidFill>
+                  </a:tcPr>
+                </a:tc>
+                <a:tc>
+                  <a:txBody>
+                    <a:bodyPr/>
+                    <a:lstStyle/>
+                    <a:p>
+                      <a:pPr algn="ctr" indent="0" marL="0">
+                        <a:buNone/>
+                      </a:pPr>
+                      <a:r>
+                        <a:rPr lang="en-US" sz="1500" b="1" dirty="0">
+                          <a:solidFill>
+                            <a:srgbClr val="B06000"/>
+                          </a:solidFill>
+                          <a:latin typeface="Calibri" pitchFamily="34" charset="0"/>
+                          <a:ea typeface="Calibri" pitchFamily="34" charset="-122"/>
+                          <a:cs typeface="Calibri" pitchFamily="34" charset="-120"/>
+                        </a:rPr>
+                        <a:t>◐</a:t>
+                      </a:r>
+                      <a:endParaRPr lang="en-US" sz="1500" dirty="0">
+                        <a:latin typeface="Calibri" charset="0"/>
+                        <a:ea typeface="Calibri" charset="0"/>
+                        <a:cs typeface="Calibri" charset="0"/>
+                      </a:endParaRPr>
+                    </a:p>
+                  </a:txBody>
+                  <a:tcPr marL="76200" marR="76200" marT="25400" marB="25400" anchor="ctr">
+                    <a:lnL w="6350" cap="flat" cmpd="sng" algn="ctr">
+                      <a:solidFill>
+                        <a:srgbClr val="DCE2EA"/>
+                      </a:solidFill>
+                      <a:prstDash val="solid"/>
+                      <a:round/>
+                      <a:headEnd type="none" w="med" len="med"/>
+                      <a:tailEnd type="none" w="med" len="med"/>
+                    </a:lnL>
+                    <a:lnR w="6350" cap="flat" cmpd="sng" algn="ctr">
+                      <a:solidFill>
+                        <a:srgbClr val="DCE2EA"/>
+                      </a:solidFill>
+                      <a:prstDash val="solid"/>
+                      <a:round/>
+                      <a:headEnd type="none" w="med" len="med"/>
+                      <a:tailEnd type="none" w="med" len="med"/>
+                    </a:lnR>
+                    <a:lnT w="6350" cap="flat" cmpd="sng" algn="ctr">
+                      <a:solidFill>
+                        <a:srgbClr val="DCE2EA"/>
+                      </a:solidFill>
+                      <a:prstDash val="solid"/>
+                      <a:round/>
+                      <a:headEnd type="none" w="med" len="med"/>
+                      <a:tailEnd type="none" w="med" len="med"/>
+                    </a:lnT>
+                    <a:lnB w="6350" cap="flat" cmpd="sng" algn="ctr">
+                      <a:solidFill>
+                        <a:srgbClr val="DCE2EA"/>
+                      </a:solidFill>
+                      <a:prstDash val="solid"/>
+                      <a:round/>
+                      <a:headEnd type="none" w="med" len="med"/>
+                      <a:tailEnd type="none" w="med" len="med"/>
+                    </a:lnB>
+                    <a:solidFill>
+                      <a:srgbClr val="FFFFFF"/>
+                    </a:solidFill>
+                  </a:tcPr>
+                </a:tc>
+              </a:tr>
+            </a:tbl>
+          </a:graphicData>
+        </a:graphic>
+      </p:graphicFrame>
+      <p:sp>
+        <p:nvSpPr>
+          <p:cNvPr id="5" name="Text 2"/>
+          <p:cNvSpPr/>
+          <p:nvPr/>
+        </p:nvSpPr>
+        <p:spPr>
+          <a:xfrm>
+            <a:off x="548640" y="5870448"/>
+            <a:ext cx="6400800" cy="274320"/>
+          </a:xfrm>
+          <a:prstGeom prst="rect">
+            <a:avLst/>
+          </a:prstGeom>
+          <a:noFill/>
+          <a:ln/>
+        </p:spPr>
+        <p:txBody>
+          <a:bodyPr wrap="square" lIns="0" tIns="0" rIns="0" bIns="0" rtlCol="0" anchor="ctr"/>
+          <a:lstStyle/>
+          <a:p>
+            <a:pPr indent="0" marL="0">
+              <a:buNone/>
+            </a:pPr>
+            <a:r>
+              <a:rPr lang="en-US" sz="1400" b="1" dirty="0">
+                <a:solidFill>
+                  <a:srgbClr val="1E7B34"/>
+                </a:solidFill>
+                <a:latin typeface="Calibri" pitchFamily="34" charset="0"/>
+                <a:ea typeface="Calibri" pitchFamily="34" charset="-122"/>
+                <a:cs typeface="Calibri" pitchFamily="34" charset="-120"/>
+              </a:rPr>
+              <a:t>●  </a:t>
+            </a:r>
+            <a:pPr indent="0" marL="0">
+              <a:buNone/>
+            </a:pPr>
+            <a:r>
+              <a:rPr lang="en-US" sz="1100" dirty="0">
+                <a:solidFill>
+                  <a:srgbClr val="5A6472"/>
+                </a:solidFill>
+                <a:latin typeface="Calibri" pitchFamily="34" charset="0"/>
+                <a:ea typeface="Calibri" pitchFamily="34" charset="-122"/>
+                <a:cs typeface="Calibri" pitchFamily="34" charset="-120"/>
+              </a:rPr>
+              <a:t>Full support     </a:t>
+            </a:r>
+            <a:pPr indent="0" marL="0">
+              <a:buNone/>
+            </a:pPr>
+            <a:r>
+              <a:rPr lang="en-US" sz="1400" b="1" dirty="0">
+                <a:solidFill>
+                  <a:srgbClr val="B06000"/>
+                </a:solidFill>
+                <a:latin typeface="Calibri" pitchFamily="34" charset="0"/>
+                <a:ea typeface="Calibri" pitchFamily="34" charset="-122"/>
+                <a:cs typeface="Calibri" pitchFamily="34" charset="-120"/>
+              </a:rPr>
+              <a:t>◐  </a:t>
+            </a:r>
+            <a:pPr indent="0" marL="0">
+              <a:buNone/>
+            </a:pPr>
+            <a:r>
+              <a:rPr lang="en-US" sz="1100" dirty="0">
+                <a:solidFill>
+                  <a:srgbClr val="5A6472"/>
+                </a:solidFill>
+                <a:latin typeface="Calibri" pitchFamily="34" charset="0"/>
+                <a:ea typeface="Calibri" pitchFamily="34" charset="-122"/>
+                <a:cs typeface="Calibri" pitchFamily="34" charset="-120"/>
+              </a:rPr>
+              <a:t>Partial     </a:t>
+            </a:r>
+            <a:pPr indent="0" marL="0">
+              <a:buNone/>
+            </a:pPr>
+            <a:r>
+              <a:rPr lang="en-US" sz="1400" b="1" dirty="0">
+                <a:solidFill>
+                  <a:srgbClr val="9AA3AE"/>
+                </a:solidFill>
+                <a:latin typeface="Calibri" pitchFamily="34" charset="0"/>
+                <a:ea typeface="Calibri" pitchFamily="34" charset="-122"/>
+                <a:cs typeface="Calibri" pitchFamily="34" charset="-120"/>
+              </a:rPr>
+              <a:t>○  </a:t>
+            </a:r>
+            <a:pPr indent="0" marL="0">
+              <a:buNone/>
+            </a:pPr>
+            <a:r>
+              <a:rPr lang="en-US" sz="1100" dirty="0">
+                <a:solidFill>
+                  <a:srgbClr val="5A6472"/>
+                </a:solidFill>
+                <a:latin typeface="Calibri" pitchFamily="34" charset="0"/>
+                <a:ea typeface="Calibri" pitchFamily="34" charset="-122"/>
+                <a:cs typeface="Calibri" pitchFamily="34" charset="-120"/>
+              </a:rPr>
+              <a:t>Not available</a:t>
+            </a:r>
+            <a:endParaRPr lang="en-US" sz="1400" dirty="0"/>
+          </a:p>
+        </p:txBody>
+      </p:sp>
+      <p:sp>
+        <p:nvSpPr>
+          <p:cNvPr id="6" name="Text 3"/>
+          <p:cNvSpPr/>
+          <p:nvPr/>
+        </p:nvSpPr>
+        <p:spPr>
+          <a:xfrm>
+            <a:off x="7589520" y="5870448"/>
+            <a:ext cx="4023360" cy="274320"/>
+          </a:xfrm>
+          <a:prstGeom prst="rect">
+            <a:avLst/>
+          </a:prstGeom>
+          <a:noFill/>
+          <a:ln/>
+        </p:spPr>
+        <p:txBody>
+          <a:bodyPr wrap="square" lIns="0" tIns="0" rIns="0" bIns="0" rtlCol="0" anchor="ctr"/>
+          <a:lstStyle/>
+          <a:p>
+            <a:pPr algn="r" indent="0" marL="0">
+              <a:buNone/>
+            </a:pPr>
+            <a:r>
+              <a:rPr lang="en-US" sz="1050" i="1" dirty="0">
+                <a:solidFill>
+                  <a:srgbClr val="5A6472"/>
+                </a:solidFill>
+                <a:latin typeface="Calibri" pitchFamily="34" charset="0"/>
+                <a:ea typeface="Calibri" pitchFamily="34" charset="-122"/>
+                <a:cs typeface="Calibri" pitchFamily="34" charset="-120"/>
+              </a:rPr>
+              <a:t>Full detail in Qplus Feature Matrix.docx</a:t>
+            </a:r>
+            <a:endParaRPr lang="en-US" sz="1050" dirty="0"/>
+          </a:p>
+        </p:txBody>
+      </p:sp>
+    </p:spTree>
+  </p:cSld>
+  <p:clrMapOvr>
+    <a:masterClrMapping/>
+  </p:clrMapOvr>
+</p:sld>
+</file>
+
+<file path=ppt/slides/slide17.xml><?xml version="1.0" encoding="utf-8"?>
+<p:sld xmlns:a="http://schemas.openxmlformats.org/drawingml/2006/main" xmlns:r="http://schemas.openxmlformats.org/officeDocument/2006/relationships" xmlns:p="http://schemas.openxmlformats.org/presentationml/2006/main">
+  <p:cSld name="Slide 17">
+    <p:bg>
+      <p:bgPr>
+        <a:solidFill>
+          <a:srgbClr val="FFFFFF"/>
+        </a:solidFill>
+      </p:bgPr>
+    </p:bg>
+    <p:spTree>
+      <p:nvGrpSpPr>
+        <p:cNvPr id="1" name=""/>
+        <p:cNvGrpSpPr/>
+        <p:nvPr/>
+      </p:nvGrpSpPr>
+      <p:grpSpPr>
+        <a:xfrm>
+          <a:off x="0" y="0"/>
+          <a:ext cx="0" cy="0"/>
+          <a:chOff x="0" y="0"/>
+          <a:chExt cx="0" cy="0"/>
+        </a:xfrm>
+      </p:grpSpPr>
+      <p:sp>
+        <p:nvSpPr>
+          <p:cNvPr id="2" name="Text 0"/>
+          <p:cNvSpPr/>
+          <p:nvPr/>
+        </p:nvSpPr>
+        <p:spPr>
+          <a:xfrm>
+            <a:off x="548640" y="411480"/>
+            <a:ext cx="7315200" cy="256032"/>
+          </a:xfrm>
+          <a:prstGeom prst="rect">
+            <a:avLst/>
+          </a:prstGeom>
+          <a:noFill/>
+          <a:ln/>
+        </p:spPr>
+        <p:txBody>
+          <a:bodyPr wrap="square" lIns="0" tIns="0" rIns="0" bIns="0" rtlCol="0" anchor="ctr"/>
+          <a:lstStyle/>
+          <a:p>
+            <a:pPr indent="0" marL="0">
+              <a:buNone/>
+            </a:pPr>
+            <a:r>
+              <a:rPr lang="en-US" sz="1100" b="1" spc="200" kern="0" dirty="0">
+                <a:solidFill>
+                  <a:srgbClr val="2D8CFF"/>
+                </a:solidFill>
+                <a:latin typeface="Calibri" pitchFamily="34" charset="0"/>
+                <a:ea typeface="Calibri" pitchFamily="34" charset="-122"/>
+                <a:cs typeface="Calibri" pitchFamily="34" charset="-120"/>
+              </a:rPr>
+              <a:t>FEATURE MATRIX</a:t>
+            </a:r>
+            <a:endParaRPr lang="en-US" sz="1100" dirty="0"/>
+          </a:p>
+        </p:txBody>
+      </p:sp>
+      <p:sp>
+        <p:nvSpPr>
+          <p:cNvPr id="3" name="Text 1"/>
+          <p:cNvSpPr/>
+          <p:nvPr/>
+        </p:nvSpPr>
+        <p:spPr>
+          <a:xfrm>
+            <a:off x="548640" y="713232"/>
+            <a:ext cx="11064240" cy="685800"/>
+          </a:xfrm>
+          <a:prstGeom prst="rect">
+            <a:avLst/>
+          </a:prstGeom>
+          <a:noFill/>
+          <a:ln/>
+        </p:spPr>
+        <p:txBody>
+          <a:bodyPr wrap="square" lIns="0" tIns="0" rIns="0" bIns="0" rtlCol="0" anchor="ctr"/>
+          <a:lstStyle/>
+          <a:p>
+            <a:pPr indent="0" marL="0">
+              <a:buNone/>
+            </a:pPr>
+            <a:r>
+              <a:rPr lang="en-US" sz="3400" b="1" dirty="0">
+                <a:solidFill>
+                  <a:srgbClr val="1B1D22"/>
+                </a:solidFill>
+                <a:latin typeface="Calibri" pitchFamily="34" charset="0"/>
+                <a:ea typeface="Calibri" pitchFamily="34" charset="-122"/>
+                <a:cs typeface="Calibri" pitchFamily="34" charset="-120"/>
+              </a:rPr>
+              <a:t>Use the right tool for the job</a:t>
+            </a:r>
+            <a:endParaRPr lang="en-US" sz="3400" dirty="0"/>
+          </a:p>
+        </p:txBody>
+      </p:sp>
+      <p:sp>
+        <p:nvSpPr>
+          <p:cNvPr id="4" name="Shape 2"/>
+          <p:cNvSpPr/>
+          <p:nvPr/>
+        </p:nvSpPr>
+        <p:spPr>
+          <a:xfrm>
+            <a:off x="548640" y="1691640"/>
+            <a:ext cx="3520440" cy="2697480"/>
+          </a:xfrm>
+          <a:prstGeom prst="roundRect">
+            <a:avLst>
+              <a:gd name="adj" fmla="val 2034"/>
+            </a:avLst>
+          </a:prstGeom>
+          <a:solidFill>
+            <a:srgbClr val="F4F6F8"/>
+          </a:solidFill>
+          <a:ln w="9525">
+            <a:solidFill>
+              <a:srgbClr val="DCE2EA"/>
+            </a:solidFill>
+            <a:prstDash val="solid"/>
+          </a:ln>
+        </p:spPr>
+      </p:sp>
+      <p:sp>
+        <p:nvSpPr>
+          <p:cNvPr id="5" name="Shape 3"/>
+          <p:cNvSpPr/>
+          <p:nvPr/>
+        </p:nvSpPr>
+        <p:spPr>
+          <a:xfrm>
+            <a:off x="749808" y="1892808"/>
+            <a:ext cx="155448" cy="155448"/>
+          </a:xfrm>
+          <a:prstGeom prst="roundRect">
+            <a:avLst>
+              <a:gd name="adj" fmla="val 23529"/>
+            </a:avLst>
+          </a:prstGeom>
+          <a:solidFill>
+            <a:srgbClr val="2D8CFF"/>
+          </a:solidFill>
+          <a:ln w="12700">
+            <a:solidFill>
+              <a:srgbClr val="2D8CFF"/>
+            </a:solidFill>
+            <a:prstDash val="solid"/>
+          </a:ln>
+        </p:spPr>
+      </p:sp>
+      <p:sp>
+        <p:nvSpPr>
+          <p:cNvPr id="6" name="Text 4"/>
+          <p:cNvSpPr/>
+          <p:nvPr/>
+        </p:nvSpPr>
+        <p:spPr>
+          <a:xfrm>
+            <a:off x="1005840" y="1819656"/>
+            <a:ext cx="2880360" cy="292608"/>
+          </a:xfrm>
+          <a:prstGeom prst="rect">
+            <a:avLst/>
+          </a:prstGeom>
+          <a:noFill/>
+          <a:ln/>
+        </p:spPr>
+        <p:txBody>
+          <a:bodyPr wrap="square" lIns="0" tIns="0" rIns="0" bIns="0" rtlCol="0" anchor="ctr"/>
+          <a:lstStyle/>
+          <a:p>
+            <a:pPr indent="0" marL="0">
+              <a:buNone/>
+            </a:pPr>
+            <a:r>
+              <a:rPr lang="en-US" sz="1400" b="1" dirty="0">
+                <a:solidFill>
+                  <a:srgbClr val="1B1D22"/>
+                </a:solidFill>
+                <a:latin typeface="Calibri" pitchFamily="34" charset="0"/>
+                <a:ea typeface="Calibri" pitchFamily="34" charset="-122"/>
+                <a:cs typeface="Calibri" pitchFamily="34" charset="-120"/>
+              </a:rPr>
+              <a:t>Reach for Qplus</a:t>
+            </a:r>
+            <a:endParaRPr lang="en-US" sz="1400" dirty="0"/>
+          </a:p>
+        </p:txBody>
+      </p:sp>
+      <p:sp>
+        <p:nvSpPr>
+          <p:cNvPr id="7" name="Text 5"/>
+          <p:cNvSpPr/>
+          <p:nvPr/>
+        </p:nvSpPr>
+        <p:spPr>
+          <a:xfrm>
+            <a:off x="804672" y="2157984"/>
+            <a:ext cx="3008376" cy="274320"/>
+          </a:xfrm>
+          <a:prstGeom prst="rect">
+            <a:avLst/>
+          </a:prstGeom>
+          <a:noFill/>
+          <a:ln/>
+        </p:spPr>
+        <p:txBody>
+          <a:bodyPr wrap="square" lIns="0" tIns="0" rIns="0" bIns="0" rtlCol="0" anchor="ctr"/>
+          <a:lstStyle/>
+          <a:p>
+            <a:pPr indent="0" marL="0">
+              <a:buNone/>
+            </a:pPr>
+            <a:r>
+              <a:rPr lang="en-US" sz="1100" i="1" dirty="0">
+                <a:solidFill>
+                  <a:srgbClr val="5A6472"/>
+                </a:solidFill>
+                <a:latin typeface="Calibri" pitchFamily="34" charset="0"/>
+                <a:ea typeface="Calibri" pitchFamily="34" charset="-122"/>
+                <a:cs typeface="Calibri" pitchFamily="34" charset="-120"/>
+              </a:rPr>
+              <a:t>The client you keep open all day</a:t>
+            </a:r>
+            <a:endParaRPr lang="en-US" sz="1100" dirty="0"/>
+          </a:p>
+        </p:txBody>
+      </p:sp>
+      <p:sp>
+        <p:nvSpPr>
+          <p:cNvPr id="8" name="Text 6"/>
+          <p:cNvSpPr/>
+          <p:nvPr/>
+        </p:nvSpPr>
+        <p:spPr>
+          <a:xfrm>
+            <a:off x="804672" y="2542032"/>
+            <a:ext cx="3008376" cy="1737360"/>
+          </a:xfrm>
+          <a:prstGeom prst="rect">
+            <a:avLst/>
+          </a:prstGeom>
+          <a:noFill/>
+          <a:ln/>
+        </p:spPr>
+        <p:txBody>
+          <a:bodyPr wrap="square" lIns="0" tIns="0" rIns="0" bIns="0" rtlCol="0" anchor="t"/>
+          <a:lstStyle/>
+          <a:p>
+            <a:pPr marL="342900" indent="-342900">
+              <a:spcAft>
+                <a:spcPts val="800"/>
+              </a:spcAft>
+              <a:buSzPct val="100000"/>
+              <a:buChar char="•"/>
+            </a:pPr>
+            <a:r>
+              <a:rPr lang="en-US" sz="1200" dirty="0">
+                <a:solidFill>
+                  <a:srgbClr val="5A6472"/>
+                </a:solidFill>
+                <a:latin typeface="Calibri" pitchFamily="34" charset="0"/>
+                <a:ea typeface="Calibri" pitchFamily="34" charset="-122"/>
+                <a:cs typeface="Calibri" pitchFamily="34" charset="-120"/>
+              </a:rPr>
+              <a:t>You work across both engines</a:t>
+            </a:r>
+            <a:endParaRPr lang="en-US" sz="1200" dirty="0"/>
+          </a:p>
+          <a:p>
+            <a:pPr marL="342900" indent="-342900">
+              <a:spcAft>
+                <a:spcPts val="800"/>
+              </a:spcAft>
+              <a:buSzPct val="100000"/>
+              <a:buChar char="•"/>
+            </a:pPr>
+            <a:r>
+              <a:rPr lang="en-US" sz="1200" dirty="0">
+                <a:solidFill>
+                  <a:srgbClr val="5A6472"/>
+                </a:solidFill>
+                <a:latin typeface="Calibri" pitchFamily="34" charset="0"/>
+                <a:ea typeface="Calibri" pitchFamily="34" charset="-122"/>
+                <a:cs typeface="Calibri" pitchFamily="34" charset="-120"/>
+              </a:rPr>
+              <a:t>The team shares sensitive SQL</a:t>
+            </a:r>
+            <a:endParaRPr lang="en-US" sz="1200" dirty="0"/>
+          </a:p>
+          <a:p>
+            <a:pPr marL="342900" indent="-342900">
+              <a:spcAft>
+                <a:spcPts val="800"/>
+              </a:spcAft>
+              <a:buSzPct val="100000"/>
+              <a:buChar char="•"/>
+            </a:pPr>
+            <a:r>
+              <a:rPr lang="en-US" sz="1200" dirty="0">
+                <a:solidFill>
+                  <a:srgbClr val="5A6472"/>
+                </a:solidFill>
+                <a:latin typeface="Calibri" pitchFamily="34" charset="0"/>
+                <a:ea typeface="Calibri" pitchFamily="34" charset="-122"/>
+                <a:cs typeface="Calibri" pitchFamily="34" charset="-120"/>
+              </a:rPr>
+              <a:t>You cannot install software</a:t>
+            </a:r>
+            <a:endParaRPr lang="en-US" sz="1200" dirty="0"/>
+          </a:p>
+          <a:p>
+            <a:pPr marL="342900" indent="-342900">
+              <a:spcAft>
+                <a:spcPts val="800"/>
+              </a:spcAft>
+              <a:buSzPct val="100000"/>
+              <a:buChar char="•"/>
+            </a:pPr>
+            <a:r>
+              <a:rPr lang="en-US" sz="1200" dirty="0">
+                <a:solidFill>
+                  <a:srgbClr val="5A6472"/>
+                </a:solidFill>
+                <a:latin typeface="Calibri" pitchFamily="34" charset="0"/>
+                <a:ea typeface="Calibri" pitchFamily="34" charset="-122"/>
+                <a:cs typeface="Calibri" pitchFamily="34" charset="-120"/>
+              </a:rPr>
+              <a:t>You want it light and portable</a:t>
+            </a:r>
+            <a:endParaRPr lang="en-US" sz="1200" dirty="0"/>
+          </a:p>
+        </p:txBody>
+      </p:sp>
+      <p:sp>
+        <p:nvSpPr>
+          <p:cNvPr id="9" name="Shape 7"/>
+          <p:cNvSpPr/>
+          <p:nvPr/>
+        </p:nvSpPr>
+        <p:spPr>
+          <a:xfrm>
+            <a:off x="4270248" y="1691640"/>
+            <a:ext cx="3520440" cy="2697480"/>
+          </a:xfrm>
+          <a:prstGeom prst="roundRect">
+            <a:avLst>
+              <a:gd name="adj" fmla="val 2034"/>
+            </a:avLst>
+          </a:prstGeom>
+          <a:solidFill>
+            <a:srgbClr val="F4F6F8"/>
+          </a:solidFill>
+          <a:ln w="9525">
+            <a:solidFill>
+              <a:srgbClr val="DCE2EA"/>
+            </a:solidFill>
+            <a:prstDash val="solid"/>
+          </a:ln>
+        </p:spPr>
+      </p:sp>
+      <p:sp>
+        <p:nvSpPr>
+          <p:cNvPr id="10" name="Shape 8"/>
+          <p:cNvSpPr/>
+          <p:nvPr/>
+        </p:nvSpPr>
+        <p:spPr>
+          <a:xfrm>
+            <a:off x="4471416" y="1892808"/>
+            <a:ext cx="155448" cy="155448"/>
+          </a:xfrm>
+          <a:prstGeom prst="roundRect">
+            <a:avLst>
+              <a:gd name="adj" fmla="val 23529"/>
+            </a:avLst>
+          </a:prstGeom>
+          <a:solidFill>
+            <a:srgbClr val="4FD6E6"/>
+          </a:solidFill>
+          <a:ln w="12700">
+            <a:solidFill>
+              <a:srgbClr val="4FD6E6"/>
+            </a:solidFill>
+            <a:prstDash val="solid"/>
+          </a:ln>
+        </p:spPr>
+      </p:sp>
+      <p:sp>
+        <p:nvSpPr>
+          <p:cNvPr id="11" name="Text 9"/>
+          <p:cNvSpPr/>
+          <p:nvPr/>
+        </p:nvSpPr>
+        <p:spPr>
+          <a:xfrm>
+            <a:off x="4727448" y="1819656"/>
+            <a:ext cx="2880360" cy="292608"/>
+          </a:xfrm>
+          <a:prstGeom prst="rect">
+            <a:avLst/>
+          </a:prstGeom>
+          <a:noFill/>
+          <a:ln/>
+        </p:spPr>
+        <p:txBody>
+          <a:bodyPr wrap="square" lIns="0" tIns="0" rIns="0" bIns="0" rtlCol="0" anchor="ctr"/>
+          <a:lstStyle/>
+          <a:p>
+            <a:pPr indent="0" marL="0">
+              <a:buNone/>
+            </a:pPr>
+            <a:r>
+              <a:rPr lang="en-US" sz="1400" b="1" dirty="0">
+                <a:solidFill>
+                  <a:srgbClr val="1B1D22"/>
+                </a:solidFill>
+                <a:latin typeface="Calibri" pitchFamily="34" charset="0"/>
+                <a:ea typeface="Calibri" pitchFamily="34" charset="-122"/>
+                <a:cs typeface="Calibri" pitchFamily="34" charset="-120"/>
+              </a:rPr>
+              <a:t>Reach for SSMS</a:t>
+            </a:r>
+            <a:endParaRPr lang="en-US" sz="1400" dirty="0"/>
+          </a:p>
+        </p:txBody>
+      </p:sp>
+      <p:sp>
+        <p:nvSpPr>
+          <p:cNvPr id="12" name="Text 10"/>
+          <p:cNvSpPr/>
+          <p:nvPr/>
+        </p:nvSpPr>
+        <p:spPr>
+          <a:xfrm>
+            <a:off x="4526280" y="2157984"/>
+            <a:ext cx="3008376" cy="274320"/>
+          </a:xfrm>
+          <a:prstGeom prst="rect">
+            <a:avLst/>
+          </a:prstGeom>
+          <a:noFill/>
+          <a:ln/>
+        </p:spPr>
+        <p:txBody>
+          <a:bodyPr wrap="square" lIns="0" tIns="0" rIns="0" bIns="0" rtlCol="0" anchor="ctr"/>
+          <a:lstStyle/>
+          <a:p>
+            <a:pPr indent="0" marL="0">
+              <a:buNone/>
+            </a:pPr>
+            <a:r>
+              <a:rPr lang="en-US" sz="1100" i="1" dirty="0">
+                <a:solidFill>
+                  <a:srgbClr val="5A6472"/>
+                </a:solidFill>
+                <a:latin typeface="Calibri" pitchFamily="34" charset="0"/>
+                <a:ea typeface="Calibri" pitchFamily="34" charset="-122"/>
+                <a:cs typeface="Calibri" pitchFamily="34" charset="-120"/>
+              </a:rPr>
+              <a:t>The SQL Server administrator’s console</a:t>
+            </a:r>
+            <a:endParaRPr lang="en-US" sz="1100" dirty="0"/>
+          </a:p>
+        </p:txBody>
+      </p:sp>
+      <p:sp>
+        <p:nvSpPr>
+          <p:cNvPr id="13" name="Text 11"/>
+          <p:cNvSpPr/>
+          <p:nvPr/>
+        </p:nvSpPr>
+        <p:spPr>
+          <a:xfrm>
+            <a:off x="4526280" y="2542032"/>
+            <a:ext cx="3008376" cy="1737360"/>
+          </a:xfrm>
+          <a:prstGeom prst="rect">
+            <a:avLst/>
+          </a:prstGeom>
+          <a:noFill/>
+          <a:ln/>
+        </p:spPr>
+        <p:txBody>
+          <a:bodyPr wrap="square" lIns="0" tIns="0" rIns="0" bIns="0" rtlCol="0" anchor="t"/>
+          <a:lstStyle/>
+          <a:p>
+            <a:pPr marL="342900" indent="-342900">
+              <a:spcAft>
+                <a:spcPts val="800"/>
+              </a:spcAft>
+              <a:buSzPct val="100000"/>
+              <a:buChar char="•"/>
+            </a:pPr>
+            <a:r>
+              <a:rPr lang="en-US" sz="1200" dirty="0">
+                <a:solidFill>
+                  <a:srgbClr val="5A6472"/>
+                </a:solidFill>
+                <a:latin typeface="Calibri" pitchFamily="34" charset="0"/>
+                <a:ea typeface="Calibri" pitchFamily="34" charset="-122"/>
+                <a:cs typeface="Calibri" pitchFamily="34" charset="-120"/>
+              </a:rPr>
+              <a:t>You need an execution plan</a:t>
+            </a:r>
+            <a:endParaRPr lang="en-US" sz="1200" dirty="0"/>
+          </a:p>
+          <a:p>
+            <a:pPr marL="342900" indent="-342900">
+              <a:spcAft>
+                <a:spcPts val="800"/>
+              </a:spcAft>
+              <a:buSzPct val="100000"/>
+              <a:buChar char="•"/>
+            </a:pPr>
+            <a:r>
+              <a:rPr lang="en-US" sz="1200" dirty="0">
+                <a:solidFill>
+                  <a:srgbClr val="5A6472"/>
+                </a:solidFill>
+                <a:latin typeface="Calibri" pitchFamily="34" charset="0"/>
+                <a:ea typeface="Calibri" pitchFamily="34" charset="-122"/>
+                <a:cs typeface="Calibri" pitchFamily="34" charset="-120"/>
+              </a:rPr>
+              <a:t>Backups, Agent jobs, Always On</a:t>
+            </a:r>
+            <a:endParaRPr lang="en-US" sz="1200" dirty="0"/>
+          </a:p>
+          <a:p>
+            <a:pPr marL="342900" indent="-342900">
+              <a:spcAft>
+                <a:spcPts val="800"/>
+              </a:spcAft>
+              <a:buSzPct val="100000"/>
+              <a:buChar char="•"/>
+            </a:pPr>
+            <a:r>
+              <a:rPr lang="en-US" sz="1200" dirty="0">
+                <a:solidFill>
+                  <a:srgbClr val="5A6472"/>
+                </a:solidFill>
+                <a:latin typeface="Calibri" pitchFamily="34" charset="0"/>
+                <a:ea typeface="Calibri" pitchFamily="34" charset="-122"/>
+                <a:cs typeface="Calibri" pitchFamily="34" charset="-120"/>
+              </a:rPr>
+              <a:t>Activity Monitor or Query Store</a:t>
+            </a:r>
+            <a:endParaRPr lang="en-US" sz="1200" dirty="0"/>
+          </a:p>
+          <a:p>
+            <a:pPr marL="342900" indent="-342900">
+              <a:spcAft>
+                <a:spcPts val="800"/>
+              </a:spcAft>
+              <a:buSzPct val="100000"/>
+              <a:buChar char="•"/>
+            </a:pPr>
+            <a:r>
+              <a:rPr lang="en-US" sz="1200" dirty="0">
+                <a:solidFill>
+                  <a:srgbClr val="5A6472"/>
+                </a:solidFill>
+                <a:latin typeface="Calibri" pitchFamily="34" charset="0"/>
+                <a:ea typeface="Calibri" pitchFamily="34" charset="-122"/>
+                <a:cs typeface="Calibri" pitchFamily="34" charset="-120"/>
+              </a:rPr>
+              <a:t>SSIS, SSAS or SSRS work</a:t>
+            </a:r>
+            <a:endParaRPr lang="en-US" sz="1200" dirty="0"/>
+          </a:p>
+        </p:txBody>
+      </p:sp>
+      <p:sp>
+        <p:nvSpPr>
+          <p:cNvPr id="14" name="Shape 12"/>
+          <p:cNvSpPr/>
+          <p:nvPr/>
+        </p:nvSpPr>
+        <p:spPr>
+          <a:xfrm>
+            <a:off x="7991856" y="1691640"/>
+            <a:ext cx="3520440" cy="2697480"/>
+          </a:xfrm>
+          <a:prstGeom prst="roundRect">
+            <a:avLst>
+              <a:gd name="adj" fmla="val 2034"/>
+            </a:avLst>
+          </a:prstGeom>
+          <a:solidFill>
+            <a:srgbClr val="F4F6F8"/>
+          </a:solidFill>
+          <a:ln w="9525">
+            <a:solidFill>
+              <a:srgbClr val="DCE2EA"/>
+            </a:solidFill>
+            <a:prstDash val="solid"/>
+          </a:ln>
+        </p:spPr>
+      </p:sp>
+      <p:sp>
+        <p:nvSpPr>
+          <p:cNvPr id="15" name="Shape 13"/>
+          <p:cNvSpPr/>
+          <p:nvPr/>
+        </p:nvSpPr>
+        <p:spPr>
+          <a:xfrm>
+            <a:off x="8193024" y="1892808"/>
+            <a:ext cx="155448" cy="155448"/>
+          </a:xfrm>
+          <a:prstGeom prst="roundRect">
+            <a:avLst>
+              <a:gd name="adj" fmla="val 23529"/>
+            </a:avLst>
+          </a:prstGeom>
+          <a:solidFill>
+            <a:srgbClr val="4FD6E6"/>
+          </a:solidFill>
+          <a:ln w="12700">
+            <a:solidFill>
+              <a:srgbClr val="4FD6E6"/>
+            </a:solidFill>
+            <a:prstDash val="solid"/>
+          </a:ln>
+        </p:spPr>
+      </p:sp>
+      <p:sp>
+        <p:nvSpPr>
+          <p:cNvPr id="16" name="Text 14"/>
+          <p:cNvSpPr/>
+          <p:nvPr/>
+        </p:nvSpPr>
+        <p:spPr>
+          <a:xfrm>
+            <a:off x="8449056" y="1819656"/>
+            <a:ext cx="2880360" cy="292608"/>
+          </a:xfrm>
+          <a:prstGeom prst="rect">
+            <a:avLst/>
+          </a:prstGeom>
+          <a:noFill/>
+          <a:ln/>
+        </p:spPr>
+        <p:txBody>
+          <a:bodyPr wrap="square" lIns="0" tIns="0" rIns="0" bIns="0" rtlCol="0" anchor="ctr"/>
+          <a:lstStyle/>
+          <a:p>
+            <a:pPr indent="0" marL="0">
+              <a:buNone/>
+            </a:pPr>
+            <a:r>
+              <a:rPr lang="en-US" sz="1400" b="1" dirty="0">
+                <a:solidFill>
+                  <a:srgbClr val="1B1D22"/>
+                </a:solidFill>
+                <a:latin typeface="Calibri" pitchFamily="34" charset="0"/>
+                <a:ea typeface="Calibri" pitchFamily="34" charset="-122"/>
+                <a:cs typeface="Calibri" pitchFamily="34" charset="-120"/>
+              </a:rPr>
+              <a:t>Reach for SQL Developer</a:t>
+            </a:r>
+            <a:endParaRPr lang="en-US" sz="1400" dirty="0"/>
+          </a:p>
+        </p:txBody>
+      </p:sp>
+      <p:sp>
+        <p:nvSpPr>
+          <p:cNvPr id="17" name="Text 15"/>
+          <p:cNvSpPr/>
+          <p:nvPr/>
+        </p:nvSpPr>
+        <p:spPr>
+          <a:xfrm>
+            <a:off x="8247888" y="2157984"/>
+            <a:ext cx="3008376" cy="274320"/>
+          </a:xfrm>
+          <a:prstGeom prst="rect">
+            <a:avLst/>
+          </a:prstGeom>
+          <a:noFill/>
+          <a:ln/>
+        </p:spPr>
+        <p:txBody>
+          <a:bodyPr wrap="square" lIns="0" tIns="0" rIns="0" bIns="0" rtlCol="0" anchor="ctr"/>
+          <a:lstStyle/>
+          <a:p>
+            <a:pPr indent="0" marL="0">
+              <a:buNone/>
+            </a:pPr>
+            <a:r>
+              <a:rPr lang="en-US" sz="1100" i="1" dirty="0">
+                <a:solidFill>
+                  <a:srgbClr val="5A6472"/>
+                </a:solidFill>
+                <a:latin typeface="Calibri" pitchFamily="34" charset="0"/>
+                <a:ea typeface="Calibri" pitchFamily="34" charset="-122"/>
+                <a:cs typeface="Calibri" pitchFamily="34" charset="-120"/>
+              </a:rPr>
+              <a:t>The Oracle specialist’s toolkit</a:t>
+            </a:r>
+            <a:endParaRPr lang="en-US" sz="1100" dirty="0"/>
+          </a:p>
+        </p:txBody>
+      </p:sp>
+      <p:sp>
+        <p:nvSpPr>
+          <p:cNvPr id="18" name="Text 16"/>
+          <p:cNvSpPr/>
+          <p:nvPr/>
+        </p:nvSpPr>
+        <p:spPr>
+          <a:xfrm>
+            <a:off x="8247888" y="2542032"/>
+            <a:ext cx="3008376" cy="1737360"/>
+          </a:xfrm>
+          <a:prstGeom prst="rect">
+            <a:avLst/>
+          </a:prstGeom>
+          <a:noFill/>
+          <a:ln/>
+        </p:spPr>
+        <p:txBody>
+          <a:bodyPr wrap="square" lIns="0" tIns="0" rIns="0" bIns="0" rtlCol="0" anchor="t"/>
+          <a:lstStyle/>
+          <a:p>
+            <a:pPr marL="342900" indent="-342900">
+              <a:spcAft>
+                <a:spcPts val="800"/>
+              </a:spcAft>
+              <a:buSzPct val="100000"/>
+              <a:buChar char="•"/>
+            </a:pPr>
+            <a:r>
+              <a:rPr lang="en-US" sz="1200" dirty="0">
+                <a:solidFill>
+                  <a:srgbClr val="5A6472"/>
+                </a:solidFill>
+                <a:latin typeface="Calibri" pitchFamily="34" charset="0"/>
+                <a:ea typeface="Calibri" pitchFamily="34" charset="-122"/>
+                <a:cs typeface="Calibri" pitchFamily="34" charset="-120"/>
+              </a:rPr>
+              <a:t>Debugging or profiling PL/SQL</a:t>
+            </a:r>
+            <a:endParaRPr lang="en-US" sz="1200" dirty="0"/>
+          </a:p>
+          <a:p>
+            <a:pPr marL="342900" indent="-342900">
+              <a:spcAft>
+                <a:spcPts val="800"/>
+              </a:spcAft>
+              <a:buSzPct val="100000"/>
+              <a:buChar char="•"/>
+            </a:pPr>
+            <a:r>
+              <a:rPr lang="en-US" sz="1200" dirty="0">
+                <a:solidFill>
+                  <a:srgbClr val="5A6472"/>
+                </a:solidFill>
+                <a:latin typeface="Calibri" pitchFamily="34" charset="0"/>
+                <a:ea typeface="Calibri" pitchFamily="34" charset="-122"/>
+                <a:cs typeface="Calibri" pitchFamily="34" charset="-120"/>
+              </a:rPr>
+              <a:t>Data Modeler or schema diff</a:t>
+            </a:r>
+            <a:endParaRPr lang="en-US" sz="1200" dirty="0"/>
+          </a:p>
+          <a:p>
+            <a:pPr marL="342900" indent="-342900">
+              <a:spcAft>
+                <a:spcPts val="800"/>
+              </a:spcAft>
+              <a:buSzPct val="100000"/>
+              <a:buChar char="•"/>
+            </a:pPr>
+            <a:r>
+              <a:rPr lang="en-US" sz="1200" dirty="0">
+                <a:solidFill>
+                  <a:srgbClr val="5A6472"/>
+                </a:solidFill>
+                <a:latin typeface="Calibri" pitchFamily="34" charset="0"/>
+                <a:ea typeface="Calibri" pitchFamily="34" charset="-122"/>
+                <a:cs typeface="Calibri" pitchFamily="34" charset="-120"/>
+              </a:rPr>
+              <a:t>Exports beyond CSV</a:t>
+            </a:r>
+            <a:endParaRPr lang="en-US" sz="1200" dirty="0"/>
+          </a:p>
+          <a:p>
+            <a:pPr marL="342900" indent="-342900">
+              <a:spcAft>
+                <a:spcPts val="800"/>
+              </a:spcAft>
+              <a:buSzPct val="100000"/>
+              <a:buChar char="•"/>
+            </a:pPr>
+            <a:r>
+              <a:rPr lang="en-US" sz="1200" dirty="0">
+                <a:solidFill>
+                  <a:srgbClr val="5A6472"/>
+                </a:solidFill>
+                <a:latin typeface="Calibri" pitchFamily="34" charset="0"/>
+                <a:ea typeface="Calibri" pitchFamily="34" charset="-122"/>
+                <a:cs typeface="Calibri" pitchFamily="34" charset="-120"/>
+              </a:rPr>
+              <a:t>You are not on Windows</a:t>
+            </a:r>
+            <a:endParaRPr lang="en-US" sz="1200" dirty="0"/>
+          </a:p>
+        </p:txBody>
+      </p:sp>
+      <p:sp>
+        <p:nvSpPr>
+          <p:cNvPr id="19" name="Shape 17"/>
+          <p:cNvSpPr/>
+          <p:nvPr/>
+        </p:nvSpPr>
+        <p:spPr>
+          <a:xfrm>
+            <a:off x="548640" y="4709160"/>
+            <a:ext cx="11064240" cy="960120"/>
+          </a:xfrm>
+          <a:prstGeom prst="roundRect">
+            <a:avLst>
+              <a:gd name="adj" fmla="val 5714"/>
+            </a:avLst>
+          </a:prstGeom>
+          <a:solidFill>
+            <a:srgbClr val="1B1D22"/>
+          </a:solidFill>
+          <a:ln w="12700">
+            <a:solidFill>
+              <a:srgbClr val="1B1D22"/>
+            </a:solidFill>
+            <a:prstDash val="solid"/>
+          </a:ln>
+        </p:spPr>
+      </p:sp>
+      <p:sp>
+        <p:nvSpPr>
+          <p:cNvPr id="20" name="Text 18"/>
+          <p:cNvSpPr/>
+          <p:nvPr/>
+        </p:nvSpPr>
+        <p:spPr>
+          <a:xfrm>
+            <a:off x="914400" y="4709160"/>
+            <a:ext cx="10332720" cy="960120"/>
+          </a:xfrm>
+          <a:prstGeom prst="rect">
+            <a:avLst/>
+          </a:prstGeom>
+          <a:noFill/>
+          <a:ln/>
+        </p:spPr>
+        <p:txBody>
+          <a:bodyPr wrap="square" lIns="0" tIns="0" rIns="0" bIns="0" rtlCol="0" anchor="ctr"/>
+          <a:lstStyle/>
+          <a:p>
+            <a:pPr indent="0" marL="0">
+              <a:buNone/>
+            </a:pPr>
+            <a:r>
+              <a:rPr lang="en-US" sz="1350" dirty="0">
+                <a:solidFill>
+                  <a:srgbClr val="D6DCE4"/>
+                </a:solidFill>
+                <a:latin typeface="Calibri" pitchFamily="34" charset="0"/>
+                <a:ea typeface="Calibri" pitchFamily="34" charset="-122"/>
+                <a:cs typeface="Calibri" pitchFamily="34" charset="-120"/>
+              </a:rPr>
+              <a:t>Qplus covers the daily work across both engines in one portable file. It does not replace the deep, engine-specific tooling — it sits alongside it.</a:t>
+            </a:r>
+            <a:endParaRPr lang="en-US" sz="1350" dirty="0"/>
+          </a:p>
+        </p:txBody>
+      </p:sp>
+    </p:spTree>
+  </p:cSld>
+  <p:clrMapOvr>
+    <a:masterClrMapping/>
+  </p:clrMapOvr>
+</p:sld>
+</file>
+
+<file path=ppt/slides/slide18.xml><?xml version="1.0" encoding="utf-8"?>
+<p:sld xmlns:a="http://schemas.openxmlformats.org/drawingml/2006/main" xmlns:r="http://schemas.openxmlformats.org/officeDocument/2006/relationships" xmlns:p="http://schemas.openxmlformats.org/presentationml/2006/main">
+  <p:cSld name="Slide 18">
+    <p:bg>
+      <p:bgPr>
+        <a:solidFill>
           <a:srgbClr val="1B1D22"/>
         </a:solidFill>
       </p:bgPr>
@@ -6417,7 +11063,7 @@
                 <a:ea typeface="Calibri" pitchFamily="34" charset="-122"/>
                 <a:cs typeface="Calibri" pitchFamily="34" charset="-120"/>
               </a:rPr>
-              <a:t>Qplus User Guide  ·  Qplus Technical Documentation</a:t>
+              <a:t>Qplus User Guide  ·  Qplus Technical Documentation  ·  Qplus Feature Matrix</a:t>
             </a:r>
             <a:endParaRPr lang="en-US" sz="1300" dirty="0"/>
           </a:p>

</xml_diff>